<commit_message>
Rewrite estado del arte with real user interviews
Replaces AI-sourced review summaries with direct conversations with
students/young people (same profile as the target market): Notas
(not WhatsApp) is the dominant informal solution, Bring! wins on
real-time collaboration but adds friction per item, and AnyList
nearly matches Notas' speed via smart recognition + barcode scanning
but is entirely cooking/recipe-oriented. Reframes the core gap as
positioning (nobody targets saving/stock-tracking), not just
usability. Regenerates larder-presentacion.pptx slides 3-4 to match.

Co-Authored-By: Claude Sonnet 5 <noreply@anthropic.com>
Claude-Session: https://claude.ai/code/session_012BwrUiCYr6ApYk5hmXyh4o
</commit_message>
<xml_diff>
--- a/docs/larder-presentacion.pptx
+++ b/docs/larder-presentacion.pptx
@@ -686,7 +686,7 @@
           <a:p>
             <a:r>
               <a:rPr lang="en-US" dirty="0"/>
-              <a:t>La fila de Out of Milk se genero con IA (nivel IA-2) y no se pudo verificar como app real. Se documenta la retractacion en vez de ocultarla: es exactamente lo que pide el guion sobre no dar por cierto un dato de IA sin comprobar.</a:t>
+              <a:t>La fuente principal ya no es busqueda por IA sino conversaciones reales con estudiantes/gente joven que comparten piso (mismo perfil que el mercado objetivo). AnyList tiene reconocimiento inteligente al escribir y codigo de barras -casi tan rapido como Notas-, pero todo su valor extra apunta a cocinar. La fila de Out of Milk se genero con IA (IA-2) y no se pudo verificar como app real: se documenta la retractacion en vez de ocultarla.</a:t>
             </a:r>
             <a:endParaRPr lang="en-US" dirty="0"/>
           </a:p>
@@ -774,7 +774,7 @@
           <a:p>
             <a:r>
               <a:rPr lang="en-US" dirty="0"/>
-              <a:t>Conclusion del estado del arte: el hueco es de usabilidad y de combinar nevera+lista, no de estetica.</a:t>
+              <a:t>Conclusion del estado del arte: el hueco no es "mas bonita", es rapidez de Notas + colaboracion de Bring + foco en ahorro/stock, que ninguna cubre. Tambien vale mencionar el testimonio propio: en casa se abandono una app similar tras 2 usos por pereza de abrir "otra app".</a:t>
             </a:r>
             <a:endParaRPr lang="en-US" dirty="0"/>
           </a:p>
@@ -2502,6 +2502,45 @@
           </a:p>
         </p:txBody>
       </p:sp>
+      <p:sp>
+        <p:nvSpPr>
+          <p:cNvPr id="6" name="Text 3"/>
+          <p:cNvSpPr txBox="1"/>
+          <p:nvPr/>
+        </p:nvSpPr>
+        <p:spPr>
+          <a:xfrm>
+            <a:off x="548640" y="1234440"/>
+            <a:ext cx="11094415" cy="274320"/>
+          </a:xfrm>
+          <a:prstGeom prst="rect">
+            <a:avLst/>
+          </a:prstGeom>
+          <a:noFill/>
+          <a:ln/>
+        </p:spPr>
+        <p:txBody>
+          <a:bodyPr wrap="square" lIns="0" tIns="0" rIns="0" bIns="0" rtlCol="0" anchor="ctr"/>
+          <a:lstStyle/>
+          <a:p>
+            <a:pPr indent="0" marL="0">
+              <a:buNone/>
+            </a:pPr>
+            <a:r>
+              <a:rPr lang="en-US" sz="1000" i="1" dirty="0">
+                <a:solidFill>
+                  <a:srgbClr val="8A7A6D"/>
+                </a:solidFill>
+                <a:latin typeface="Calibri" pitchFamily="34" charset="0"/>
+                <a:ea typeface="Calibri" pitchFamily="34" charset="-122"/>
+                <a:cs typeface="Calibri" pitchFamily="34" charset="-120"/>
+              </a:rPr>
+              <a:t>Fuente principal: conversaciones directas con estudiantes/gente joven — el mismo perfil que el mercado objetivo.</a:t>
+            </a:r>
+            <a:endParaRPr lang="en-US" sz="1000" dirty="0"/>
+          </a:p>
+        </p:txBody>
+      </p:sp>
       <p:graphicFrame>
         <p:nvGraphicFramePr>
           <p:cNvPr id="4" name="Table 0"/>
@@ -2517,19 +2556,19 @@
           </p:nvPr>
         </p:nvGraphicFramePr>
         <p:xfrm>
-          <a:off x="548640" y="1417320"/>
-          <a:ext cx="11064240" cy="2194560"/>
+          <a:off x="548640" y="1508760"/>
+          <a:ext cx="11064240" cy="2286000"/>
         </p:xfrm>
         <a:graphic>
           <a:graphicData uri="http://schemas.openxmlformats.org/drawingml/2006/table">
             <a:tbl>
               <a:tblPr/>
               <a:tblGrid>
-                <a:gridCol w="2377440"/>
-                <a:gridCol w="4297680"/>
-                <a:gridCol w="4389120"/>
+                <a:gridCol w="1737360"/>
+                <a:gridCol w="4480560"/>
+                <a:gridCol w="4846320"/>
               </a:tblGrid>
-              <a:tr h="438912">
+              <a:tr h="457200">
                 <a:tc>
                   <a:txBody>
                     <a:bodyPr/>
@@ -2539,7 +2578,7 @@
                         <a:buNone/>
                       </a:pPr>
                       <a:r>
-                        <a:rPr lang="en-US" sz="1250" b="1" dirty="0">
+                        <a:rPr lang="en-US" sz="1200" b="1" dirty="0">
                           <a:solidFill>
                             <a:srgbClr val="FFFFFF"/>
                           </a:solidFill>
@@ -2549,7 +2588,7 @@
                         </a:rPr>
                         <a:t>Solución</a:t>
                       </a:r>
-                      <a:endParaRPr lang="en-US" sz="1250" dirty="0">
+                      <a:endParaRPr lang="en-US" sz="1200" dirty="0">
                         <a:latin typeface="Calibri" charset="0"/>
                         <a:ea typeface="Calibri" charset="0"/>
                         <a:cs typeface="Calibri" charset="0"/>
@@ -2607,7 +2646,7 @@
                         <a:buNone/>
                       </a:pPr>
                       <a:r>
-                        <a:rPr lang="en-US" sz="1250" b="1" dirty="0">
+                        <a:rPr lang="en-US" sz="1200" b="1" dirty="0">
                           <a:solidFill>
                             <a:srgbClr val="FFFFFF"/>
                           </a:solidFill>
@@ -2615,9 +2654,9 @@
                           <a:ea typeface="Calibri" pitchFamily="34" charset="-122"/>
                           <a:cs typeface="Calibri" pitchFamily="34" charset="-120"/>
                         </a:rPr>
-                        <a:t>Qué resuelve bien</a:t>
+                        <a:t>Lo bueno</a:t>
                       </a:r>
-                      <a:endParaRPr lang="en-US" sz="1250" dirty="0">
+                      <a:endParaRPr lang="en-US" sz="1200" dirty="0">
                         <a:latin typeface="Calibri" charset="0"/>
                         <a:ea typeface="Calibri" charset="0"/>
                         <a:cs typeface="Calibri" charset="0"/>
@@ -2675,7 +2714,7 @@
                         <a:buNone/>
                       </a:pPr>
                       <a:r>
-                        <a:rPr lang="en-US" sz="1250" b="1" dirty="0">
+                        <a:rPr lang="en-US" sz="1200" b="1" dirty="0">
                           <a:solidFill>
                             <a:srgbClr val="FFFFFF"/>
                           </a:solidFill>
@@ -2683,9 +2722,9 @@
                           <a:ea typeface="Calibri" pitchFamily="34" charset="-122"/>
                           <a:cs typeface="Calibri" pitchFamily="34" charset="-120"/>
                         </a:rPr>
-                        <a:t>Qué le reprochan</a:t>
+                        <a:t>El problema</a:t>
                       </a:r>
-                      <a:endParaRPr lang="en-US" sz="1250" dirty="0">
+                      <a:endParaRPr lang="en-US" sz="1200" dirty="0">
                         <a:latin typeface="Calibri" charset="0"/>
                         <a:ea typeface="Calibri" charset="0"/>
                         <a:cs typeface="Calibri" charset="0"/>
@@ -2735,7 +2774,7 @@
                   </a:tcPr>
                 </a:tc>
               </a:tr>
-              <a:tr h="438912">
+              <a:tr h="457200">
                 <a:tc>
                   <a:txBody>
                     <a:bodyPr/>
@@ -2745,7 +2784,7 @@
                         <a:buNone/>
                       </a:pPr>
                       <a:r>
-                        <a:rPr lang="en-US" sz="1250" dirty="0">
+                        <a:rPr lang="en-US" sz="1200" dirty="0">
                           <a:solidFill>
                             <a:srgbClr val="2E2119"/>
                           </a:solidFill>
@@ -2755,7 +2794,7 @@
                         </a:rPr>
                         <a:t>Papel y boli</a:t>
                       </a:r>
-                      <a:endParaRPr lang="en-US" sz="1250" dirty="0">
+                      <a:endParaRPr lang="en-US" sz="1200" dirty="0">
                         <a:latin typeface="Calibri" charset="0"/>
                         <a:ea typeface="Calibri" charset="0"/>
                         <a:cs typeface="Calibri" charset="0"/>
@@ -2813,7 +2852,7 @@
                         <a:buNone/>
                       </a:pPr>
                       <a:r>
-                        <a:rPr lang="en-US" sz="1250" dirty="0">
+                        <a:rPr lang="en-US" sz="1200" dirty="0">
                           <a:solidFill>
                             <a:srgbClr val="2E2119"/>
                           </a:solidFill>
@@ -2821,9 +2860,9 @@
                           <a:ea typeface="Calibri" pitchFamily="34" charset="-122"/>
                           <a:cs typeface="Calibri" pitchFamily="34" charset="-120"/>
                         </a:rPr>
-                        <a:t>Gratis, sin curva de aprendizaje</a:t>
+                        <a:t>Rápido y sencillo</a:t>
                       </a:r>
-                      <a:endParaRPr lang="en-US" sz="1250" dirty="0">
+                      <a:endParaRPr lang="en-US" sz="1200" dirty="0">
                         <a:latin typeface="Calibri" charset="0"/>
                         <a:ea typeface="Calibri" charset="0"/>
                         <a:cs typeface="Calibri" charset="0"/>
@@ -2881,7 +2920,7 @@
                         <a:buNone/>
                       </a:pPr>
                       <a:r>
-                        <a:rPr lang="en-US" sz="1250" dirty="0">
+                        <a:rPr lang="en-US" sz="1200" dirty="0">
                           <a:solidFill>
                             <a:srgbClr val="2E2119"/>
                           </a:solidFill>
@@ -2889,9 +2928,9 @@
                           <a:ea typeface="Calibri" pitchFamily="34" charset="-122"/>
                           <a:cs typeface="Calibri" pitchFamily="34" charset="-120"/>
                         </a:rPr>
-                        <a:t>Sin overview fija: no evita duplicados</a:t>
+                        <a:t>Se pierde fácil; de un solo uso (gasta papel)</a:t>
                       </a:r>
-                      <a:endParaRPr lang="en-US" sz="1250" dirty="0">
+                      <a:endParaRPr lang="en-US" sz="1200" dirty="0">
                         <a:latin typeface="Calibri" charset="0"/>
                         <a:ea typeface="Calibri" charset="0"/>
                         <a:cs typeface="Calibri" charset="0"/>
@@ -2941,7 +2980,7 @@
                   </a:tcPr>
                 </a:tc>
               </a:tr>
-              <a:tr h="438912">
+              <a:tr h="457200">
                 <a:tc>
                   <a:txBody>
                     <a:bodyPr/>
@@ -2951,7 +2990,7 @@
                         <a:buNone/>
                       </a:pPr>
                       <a:r>
-                        <a:rPr lang="en-US" sz="1250" dirty="0">
+                        <a:rPr lang="en-US" sz="1200" dirty="0">
                           <a:solidFill>
                             <a:srgbClr val="2E2119"/>
                           </a:solidFill>
@@ -2959,9 +2998,9 @@
                           <a:ea typeface="Calibri" pitchFamily="34" charset="-122"/>
                           <a:cs typeface="Calibri" pitchFamily="34" charset="-120"/>
                         </a:rPr>
-                        <a:t>Grupo de WhatsApp</a:t>
+                        <a:t>Notas (móvil)</a:t>
                       </a:r>
-                      <a:endParaRPr lang="en-US" sz="1250" dirty="0">
+                      <a:endParaRPr lang="en-US" sz="1200" dirty="0">
                         <a:latin typeface="Calibri" charset="0"/>
                         <a:ea typeface="Calibri" charset="0"/>
                         <a:cs typeface="Calibri" charset="0"/>
@@ -3019,7 +3058,7 @@
                         <a:buNone/>
                       </a:pPr>
                       <a:r>
-                        <a:rPr lang="en-US" sz="1250" dirty="0">
+                        <a:rPr lang="en-US" sz="1200" dirty="0">
                           <a:solidFill>
                             <a:srgbClr val="2E2119"/>
                           </a:solidFill>
@@ -3027,9 +3066,9 @@
                           <a:ea typeface="Calibri" pitchFamily="34" charset="-122"/>
                           <a:cs typeface="Calibri" pitchFamily="34" charset="-120"/>
                         </a:rPr>
-                        <a:t>Ya instalado, se mira a diario</a:t>
+                        <a:t>La más usada; simple y reusable — "la que mejor funciona"</a:t>
                       </a:r>
-                      <a:endParaRPr lang="en-US" sz="1250" dirty="0">
+                      <a:endParaRPr lang="en-US" sz="1200" dirty="0">
                         <a:latin typeface="Calibri" charset="0"/>
                         <a:ea typeface="Calibri" charset="0"/>
                         <a:cs typeface="Calibri" charset="0"/>
@@ -3087,7 +3126,7 @@
                         <a:buNone/>
                       </a:pPr>
                       <a:r>
-                        <a:rPr lang="en-US" sz="1250" dirty="0">
+                        <a:rPr lang="en-US" sz="1200" dirty="0">
                           <a:solidFill>
                             <a:srgbClr val="2E2119"/>
                           </a:solidFill>
@@ -3095,9 +3134,9 @@
                           <a:ea typeface="Calibri" pitchFamily="34" charset="-122"/>
                           <a:cs typeface="Calibri" pitchFamily="34" charset="-120"/>
                         </a:rPr>
-                        <a:t>El aviso se pierde entre mensajes</a:t>
+                        <a:t>No se comparte ni coedita en tiempo real</a:t>
                       </a:r>
-                      <a:endParaRPr lang="en-US" sz="1250" dirty="0">
+                      <a:endParaRPr lang="en-US" sz="1200" dirty="0">
                         <a:latin typeface="Calibri" charset="0"/>
                         <a:ea typeface="Calibri" charset="0"/>
                         <a:cs typeface="Calibri" charset="0"/>
@@ -3147,7 +3186,7 @@
                   </a:tcPr>
                 </a:tc>
               </a:tr>
-              <a:tr h="438912">
+              <a:tr h="457200">
                 <a:tc>
                   <a:txBody>
                     <a:bodyPr/>
@@ -3157,7 +3196,7 @@
                         <a:buNone/>
                       </a:pPr>
                       <a:r>
-                        <a:rPr lang="en-US" sz="1250" dirty="0">
+                        <a:rPr lang="en-US" sz="1200" dirty="0">
                           <a:solidFill>
                             <a:srgbClr val="2E2119"/>
                           </a:solidFill>
@@ -3167,7 +3206,7 @@
                         </a:rPr>
                         <a:t>Bring!</a:t>
                       </a:r>
-                      <a:endParaRPr lang="en-US" sz="1250" dirty="0">
+                      <a:endParaRPr lang="en-US" sz="1200" dirty="0">
                         <a:latin typeface="Calibri" charset="0"/>
                         <a:ea typeface="Calibri" charset="0"/>
                         <a:cs typeface="Calibri" charset="0"/>
@@ -3225,7 +3264,7 @@
                         <a:buNone/>
                       </a:pPr>
                       <a:r>
-                        <a:rPr lang="en-US" sz="1250" dirty="0">
+                        <a:rPr lang="en-US" sz="1200" dirty="0">
                           <a:solidFill>
                             <a:srgbClr val="2E2119"/>
                           </a:solidFill>
@@ -3233,9 +3272,9 @@
                           <a:ea typeface="Calibri" pitchFamily="34" charset="-122"/>
                           <a:cs typeface="Calibri" pitchFamily="34" charset="-120"/>
                         </a:rPr>
-                        <a:t>Listas simples por categorías</a:t>
+                        <a:t>Colaborativo de verdad, en tiempo real</a:t>
                       </a:r>
-                      <a:endParaRPr lang="en-US" sz="1250" dirty="0">
+                      <a:endParaRPr lang="en-US" sz="1200" dirty="0">
                         <a:latin typeface="Calibri" charset="0"/>
                         <a:ea typeface="Calibri" charset="0"/>
                         <a:cs typeface="Calibri" charset="0"/>
@@ -3293,7 +3332,7 @@
                         <a:buNone/>
                       </a:pPr>
                       <a:r>
-                        <a:rPr lang="en-US" sz="1250" dirty="0">
+                        <a:rPr lang="en-US" sz="1200" dirty="0">
                           <a:solidFill>
                             <a:srgbClr val="2E2119"/>
                           </a:solidFill>
@@ -3301,9 +3340,9 @@
                           <a:ea typeface="Calibri" pitchFamily="34" charset="-122"/>
                           <a:cs typeface="Calibri" pitchFamily="34" charset="-120"/>
                         </a:rPr>
-                        <a:t>Borra items sin querer; pide cuenta hasta en solitario</a:t>
+                        <a:t>Paso extra al añadir un item; su "Inspiración" no resuelve el caso de uso</a:t>
                       </a:r>
-                      <a:endParaRPr lang="en-US" sz="1250" dirty="0">
+                      <a:endParaRPr lang="en-US" sz="1200" dirty="0">
                         <a:latin typeface="Calibri" charset="0"/>
                         <a:ea typeface="Calibri" charset="0"/>
                         <a:cs typeface="Calibri" charset="0"/>
@@ -3353,7 +3392,7 @@
                   </a:tcPr>
                 </a:tc>
               </a:tr>
-              <a:tr h="438912">
+              <a:tr h="457200">
                 <a:tc>
                   <a:txBody>
                     <a:bodyPr/>
@@ -3363,7 +3402,7 @@
                         <a:buNone/>
                       </a:pPr>
                       <a:r>
-                        <a:rPr lang="en-US" sz="1250" dirty="0">
+                        <a:rPr lang="en-US" sz="1200" dirty="0">
                           <a:solidFill>
                             <a:srgbClr val="2E2119"/>
                           </a:solidFill>
@@ -3373,7 +3412,7 @@
                         </a:rPr>
                         <a:t>AnyList</a:t>
                       </a:r>
-                      <a:endParaRPr lang="en-US" sz="1250" dirty="0">
+                      <a:endParaRPr lang="en-US" sz="1200" dirty="0">
                         <a:latin typeface="Calibri" charset="0"/>
                         <a:ea typeface="Calibri" charset="0"/>
                         <a:cs typeface="Calibri" charset="0"/>
@@ -3431,7 +3470,7 @@
                         <a:buNone/>
                       </a:pPr>
                       <a:r>
-                        <a:rPr lang="en-US" sz="1250" dirty="0">
+                        <a:rPr lang="en-US" sz="1200" dirty="0">
                           <a:solidFill>
                             <a:srgbClr val="2E2119"/>
                           </a:solidFill>
@@ -3439,9 +3478,9 @@
                           <a:ea typeface="Calibri" pitchFamily="34" charset="-122"/>
                           <a:cs typeface="Calibri" pitchFamily="34" charset="-120"/>
                         </a:rPr>
-                        <a:t>Listas compartidas + recetas</a:t>
+                        <a:t>Reconoce items al escribir + código de barras</a:t>
                       </a:r>
-                      <a:endParaRPr lang="en-US" sz="1250" dirty="0">
+                      <a:endParaRPr lang="en-US" sz="1200" dirty="0">
                         <a:latin typeface="Calibri" charset="0"/>
                         <a:ea typeface="Calibri" charset="0"/>
                         <a:cs typeface="Calibri" charset="0"/>
@@ -3499,7 +3538,7 @@
                         <a:buNone/>
                       </a:pPr>
                       <a:r>
-                        <a:rPr lang="en-US" sz="1250" dirty="0">
+                        <a:rPr lang="en-US" sz="1200" dirty="0">
                           <a:solidFill>
                             <a:srgbClr val="2E2119"/>
                           </a:solidFill>
@@ -3507,9 +3546,9 @@
                           <a:ea typeface="Calibri" pitchFamily="34" charset="-122"/>
                           <a:cs typeface="Calibri" pitchFamily="34" charset="-120"/>
                         </a:rPr>
-                        <a:t>Interfaz "obtusa"; borra el item al marcarlo comprado</a:t>
+                        <a:t>Todo el valor apunta a cocinar, no a ahorrar o controlar stock</a:t>
                       </a:r>
-                      <a:endParaRPr lang="en-US" sz="1250" dirty="0">
+                      <a:endParaRPr lang="en-US" sz="1200" dirty="0">
                         <a:latin typeface="Calibri" charset="0"/>
                         <a:ea typeface="Calibri" charset="0"/>
                         <a:cs typeface="Calibri" charset="0"/>
@@ -3565,18 +3604,18 @@
       </p:graphicFrame>
       <p:sp>
         <p:nvSpPr>
-          <p:cNvPr id="7" name="Shape 3"/>
+          <p:cNvPr id="8" name="Shape 4"/>
           <p:cNvSpPr/>
           <p:nvPr/>
         </p:nvSpPr>
         <p:spPr>
           <a:xfrm>
-            <a:off x="548640" y="3840480"/>
-            <a:ext cx="11064240" cy="1417320"/>
+            <a:off x="548640" y="3977640"/>
+            <a:ext cx="11064240" cy="1280160"/>
           </a:xfrm>
           <a:prstGeom prst="roundRect">
             <a:avLst>
-              <a:gd name="adj" fmla="val 7742"/>
+              <a:gd name="adj" fmla="val 8571"/>
             </a:avLst>
           </a:prstGeom>
           <a:solidFill>
@@ -3594,14 +3633,14 @@
       </p:sp>
       <p:sp>
         <p:nvSpPr>
-          <p:cNvPr id="8" name="Text 4"/>
-          <p:cNvSpPr txBox="1"/>
-          <p:nvPr/>
-        </p:nvSpPr>
-        <p:spPr>
-          <a:xfrm>
-            <a:off x="777240" y="3977640"/>
-            <a:ext cx="4572000" cy="274320"/>
+          <p:cNvPr id="9" name="Text 5"/>
+          <p:cNvSpPr txBox="1"/>
+          <p:nvPr/>
+        </p:nvSpPr>
+        <p:spPr>
+          <a:xfrm>
+            <a:off x="777240" y="4096512"/>
+            <a:ext cx="5486400" cy="274320"/>
           </a:xfrm>
           <a:prstGeom prst="rect">
             <a:avLst/>
@@ -3625,7 +3664,7 @@
                 <a:ea typeface="Calibri" pitchFamily="34" charset="-122"/>
                 <a:cs typeface="Calibri" pitchFamily="34" charset="-120"/>
               </a:rPr>
-              <a:t>Cita literal verificada</a:t>
+              <a:t>Cita literal verificada (fuente secundaria)</a:t>
             </a:r>
             <a:endParaRPr lang="en-US" sz="1100" dirty="0"/>
           </a:p>
@@ -3633,14 +3672,14 @@
       </p:sp>
       <p:sp>
         <p:nvSpPr>
-          <p:cNvPr id="9" name="Text 5"/>
-          <p:cNvSpPr txBox="1"/>
-          <p:nvPr/>
-        </p:nvSpPr>
-        <p:spPr>
-          <a:xfrm>
-            <a:off x="777240" y="4251960"/>
-            <a:ext cx="10607040" cy="548640"/>
+          <p:cNvPr id="10" name="Text 6"/>
+          <p:cNvSpPr txBox="1"/>
+          <p:nvPr/>
+        </p:nvSpPr>
+        <p:spPr>
+          <a:xfrm>
+            <a:off x="777240" y="4370832"/>
+            <a:ext cx="10607040" cy="502920"/>
           </a:xfrm>
           <a:prstGeom prst="rect">
             <a:avLst/>
@@ -3656,7 +3695,7 @@
               <a:buNone/>
             </a:pPr>
             <a:r>
-              <a:rPr lang="en-US" sz="1300" i="1" dirty="0">
+              <a:rPr lang="en-US" sz="1250" i="1" dirty="0">
                 <a:solidFill>
                   <a:srgbClr val="2E2119"/>
                 </a:solidFill>
@@ -3666,19 +3705,19 @@
               </a:rPr>
               <a:t>"El icono de la aplicación aparece marcado como comprado en el Apple Watch pero no llega a descargarse ni a instalarse."</a:t>
             </a:r>
-            <a:endParaRPr lang="en-US" sz="1300" dirty="0"/>
-          </a:p>
-        </p:txBody>
-      </p:sp>
-      <p:sp>
-        <p:nvSpPr>
-          <p:cNvPr id="10" name="Text 6"/>
-          <p:cNvSpPr txBox="1"/>
-          <p:nvPr/>
-        </p:nvSpPr>
-        <p:spPr>
-          <a:xfrm>
-            <a:off x="777240" y="4800600"/>
+            <a:endParaRPr lang="en-US" sz="1250" dirty="0"/>
+          </a:p>
+        </p:txBody>
+      </p:sp>
+      <p:sp>
+        <p:nvSpPr>
+          <p:cNvPr id="11" name="Text 7"/>
+          <p:cNvSpPr txBox="1"/>
+          <p:nvPr/>
+        </p:nvSpPr>
+        <p:spPr>
+          <a:xfrm>
+            <a:off x="777240" y="4864608"/>
             <a:ext cx="10607040" cy="320040"/>
           </a:xfrm>
           <a:prstGeom prst="rect">
@@ -3711,7 +3750,7 @@
       </p:sp>
       <p:sp>
         <p:nvSpPr>
-          <p:cNvPr id="11" name="Shape 7"/>
+          <p:cNvPr id="12" name="Shape 8"/>
           <p:cNvSpPr/>
           <p:nvPr/>
         </p:nvSpPr>
@@ -3738,7 +3777,7 @@
       </p:sp>
       <p:sp>
         <p:nvSpPr>
-          <p:cNvPr id="12" name="Text 8"/>
+          <p:cNvPr id="13" name="Text 9"/>
           <p:cNvSpPr txBox="1"/>
           <p:nvPr/>
         </p:nvSpPr>
@@ -4005,7 +4044,7 @@
                 <a:ea typeface="Cambria" pitchFamily="34" charset="-122"/>
                 <a:cs typeface="Cambria" pitchFamily="34" charset="-120"/>
               </a:rPr>
-              <a:t>De usabilidad</a:t>
+              <a:t>De posicionamiento</a:t>
             </a:r>
             <a:endParaRPr lang="en-US" sz="1500" dirty="0"/>
           </a:p>
@@ -4044,7 +4083,7 @@
                 <a:ea typeface="Calibri" pitchFamily="34" charset="-122"/>
                 <a:cs typeface="Calibri" pitchFamily="34" charset="-120"/>
               </a:rPr>
-              <a:t>Toda solución exige abrir "otra app" aparte del WhatsApp de siempre — por eso se abandonan a las 2 pruebas.</a:t>
+              <a:t>Ni Bring! ni AnyList apuntan a ahorrar o controlar stock — las dos están construidas para cocinar y planificar recetas.</a:t>
             </a:r>
             <a:endParaRPr lang="en-US" sz="1300" dirty="0"/>
           </a:p>
@@ -4112,7 +4151,7 @@
                 <a:ea typeface="Cambria" pitchFamily="34" charset="-122"/>
                 <a:cs typeface="Cambria" pitchFamily="34" charset="-120"/>
               </a:rPr>
-              <a:t>Funcional</a:t>
+              <a:t>De fricción</a:t>
             </a:r>
             <a:endParaRPr lang="en-US" sz="1500" dirty="0"/>
           </a:p>
@@ -4151,7 +4190,7 @@
                 <a:ea typeface="Calibri" pitchFamily="34" charset="-122"/>
                 <a:cs typeface="Calibri" pitchFamily="34" charset="-120"/>
               </a:rPr>
-              <a:t>Ninguna combina lista de la compra con inventario real de nevera.</a:t>
+              <a:t>Cualquier paso extra sobre "simplemente escribir" hace que la gente vuelva a Notas, la solución más simple.</a:t>
             </a:r>
             <a:endParaRPr lang="en-US" sz="1300" dirty="0"/>
           </a:p>
@@ -4219,7 +4258,7 @@
                 <a:ea typeface="Cambria" pitchFamily="34" charset="-122"/>
                 <a:cs typeface="Cambria" pitchFamily="34" charset="-120"/>
               </a:rPr>
-              <a:t>De fiabilidad</a:t>
+              <a:t>De colaboración</a:t>
             </a:r>
             <a:endParaRPr lang="en-US" sz="1500" dirty="0"/>
           </a:p>
@@ -4258,7 +4297,7 @@
                 <a:ea typeface="Calibri" pitchFamily="34" charset="-122"/>
                 <a:cs typeface="Calibri" pitchFamily="34" charset="-120"/>
               </a:rPr>
-              <a:t>Hasta las apps "serias" tienen fallos básicos (AnyList borra items al marcarlos comprados).</a:t>
+              <a:t>La solución que mejor funciona en la práctica (Notas) no se puede compartir ni coeditar en tiempo real.</a:t>
             </a:r>
             <a:endParaRPr lang="en-US" sz="1300" dirty="0"/>
           </a:p>
@@ -4319,7 +4358,7 @@
                 <a:ea typeface="Calibri" pitchFamily="34" charset="-122"/>
                 <a:cs typeface="Calibri" pitchFamily="34" charset="-120"/>
               </a:rPr>
-              <a:t>El hueco no es "una lista más bonita": es combinar nevera + lista compartida sin fricción de aprendizaje, resistiendo bien que dos personas la usen a la vez.</a:t>
+              <a:t>El hueco real: una herramienta tan rápida de usar como Notas, tan colaborativa como Bring!, y centrada en ahorro y control de stock — el ángulo que nadie cubre.</a:t>
             </a:r>
             <a:endParaRPr lang="en-US" sz="1400" dirty="0"/>
           </a:p>

</xml_diff>

<commit_message>
Update survey validation to n=19: two people have now tried an app
7 new responses arrived. The headline "0/12 has tried an app" claim no
longer holds — 2 respondents (Bring!, "Notas") report having tried one.
Updated the story honestly: the stronger, still-true claim is that 0/19
use an app *today* as their method — both people who tried one abandoned
it, and the Bring! user explains why unprompted (housemates didn't
cooperate). Also added new open-text quotes (price sensitivity, an exact
description of the Fridge+List problem) across docs/ideacion.md and the
two survey slides in the presentation.

Co-Authored-By: Claude Sonnet 5 <noreply@anthropic.com>
Claude-Session: https://claude.ai/code/session_012BwrUiCYr6ApYk5hmXyh4o
</commit_message>
<xml_diff>
--- a/docs/larder-presentacion.pptx
+++ b/docs/larder-presentacion.pptx
@@ -1040,7 +1040,7 @@
           <a:p>
             <a:r>
               <a:rPr lang="en-US" dirty="0"/>
-              <a:t>n=12. Punto clave que pidio Nadia remarcar: la gente no usa apps de listas (0/12), y eso a pesar de que Bring!/AnyList existen y de que "una app especifica" era una opcion de respuesta explicita en la propia pregunta 3 -- nadie la marco. Esto no invalida la idea: valida que el problema no es "falta una app", sino que las que hay no logran adopcion real. Los dos stats de dolor (75% duplico, 75% volvio a la tienda) bajaron un poco respecto a n=11 (82%/73%), como es esperable con muestra pequena -- se anade el dato conjunto (50% sufrio ambas cosas el mismo mes) como refuerzo.</a:t>
+              <a:t>n=19. Cambio importante respecto a la version anterior (n=12): hasta entonces nadie habia probado una app; con estas 7 respuestas nuevas aparecen 2 personas que si (Bring!, "Notas" -- esta ultima ambigua). Se actualizo el titular honestamente en vez de mantener el "0/12 nadie" que ya no era cierto. El dato que SI se mantiene y es mas fuerte que antes: 0/19 usa una app HOY como metodo (Pregunta 3) -- las 2 que la probaron la abandonaron. Quien probo Bring lo explica el mismo: fallo por falta de cooperacion de sus companeros de piso, lo cual refuerza en vez de contradecir la tesis central. Los stats de dolor bajaron una pizca (75%-&gt;74%) por la muestra mas grande, y se anade el dato conjunto (53%, 10/19) sufrio ambas cosas el mismo mes.</a:t>
             </a:r>
             <a:endParaRPr lang="en-US" dirty="0"/>
           </a:p>
@@ -1128,7 +1128,7 @@
           <a:p>
             <a:r>
               <a:rPr lang="en-US" dirty="0"/>
-              <a:t>Categorizacion pedida explicitamente: "no se quien compro que" cuenta para AMBAS columnas (coop + tracker de gastos), "no saber que quieren los otros"/"comen mis cosas" es coop puro, "no participan/tardan en pagar" es tracker de gastos puro. El 33% de coop y el 33% de "no llevamos cuenta" en la P8 son numeros independientes que apuntan al mismo sitio: History no es una funcion añadida sin motivo.</a:t>
+              <a:t>Actualizado a n=19. Categorizacion pedida explicitamente: "no se quien compro que" cuenta para AMBAS columnas (coop + tracker de gastos), "no saber que quieren los otros"/"comen mis cosas"/"compran cosas que no quiero" es coop puro, "no participan/tardan en pagar" es tracker de gastos puro. El 26% de coop y el 37% de "no llevamos cuenta" en la P8 son numeros independientes que apuntan al mismo sitio: History no es una funcion añadida sin motivo. (Dos menciones espontaneas al precio -- "esta todo carisimo", "comprar es caro" -- se documentaron en ideacion.md pero no entraron en esta diapositiva para no forzar el layout; son una senal a favor de Prices, no de Fridge/List/History.)</a:t>
             </a:r>
             <a:endParaRPr lang="en-US" dirty="0"/>
           </a:p>
@@ -5896,7 +5896,7 @@
                 <a:ea typeface="Cambria" pitchFamily="34" charset="-122"/>
                 <a:cs typeface="Cambria" pitchFamily="34" charset="-120"/>
               </a:rPr>
-              <a:t>La encuesta confirma el hueco (n=12)</a:t>
+              <a:t>La encuesta confirma el hueco (n=19)</a:t>
             </a:r>
             <a:endParaRPr lang="en-US" sz="2800" dirty="0"/>
           </a:p>
@@ -5935,7 +5935,7 @@
                 <a:ea typeface="Calibri" pitchFamily="34" charset="-122"/>
                 <a:cs typeface="Calibri" pitchFamily="34" charset="-120"/>
               </a:rPr>
-              <a:t>Encuesta bilingüe (ES/EN), 9 preguntas sobre hechos del último mes — no opiniones sobre una app futura. 12 respuestas reales recogidas.</a:t>
+              <a:t>Encuesta bilingüe (ES/EN), 9 preguntas sobre hechos del último mes — no opiniones sobre una app futura. 19 respuestas reales recogidas.</a:t>
             </a:r>
             <a:endParaRPr lang="en-US" sz="1000" dirty="0"/>
           </a:p>
@@ -5996,7 +5996,7 @@
                 <a:ea typeface="Cambria" pitchFamily="34" charset="-122"/>
                 <a:cs typeface="Cambria" pitchFamily="34" charset="-120"/>
               </a:rPr>
-              <a:t>0/12</a:t>
+              <a:t>0/19</a:t>
             </a:r>
             <a:endParaRPr lang="en-US" sz="3000" dirty="0"/>
           </a:p>
@@ -6035,7 +6035,7 @@
                 <a:ea typeface="Calibri" pitchFamily="34" charset="-122"/>
                 <a:cs typeface="Calibri" pitchFamily="34" charset="-120"/>
               </a:rPr>
-              <a:t>ha probado alguna app específica de listas — aunque podían elegirla como método (ver abajo)</a:t>
+              <a:t>usa hoy una app específica como método — aunque 2 personas SÍ la probaron alguna vez (ver abajo)</a:t>
             </a:r>
             <a:endParaRPr lang="en-US" sz="1000" dirty="0"/>
           </a:p>
@@ -6096,7 +6096,7 @@
                 <a:ea typeface="Cambria" pitchFamily="34" charset="-122"/>
                 <a:cs typeface="Cambria" pitchFamily="34" charset="-120"/>
               </a:rPr>
-              <a:t>75%</a:t>
+              <a:t>74%</a:t>
             </a:r>
             <a:endParaRPr lang="en-US" sz="3000" dirty="0"/>
           </a:p>
@@ -6196,7 +6196,7 @@
                 <a:ea typeface="Cambria" pitchFamily="34" charset="-122"/>
                 <a:cs typeface="Cambria" pitchFamily="34" charset="-120"/>
               </a:rPr>
-              <a:t>75%</a:t>
+              <a:t>74%</a:t>
             </a:r>
             <a:endParaRPr lang="en-US" sz="3000" dirty="0"/>
           </a:p>
@@ -6274,7 +6274,7 @@
                 <a:ea typeface="Calibri" pitchFamily="34" charset="-122"/>
                 <a:cs typeface="Calibri" pitchFamily="34" charset="-120"/>
               </a:rPr>
-              <a:t>El 50% (6 de 12 personas) sufrió ambas cosas — compró duplicado y volvió a la tienda — en el mismo mes.</a:t>
+              <a:t>El 53% (10 de 19 personas) sufrió ambas cosas — compró duplicado y volvió a la tienda — en el mismo mes.</a:t>
             </a:r>
             <a:endParaRPr lang="en-US" sz="1150" dirty="0"/>
           </a:p>
@@ -6464,7 +6464,7 @@
                 <a:ea typeface="Calibri" pitchFamily="34" charset="-122"/>
                 <a:cs typeface="Calibri" pitchFamily="34" charset="-120"/>
               </a:rPr>
-              <a:t>5</a:t>
+              <a:t>7</a:t>
             </a:r>
             <a:endParaRPr lang="en-US" sz="1100" dirty="0"/>
           </a:p>
@@ -6540,7 +6540,7 @@
         <p:spPr>
           <a:xfrm>
             <a:off x="2788920" y="3986784"/>
-            <a:ext cx="2852928" cy="219456"/>
+            <a:ext cx="3056709" cy="219456"/>
           </a:xfrm>
           <a:prstGeom prst="roundRect">
             <a:avLst>
@@ -6586,7 +6586,7 @@
                 <a:ea typeface="Calibri" pitchFamily="34" charset="-122"/>
                 <a:cs typeface="Calibri" pitchFamily="34" charset="-120"/>
               </a:rPr>
-              <a:t>4</a:t>
+              <a:t>6</a:t>
             </a:r>
             <a:endParaRPr lang="en-US" sz="1100" dirty="0"/>
           </a:p>
@@ -6662,7 +6662,7 @@
         <p:spPr>
           <a:xfrm>
             <a:off x="2788920" y="4297680"/>
-            <a:ext cx="1426464" cy="219456"/>
+            <a:ext cx="2547257" cy="219456"/>
           </a:xfrm>
           <a:prstGeom prst="roundRect">
             <a:avLst>
@@ -6708,7 +6708,7 @@
                 <a:ea typeface="Calibri" pitchFamily="34" charset="-122"/>
                 <a:cs typeface="Calibri" pitchFamily="34" charset="-120"/>
               </a:rPr>
-              <a:t>2</a:t>
+              <a:t>5</a:t>
             </a:r>
             <a:endParaRPr lang="en-US" sz="1100" dirty="0"/>
           </a:p>
@@ -6784,7 +6784,7 @@
         <p:spPr>
           <a:xfrm>
             <a:off x="2788920" y="4608576"/>
-            <a:ext cx="713232" cy="219456"/>
+            <a:ext cx="509451" cy="219456"/>
           </a:xfrm>
           <a:prstGeom prst="roundRect">
             <a:avLst>
@@ -6969,7 +6969,7 @@
                 <a:ea typeface="Calibri" pitchFamily="34" charset="-122"/>
                 <a:cs typeface="Calibri" pitchFamily="34" charset="-120"/>
               </a:rPr>
-              <a:t>↑ opción disponible desde el primer momento — nadie la eligió</a:t>
+              <a:t>↑ 2 personas la probaron alguna vez (Pregunta 7) — pero 0/19 la usa hoy: la abandonaron</a:t>
             </a:r>
             <a:endParaRPr lang="en-US" sz="950" dirty="0"/>
           </a:p>
@@ -7038,7 +7038,7 @@
                 <a:ea typeface="Calibri" pitchFamily="34" charset="-122"/>
                 <a:cs typeface="Calibri" pitchFamily="34" charset="-120"/>
               </a:rPr>
-              <a:t>Las apps no son el problema — la adopción sí.  </a:t>
+              <a:t>Las apps no son el problema — la retención sí.  </a:t>
             </a:r>
             <a:endParaRPr lang="en-US" sz="1150" dirty="0"/>
           </a:p>
@@ -7055,7 +7055,7 @@
                 <a:ea typeface="Calibri" pitchFamily="34" charset="-122"/>
                 <a:cs typeface="Calibri" pitchFamily="34" charset="-120"/>
               </a:rPr>
-              <a:t>Bring! y AnyList llevan años disponibles y son razonablemente buenas (estado del arte, diapositiva anterior). Aun así, 0 de 12 personas las ha probado nunca, ni al escoger su método actual. El hueco no está en construir "una app más" — está en resolver por qué ninguna de las que ya existen consigue ni el primer uso.</a:t>
+              <a:t>Bring! y AnyList llevan años disponibles y son razonablemente buenas (estado del arte, diapositiva anterior). 2 de 19 personas confirman haberlas probado — pero ninguna las usa hoy. Quien probó Bring! lo explica sin que se le pregunte: "porque si no colaboran los demás... pues mal vamos". El hueco no está en construir "una app más" — está en resolver por qué las que existen no retienen ni a quien sí las prueba.</a:t>
             </a:r>
             <a:endParaRPr lang="en-US" sz="1150" dirty="0"/>
           </a:p>
@@ -7355,7 +7355,7 @@
                 <a:ea typeface="Calibri" pitchFamily="34" charset="-122"/>
                 <a:cs typeface="Calibri" pitchFamily="34" charset="-120"/>
               </a:rPr>
-              <a:t>4 de 12 personas (33%) — sin que se les preguntara</a:t>
+              <a:t>5 de 19 personas (26%) — sin que se les preguntara</a:t>
             </a:r>
             <a:endParaRPr lang="en-US" sz="1050" dirty="0"/>
           </a:p>
@@ -7370,7 +7370,7 @@
         <p:spPr>
           <a:xfrm>
             <a:off x="822960" y="2286000"/>
-            <a:ext cx="5029200" cy="3200400"/>
+            <a:ext cx="5029200" cy="3291840"/>
           </a:xfrm>
           <a:prstGeom prst="rect">
             <a:avLst/>
@@ -7384,13 +7384,13 @@
           <a:p>
             <a:pPr marL="342900" indent="-342900">
               <a:spcAft>
-                <a:spcPts val="1000"/>
+                <a:spcPts val="800"/>
               </a:spcAft>
               <a:buSzPct val="100000"/>
               <a:buChar char="•"/>
             </a:pPr>
             <a:r>
-              <a:rPr lang="en-US" sz="1200" i="1" dirty="0">
+              <a:rPr lang="en-US" sz="1150" i="1" dirty="0">
                 <a:solidFill>
                   <a:srgbClr val="2E2119"/>
                 </a:solidFill>
@@ -7400,18 +7400,18 @@
               </a:rPr>
               <a:t>"I don’t know who bought what"</a:t>
             </a:r>
-            <a:endParaRPr lang="en-US" sz="1200" dirty="0"/>
+            <a:endParaRPr lang="en-US" sz="1150" dirty="0"/>
           </a:p>
           <a:p>
             <a:pPr marL="342900" indent="-342900">
               <a:spcAft>
-                <a:spcPts val="1000"/>
+                <a:spcPts val="800"/>
               </a:spcAft>
               <a:buSzPct val="100000"/>
               <a:buChar char="•"/>
             </a:pPr>
             <a:r>
-              <a:rPr lang="en-US" sz="1200" i="1" dirty="0">
+              <a:rPr lang="en-US" sz="1150" i="1" dirty="0">
                 <a:solidFill>
                   <a:srgbClr val="2E2119"/>
                 </a:solidFill>
@@ -7421,18 +7421,18 @@
               </a:rPr>
               <a:t>"Not knowing what the others want, the others eating my stuff"</a:t>
             </a:r>
-            <a:endParaRPr lang="en-US" sz="1200" dirty="0"/>
+            <a:endParaRPr lang="en-US" sz="1150" dirty="0"/>
           </a:p>
           <a:p>
             <a:pPr marL="342900" indent="-342900">
               <a:spcAft>
-                <a:spcPts val="1000"/>
+                <a:spcPts val="800"/>
               </a:spcAft>
               <a:buSzPct val="100000"/>
               <a:buChar char="•"/>
             </a:pPr>
             <a:r>
-              <a:rPr lang="en-US" sz="1200" i="1" dirty="0">
+              <a:rPr lang="en-US" sz="1150" i="1" dirty="0">
                 <a:solidFill>
                   <a:srgbClr val="2E2119"/>
                 </a:solidFill>
@@ -7442,18 +7442,18 @@
               </a:rPr>
               <a:t>"When people use the food I planned to use in a meal for myself... so I have to use something else"</a:t>
             </a:r>
-            <a:endParaRPr lang="en-US" sz="1200" dirty="0"/>
+            <a:endParaRPr lang="en-US" sz="1150" dirty="0"/>
           </a:p>
           <a:p>
             <a:pPr marL="342900" indent="-342900">
               <a:spcAft>
-                <a:spcPts val="1000"/>
+                <a:spcPts val="800"/>
               </a:spcAft>
               <a:buSzPct val="100000"/>
               <a:buChar char="•"/>
             </a:pPr>
             <a:r>
-              <a:rPr lang="en-US" sz="1200" i="1" dirty="0">
+              <a:rPr lang="en-US" sz="1150" i="1" dirty="0">
                 <a:solidFill>
                   <a:srgbClr val="2E2119"/>
                 </a:solidFill>
@@ -7463,7 +7463,28 @@
               </a:rPr>
               <a:t>"Not knowing if someone bought something just for themself"</a:t>
             </a:r>
-            <a:endParaRPr lang="en-US" sz="1200" dirty="0"/>
+            <a:endParaRPr lang="en-US" sz="1150" dirty="0"/>
+          </a:p>
+          <a:p>
+            <a:pPr marL="342900" indent="-342900">
+              <a:spcAft>
+                <a:spcPts val="800"/>
+              </a:spcAft>
+              <a:buSzPct val="100000"/>
+              <a:buChar char="•"/>
+            </a:pPr>
+            <a:r>
+              <a:rPr lang="en-US" sz="1150" i="1" dirty="0">
+                <a:solidFill>
+                  <a:srgbClr val="2E2119"/>
+                </a:solidFill>
+                <a:latin typeface="Calibri" pitchFamily="34" charset="0"/>
+                <a:ea typeface="Calibri" pitchFamily="34" charset="-122"/>
+                <a:cs typeface="Calibri" pitchFamily="34" charset="-120"/>
+              </a:rPr>
+              <a:t>"Que compran cosas que no quiero"</a:t>
+            </a:r>
+            <a:endParaRPr lang="en-US" sz="1150" dirty="0"/>
           </a:p>
         </p:txBody>
       </p:sp>
@@ -7568,7 +7589,7 @@
                 <a:ea typeface="Calibri" pitchFamily="34" charset="-122"/>
                 <a:cs typeface="Calibri" pitchFamily="34" charset="-120"/>
               </a:rPr>
-              <a:t>2 menciones espontáneas + 4/12 (33%) dice en la Pregunta 8 que no llevan cuenta</a:t>
+              <a:t>2 menciones espontáneas + 7/19 (37%) dice en la Pregunta 8 que no llevan cuenta</a:t>
             </a:r>
             <a:endParaRPr lang="en-US" sz="1050" dirty="0"/>
           </a:p>

</xml_diff>

<commit_message>
Update survey validation to n=26, fixing two accidental duplicate submissions
9 new responses arrived. Two pairs were the same person submitting twice
by accident ("Las cantidades" and the "Amor y Paz" joke) — merged each
pair into one response, dropping the joke text from the survived one.
Net: 19 -> 26 unique responses.

The fridge-freshness complaint stopped being a single isolated mention:
4 independent respondents now raise it unprompted, one of them describing
almost verbatim the "aviso de stock bajo" already in Fridge's scope. Also
added new cooperation/expense-tracking quotes. Updated docs/ideacion.md,
the results artifact, and the two survey slides in the presentation.

Co-Authored-By: Claude Sonnet 5 <noreply@anthropic.com>
Claude-Session: https://claude.ai/code/session_012BwrUiCYr6ApYk5hmXyh4o
</commit_message>
<xml_diff>
--- a/docs/larder-presentacion.pptx
+++ b/docs/larder-presentacion.pptx
@@ -1040,7 +1040,7 @@
           <a:p>
             <a:r>
               <a:rPr lang="en-US" dirty="0"/>
-              <a:t>n=19. Cambio importante respecto a la version anterior (n=12): hasta entonces nadie habia probado una app; con estas 7 respuestas nuevas aparecen 2 personas que si (Bring!, "Notas" -- esta ultima ambigua). Se actualizo el titular honestamente en vez de mantener el "0/12 nadie" que ya no era cierto. El dato que SI se mantiene y es mas fuerte que antes: 0/19 usa una app HOY como metodo (Pregunta 3) -- las 2 que la probaron la abandonaron. Quien probo Bring lo explica el mismo: fallo por falta de cooperacion de sus companeros de piso, lo cual refuerza en vez de contradecir la tesis central. Los stats de dolor bajaron una pizca (75%-&gt;74%) por la muestra mas grande, y se anade el dato conjunto (53%, 10/19) sufrio ambas cosas el mismo mes.</a:t>
+              <a:t>n=26 (2 envios duplicados por accidente descartados: "las cantidades" y la broma "Amor y Paz", cada par contado una vez). El dato que se mantiene y es mas fuerte que antes: 0/26 usa una app HOY como metodo (Pregunta 3) -- las 2 que probaron una app (Bring!, "Notas") la abandonaron. Quien probo Bring lo explica el mismo: fallo por falta de cooperacion de sus companeros de piso. Con mas muestra, "duplico" (73%) y "olvido" (81%) ya no coinciden como antes -- es lo esperable, no una senal de manipulacion. El dato conjunto (58%, 15/26) sigue subiendo. Aparecen por primera vez 2 personas en el bucket "mas de 5 viajes olvidados".</a:t>
             </a:r>
             <a:endParaRPr lang="en-US" dirty="0"/>
           </a:p>
@@ -1128,7 +1128,7 @@
           <a:p>
             <a:r>
               <a:rPr lang="en-US" dirty="0"/>
-              <a:t>Actualizado a n=19. Categorizacion pedida explicitamente: "no se quien compro que" cuenta para AMBAS columnas (coop + tracker de gastos), "no saber que quieren los otros"/"comen mis cosas"/"compran cosas que no quiero" es coop puro, "no participan/tardan en pagar" es tracker de gastos puro. El 26% de coop y el 37% de "no llevamos cuenta" en la P8 son numeros independientes que apuntan al mismo sitio: History no es una funcion añadida sin motivo. (Dos menciones espontaneas al precio -- "esta todo carisimo", "comprar es caro" -- se documentaron en ideacion.md pero no entraron en esta diapositiva para no forzar el layout; son una senal a favor de Prices, no de Fridge/List/History.)</a:t>
+              <a:t>Actualizado a n=26 (2 duplicados por envio accidental descartados). Categorizacion: "no se quien compro que" y "llevar la cuenta de quien compro que antes" cuentan para AMBAS columnas (coop + tracker de gastos), "no saber que quieren los otros"/"comen mis cosas"/"compran cosas que no quiero" es coop puro, "no participan/tardan en pagar" es tracker de gastos puro. Cambio importante en esta tanda: la queja de caducidad/comida que se estropea paso de 1 mencion aislada a 4 menciones independientes -- ya es el segundo tema mas repetido despues de cooperacion, y una de ellas describe literalmente el "aviso de stock bajo" que ya estaba en el alcance de Fridge (documento de una pagina). Las menciones de precio (2, "esta todo carisimo"/"comprar es caro") siguen fuera de esta diapositiva por espacio -- estan en ideacion.md.</a:t>
             </a:r>
             <a:endParaRPr lang="en-US" dirty="0"/>
           </a:p>
@@ -5896,7 +5896,7 @@
                 <a:ea typeface="Cambria" pitchFamily="34" charset="-122"/>
                 <a:cs typeface="Cambria" pitchFamily="34" charset="-120"/>
               </a:rPr>
-              <a:t>La encuesta confirma el hueco (n=19)</a:t>
+              <a:t>La encuesta confirma el hueco (n=26)</a:t>
             </a:r>
             <a:endParaRPr lang="en-US" sz="2800" dirty="0"/>
           </a:p>
@@ -5935,7 +5935,7 @@
                 <a:ea typeface="Calibri" pitchFamily="34" charset="-122"/>
                 <a:cs typeface="Calibri" pitchFamily="34" charset="-120"/>
               </a:rPr>
-              <a:t>Encuesta bilingüe (ES/EN), 9 preguntas sobre hechos del último mes — no opiniones sobre una app futura. 19 respuestas reales recogidas.</a:t>
+              <a:t>Encuesta bilingüe (ES/EN), 9 preguntas sobre hechos del último mes — no opiniones sobre una app futura. 26 respuestas únicas (2 envíos duplicados por accidente, descartados).</a:t>
             </a:r>
             <a:endParaRPr lang="en-US" sz="1000" dirty="0"/>
           </a:p>
@@ -5996,7 +5996,7 @@
                 <a:ea typeface="Cambria" pitchFamily="34" charset="-122"/>
                 <a:cs typeface="Cambria" pitchFamily="34" charset="-120"/>
               </a:rPr>
-              <a:t>0/19</a:t>
+              <a:t>0/26</a:t>
             </a:r>
             <a:endParaRPr lang="en-US" sz="3000" dirty="0"/>
           </a:p>
@@ -6096,7 +6096,7 @@
                 <a:ea typeface="Cambria" pitchFamily="34" charset="-122"/>
                 <a:cs typeface="Cambria" pitchFamily="34" charset="-120"/>
               </a:rPr>
-              <a:t>74%</a:t>
+              <a:t>73%</a:t>
             </a:r>
             <a:endParaRPr lang="en-US" sz="3000" dirty="0"/>
           </a:p>
@@ -6196,7 +6196,7 @@
                 <a:ea typeface="Cambria" pitchFamily="34" charset="-122"/>
                 <a:cs typeface="Cambria" pitchFamily="34" charset="-120"/>
               </a:rPr>
-              <a:t>74%</a:t>
+              <a:t>81%</a:t>
             </a:r>
             <a:endParaRPr lang="en-US" sz="3000" dirty="0"/>
           </a:p>
@@ -6274,7 +6274,7 @@
                 <a:ea typeface="Calibri" pitchFamily="34" charset="-122"/>
                 <a:cs typeface="Calibri" pitchFamily="34" charset="-120"/>
               </a:rPr>
-              <a:t>El 53% (10 de 19 personas) sufrió ambas cosas — compró duplicado y volvió a la tienda — en el mismo mes.</a:t>
+              <a:t>El 58% (15 de 26 personas) sufrió ambas cosas — compró duplicado y volvió a la tienda — en el mismo mes.</a:t>
             </a:r>
             <a:endParaRPr lang="en-US" sz="1150" dirty="0"/>
           </a:p>
@@ -6464,7 +6464,7 @@
                 <a:ea typeface="Calibri" pitchFamily="34" charset="-122"/>
                 <a:cs typeface="Calibri" pitchFamily="34" charset="-120"/>
               </a:rPr>
-              <a:t>7</a:t>
+              <a:t>11</a:t>
             </a:r>
             <a:endParaRPr lang="en-US" sz="1100" dirty="0"/>
           </a:p>
@@ -6540,7 +6540,7 @@
         <p:spPr>
           <a:xfrm>
             <a:off x="2788920" y="3986784"/>
-            <a:ext cx="3056709" cy="219456"/>
+            <a:ext cx="2593571" cy="219456"/>
           </a:xfrm>
           <a:prstGeom prst="roundRect">
             <a:avLst>
@@ -6586,7 +6586,7 @@
                 <a:ea typeface="Calibri" pitchFamily="34" charset="-122"/>
                 <a:cs typeface="Calibri" pitchFamily="34" charset="-120"/>
               </a:rPr>
-              <a:t>6</a:t>
+              <a:t>8</a:t>
             </a:r>
             <a:endParaRPr lang="en-US" sz="1100" dirty="0"/>
           </a:p>
@@ -6662,7 +6662,7 @@
         <p:spPr>
           <a:xfrm>
             <a:off x="2788920" y="4297680"/>
-            <a:ext cx="2547257" cy="219456"/>
+            <a:ext cx="1945178" cy="219456"/>
           </a:xfrm>
           <a:prstGeom prst="roundRect">
             <a:avLst>
@@ -6708,7 +6708,7 @@
                 <a:ea typeface="Calibri" pitchFamily="34" charset="-122"/>
                 <a:cs typeface="Calibri" pitchFamily="34" charset="-120"/>
               </a:rPr>
-              <a:t>5</a:t>
+              <a:t>6</a:t>
             </a:r>
             <a:endParaRPr lang="en-US" sz="1100" dirty="0"/>
           </a:p>
@@ -6784,7 +6784,7 @@
         <p:spPr>
           <a:xfrm>
             <a:off x="2788920" y="4608576"/>
-            <a:ext cx="509451" cy="219456"/>
+            <a:ext cx="324196" cy="219456"/>
           </a:xfrm>
           <a:prstGeom prst="roundRect">
             <a:avLst>
@@ -6969,7 +6969,7 @@
                 <a:ea typeface="Calibri" pitchFamily="34" charset="-122"/>
                 <a:cs typeface="Calibri" pitchFamily="34" charset="-120"/>
               </a:rPr>
-              <a:t>↑ 2 personas la probaron alguna vez (Pregunta 7) — pero 0/19 la usa hoy: la abandonaron</a:t>
+              <a:t>↑ 2 personas la probaron alguna vez (Pregunta 7) — pero 0/26 la usa hoy: la abandonaron</a:t>
             </a:r>
             <a:endParaRPr lang="en-US" sz="950" dirty="0"/>
           </a:p>
@@ -7055,7 +7055,7 @@
                 <a:ea typeface="Calibri" pitchFamily="34" charset="-122"/>
                 <a:cs typeface="Calibri" pitchFamily="34" charset="-120"/>
               </a:rPr>
-              <a:t>Bring! y AnyList llevan años disponibles y son razonablemente buenas (estado del arte, diapositiva anterior). 2 de 19 personas confirman haberlas probado — pero ninguna las usa hoy. Quien probó Bring! lo explica sin que se le pregunte: "porque si no colaboran los demás... pues mal vamos". El hueco no está en construir "una app más" — está en resolver por qué las que existen no retienen ni a quien sí las prueba.</a:t>
+              <a:t>Bring! y AnyList llevan años disponibles y son razonablemente buenas (estado del arte, diapositiva anterior). 2 de 26 personas confirman haberlas probado — pero ninguna las usa hoy. Quien probó Bring! lo explica sin que se le pregunte: "porque si no colaboran los demás... pues mal vamos". El hueco no está en construir "una app más" — está en resolver por qué las que existen no retienen ni a quien sí las prueba.</a:t>
             </a:r>
             <a:endParaRPr lang="en-US" sz="1150" dirty="0"/>
           </a:p>
@@ -7355,7 +7355,7 @@
                 <a:ea typeface="Calibri" pitchFamily="34" charset="-122"/>
                 <a:cs typeface="Calibri" pitchFamily="34" charset="-120"/>
               </a:rPr>
-              <a:t>5 de 19 personas (26%) — sin que se les preguntara</a:t>
+              <a:t>6 de 26 personas (23%) — sin que se les preguntara</a:t>
             </a:r>
             <a:endParaRPr lang="en-US" sz="1050" dirty="0"/>
           </a:p>
@@ -7384,13 +7384,13 @@
           <a:p>
             <a:pPr marL="342900" indent="-342900">
               <a:spcAft>
-                <a:spcPts val="800"/>
+                <a:spcPts val="700"/>
               </a:spcAft>
               <a:buSzPct val="100000"/>
               <a:buChar char="•"/>
             </a:pPr>
             <a:r>
-              <a:rPr lang="en-US" sz="1150" i="1" dirty="0">
+              <a:rPr lang="en-US" sz="1050" i="1" dirty="0">
                 <a:solidFill>
                   <a:srgbClr val="2E2119"/>
                 </a:solidFill>
@@ -7400,18 +7400,18 @@
               </a:rPr>
               <a:t>"I don’t know who bought what"</a:t>
             </a:r>
-            <a:endParaRPr lang="en-US" sz="1150" dirty="0"/>
+            <a:endParaRPr lang="en-US" sz="1050" dirty="0"/>
           </a:p>
           <a:p>
             <a:pPr marL="342900" indent="-342900">
               <a:spcAft>
-                <a:spcPts val="800"/>
+                <a:spcPts val="700"/>
               </a:spcAft>
               <a:buSzPct val="100000"/>
               <a:buChar char="•"/>
             </a:pPr>
             <a:r>
-              <a:rPr lang="en-US" sz="1150" i="1" dirty="0">
+              <a:rPr lang="en-US" sz="1050" i="1" dirty="0">
                 <a:solidFill>
                   <a:srgbClr val="2E2119"/>
                 </a:solidFill>
@@ -7421,18 +7421,18 @@
               </a:rPr>
               <a:t>"Not knowing what the others want, the others eating my stuff"</a:t>
             </a:r>
-            <a:endParaRPr lang="en-US" sz="1150" dirty="0"/>
+            <a:endParaRPr lang="en-US" sz="1050" dirty="0"/>
           </a:p>
           <a:p>
             <a:pPr marL="342900" indent="-342900">
               <a:spcAft>
-                <a:spcPts val="800"/>
+                <a:spcPts val="700"/>
               </a:spcAft>
               <a:buSzPct val="100000"/>
               <a:buChar char="•"/>
             </a:pPr>
             <a:r>
-              <a:rPr lang="en-US" sz="1150" i="1" dirty="0">
+              <a:rPr lang="en-US" sz="1050" i="1" dirty="0">
                 <a:solidFill>
                   <a:srgbClr val="2E2119"/>
                 </a:solidFill>
@@ -7442,18 +7442,18 @@
               </a:rPr>
               <a:t>"When people use the food I planned to use in a meal for myself... so I have to use something else"</a:t>
             </a:r>
-            <a:endParaRPr lang="en-US" sz="1150" dirty="0"/>
+            <a:endParaRPr lang="en-US" sz="1050" dirty="0"/>
           </a:p>
           <a:p>
             <a:pPr marL="342900" indent="-342900">
               <a:spcAft>
-                <a:spcPts val="800"/>
+                <a:spcPts val="700"/>
               </a:spcAft>
               <a:buSzPct val="100000"/>
               <a:buChar char="•"/>
             </a:pPr>
             <a:r>
-              <a:rPr lang="en-US" sz="1150" i="1" dirty="0">
+              <a:rPr lang="en-US" sz="1050" i="1" dirty="0">
                 <a:solidFill>
                   <a:srgbClr val="2E2119"/>
                 </a:solidFill>
@@ -7463,18 +7463,18 @@
               </a:rPr>
               <a:t>"Not knowing if someone bought something just for themself"</a:t>
             </a:r>
-            <a:endParaRPr lang="en-US" sz="1150" dirty="0"/>
+            <a:endParaRPr lang="en-US" sz="1050" dirty="0"/>
           </a:p>
           <a:p>
             <a:pPr marL="342900" indent="-342900">
               <a:spcAft>
-                <a:spcPts val="800"/>
+                <a:spcPts val="700"/>
               </a:spcAft>
               <a:buSzPct val="100000"/>
               <a:buChar char="•"/>
             </a:pPr>
             <a:r>
-              <a:rPr lang="en-US" sz="1150" i="1" dirty="0">
+              <a:rPr lang="en-US" sz="1050" i="1" dirty="0">
                 <a:solidFill>
                   <a:srgbClr val="2E2119"/>
                 </a:solidFill>
@@ -7484,7 +7484,28 @@
               </a:rPr>
               <a:t>"Que compran cosas que no quiero"</a:t>
             </a:r>
-            <a:endParaRPr lang="en-US" sz="1150" dirty="0"/>
+            <a:endParaRPr lang="en-US" sz="1050" dirty="0"/>
+          </a:p>
+          <a:p>
+            <a:pPr marL="342900" indent="-342900">
+              <a:spcAft>
+                <a:spcPts val="700"/>
+              </a:spcAft>
+              <a:buSzPct val="100000"/>
+              <a:buChar char="•"/>
+            </a:pPr>
+            <a:r>
+              <a:rPr lang="en-US" sz="1050" i="1" dirty="0">
+                <a:solidFill>
+                  <a:srgbClr val="2E2119"/>
+                </a:solidFill>
+                <a:latin typeface="Calibri" pitchFamily="34" charset="0"/>
+                <a:ea typeface="Calibri" pitchFamily="34" charset="-122"/>
+                <a:cs typeface="Calibri" pitchFamily="34" charset="-120"/>
+              </a:rPr>
+              <a:t>"Cada vez una compra una cosa, lo complicado es llevar la cuenta de quién compró qué antes"</a:t>
+            </a:r>
+            <a:endParaRPr lang="en-US" sz="1050" dirty="0"/>
           </a:p>
         </p:txBody>
       </p:sp>
@@ -7589,7 +7610,7 @@
                 <a:ea typeface="Calibri" pitchFamily="34" charset="-122"/>
                 <a:cs typeface="Calibri" pitchFamily="34" charset="-120"/>
               </a:rPr>
-              <a:t>2 menciones espontáneas + 7/19 (37%) dice en la Pregunta 8 que no llevan cuenta</a:t>
+              <a:t>3 menciones espontáneas + 9/26 (35%) dice en la Pregunta 8 que no llevan cuenta</a:t>
             </a:r>
             <a:endParaRPr lang="en-US" sz="1050" dirty="0"/>
           </a:p>
@@ -7604,7 +7625,7 @@
         <p:spPr>
           <a:xfrm>
             <a:off x="6537960" y="2331720"/>
-            <a:ext cx="4846320" cy="1554480"/>
+            <a:ext cx="4846320" cy="1737360"/>
           </a:xfrm>
           <a:prstGeom prst="rect">
             <a:avLst/>
@@ -7618,13 +7639,13 @@
           <a:p>
             <a:pPr marL="342900" indent="-342900">
               <a:spcAft>
-                <a:spcPts val="1000"/>
+                <a:spcPts val="800"/>
               </a:spcAft>
               <a:buSzPct val="100000"/>
               <a:buChar char="•"/>
             </a:pPr>
             <a:r>
-              <a:rPr lang="en-US" sz="1200" i="1" dirty="0">
+              <a:rPr lang="en-US" sz="1100" i="1" dirty="0">
                 <a:solidFill>
                   <a:srgbClr val="2E2119"/>
                 </a:solidFill>
@@ -7634,18 +7655,18 @@
               </a:rPr>
               <a:t>"I don’t know who bought what" — también aquí: no saber quién pagó qué</a:t>
             </a:r>
-            <a:endParaRPr lang="en-US" sz="1200" dirty="0"/>
+            <a:endParaRPr lang="en-US" sz="1100" dirty="0"/>
           </a:p>
           <a:p>
             <a:pPr marL="342900" indent="-342900">
               <a:spcAft>
-                <a:spcPts val="1000"/>
+                <a:spcPts val="800"/>
               </a:spcAft>
               <a:buSzPct val="100000"/>
               <a:buChar char="•"/>
             </a:pPr>
             <a:r>
-              <a:rPr lang="en-US" sz="1200" i="1" dirty="0">
+              <a:rPr lang="en-US" sz="1100" i="1" dirty="0">
                 <a:solidFill>
                   <a:srgbClr val="2E2119"/>
                 </a:solidFill>
@@ -7655,7 +7676,28 @@
               </a:rPr>
               <a:t>"Que la gente no participe a la hora de hacer la compra o que tarden en pagar cuando dividimos gastos"</a:t>
             </a:r>
-            <a:endParaRPr lang="en-US" sz="1200" dirty="0"/>
+            <a:endParaRPr lang="en-US" sz="1100" dirty="0"/>
+          </a:p>
+          <a:p>
+            <a:pPr marL="342900" indent="-342900">
+              <a:spcAft>
+                <a:spcPts val="800"/>
+              </a:spcAft>
+              <a:buSzPct val="100000"/>
+              <a:buChar char="•"/>
+            </a:pPr>
+            <a:r>
+              <a:rPr lang="en-US" sz="1100" i="1" dirty="0">
+                <a:solidFill>
+                  <a:srgbClr val="2E2119"/>
+                </a:solidFill>
+                <a:latin typeface="Calibri" pitchFamily="34" charset="0"/>
+                <a:ea typeface="Calibri" pitchFamily="34" charset="-122"/>
+                <a:cs typeface="Calibri" pitchFamily="34" charset="-120"/>
+              </a:rPr>
+              <a:t>"Llevar la cuenta de quién compró qué antes" — también dual, coop + gasto</a:t>
+            </a:r>
+            <a:endParaRPr lang="en-US" sz="1100" dirty="0"/>
           </a:p>
         </p:txBody>
       </p:sp>
@@ -7667,12 +7709,12 @@
         </p:nvSpPr>
         <p:spPr>
           <a:xfrm>
-            <a:off x="6492240" y="3977640"/>
-            <a:ext cx="4892040" cy="1554480"/>
+            <a:off x="6492240" y="4160520"/>
+            <a:ext cx="4892040" cy="1371600"/>
           </a:xfrm>
           <a:prstGeom prst="roundRect">
             <a:avLst>
-              <a:gd name="adj" fmla="val 5882"/>
+              <a:gd name="adj" fmla="val 6667"/>
             </a:avLst>
           </a:prstGeom>
           <a:solidFill>
@@ -7689,8 +7731,8 @@
         </p:nvSpPr>
         <p:spPr>
           <a:xfrm>
-            <a:off x="6720840" y="4096512"/>
-            <a:ext cx="4480560" cy="1325880"/>
+            <a:off x="6720840" y="4279392"/>
+            <a:ext cx="4480560" cy="1143000"/>
           </a:xfrm>
           <a:prstGeom prst="rect">
             <a:avLst/>
@@ -7709,7 +7751,7 @@
               <a:buNone/>
             </a:pPr>
             <a:r>
-              <a:rPr lang="en-US" sz="1150" b="1" dirty="0">
+              <a:rPr lang="en-US" sz="1100" b="1" dirty="0">
                 <a:solidFill>
                   <a:srgbClr val="D9A441"/>
                 </a:solidFill>
@@ -7719,14 +7761,14 @@
               </a:rPr>
               <a:t>Esto es exactamente History:  </a:t>
             </a:r>
-            <a:endParaRPr lang="en-US" sz="1150" dirty="0"/>
-          </a:p>
-          <a:p>
-            <a:pPr indent="0" marL="0">
-              <a:buNone/>
-            </a:pPr>
-            <a:r>
-              <a:rPr lang="en-US" sz="1150" dirty="0">
+            <a:endParaRPr lang="en-US" sz="1100" dirty="0"/>
+          </a:p>
+          <a:p>
+            <a:pPr indent="0" marL="0">
+              <a:buNone/>
+            </a:pPr>
+            <a:r>
+              <a:rPr lang="en-US" sz="1100" dirty="0">
                 <a:solidFill>
                   <a:srgbClr val="FFFFFF"/>
                 </a:solidFill>
@@ -7736,7 +7778,7 @@
               </a:rPr>
               <a:t>quién compró qué y quién debe a quién, resuelto sin depender de que alguien lo recuerde o lo apunte a mano.</a:t>
             </a:r>
-            <a:endParaRPr lang="en-US" sz="1150" dirty="0"/>
+            <a:endParaRPr lang="en-US" sz="1100" dirty="0"/>
           </a:p>
         </p:txBody>
       </p:sp>
@@ -7792,7 +7834,7 @@
               <a:buNone/>
             </a:pPr>
             <a:r>
-              <a:rPr lang="en-US" sz="1150" b="1" dirty="0">
+              <a:rPr lang="en-US" sz="1100" b="1" dirty="0">
                 <a:solidFill>
                   <a:srgbClr val="C9682B"/>
                 </a:solidFill>
@@ -7800,13 +7842,13 @@
                 <a:ea typeface="Calibri" pitchFamily="34" charset="-122"/>
                 <a:cs typeface="Calibri" pitchFamily="34" charset="-120"/>
               </a:rPr>
-              <a:t>Señal nueva a vigilar (Fridge):  </a:t>
-            </a:r>
-            <a:pPr indent="0" marL="0">
-              <a:buNone/>
-            </a:pPr>
-            <a:r>
-              <a:rPr lang="en-US" sz="1150" dirty="0">
+              <a:t>Ya no es señal aislada — 4 menciones (Fridge):  </a:t>
+            </a:r>
+            <a:pPr indent="0" marL="0">
+              <a:buNone/>
+            </a:pPr>
+            <a:r>
+              <a:rPr lang="en-US" sz="1100" dirty="0">
                 <a:solidFill>
                   <a:srgbClr val="2E2119"/>
                 </a:solidFill>
@@ -7814,9 +7856,9 @@
                 <a:ea typeface="Calibri" pitchFamily="34" charset="-122"/>
                 <a:cs typeface="Calibri" pitchFamily="34" charset="-120"/>
               </a:rPr>
-              <a:t>"Tener en cuenta qué productos quedan abiertos, cuáles se pierden antes, etc." — apunta a caducidad y frescura, no solo a stock o reparto de gasto.</a:t>
-            </a:r>
-            <a:endParaRPr lang="en-US" sz="1150" dirty="0"/>
+              <a:t>"Pois supoño que cando algo se acabe ninguén avise" — describe el aviso de stock bajo que ya estaba en el alcance, sin que la persona lo supiera.</a:t>
+            </a:r>
+            <a:endParaRPr lang="en-US" sz="1100" dirty="0"/>
           </a:p>
         </p:txBody>
       </p:sp>

</xml_diff>

<commit_message>
Update survey validation to n=31
5 new responses, no duplicates this time. Notes retakes the lead over
Paper by a single response (12 vs 11) after Paper had overtaken it at
n=26 — documented as genuinely unstable at this sample size rather than
picking a winner. Duplicate/forgotten-trip percentages converged back to
74%/74% (statistical coincidence, already happened and unwound before).
Cooperation remains the most-repeated spontaneous complaint (8/31, 26%)
after two new matching quotes. Updated docs/ideacion.md, the results
artifact, and the two survey slides in the presentation.

Co-Authored-By: Claude Sonnet 5 <noreply@anthropic.com>
Claude-Session: https://claude.ai/code/session_012BwrUiCYr6ApYk5hmXyh4o
</commit_message>
<xml_diff>
--- a/docs/larder-presentacion.pptx
+++ b/docs/larder-presentacion.pptx
@@ -1040,7 +1040,7 @@
           <a:p>
             <a:r>
               <a:rPr lang="en-US" dirty="0"/>
-              <a:t>n=26 (2 envios duplicados por accidente descartados: "las cantidades" y la broma "Amor y Paz", cada par contado una vez). El dato que se mantiene y es mas fuerte que antes: 0/26 usa una app HOY como metodo (Pregunta 3) -- las 2 que probaron una app (Bring!, "Notas") la abandonaron. Quien probo Bring lo explica el mismo: fallo por falta de cooperacion de sus companeros de piso. Con mas muestra, "duplico" (73%) y "olvido" (81%) ya no coinciden como antes -- es lo esperable, no una senal de manipulacion. El dato conjunto (58%, 15/26) sigue subiendo. Aparecen por primera vez 2 personas en el bucket "mas de 5 viajes olvidados".</a:t>
+              <a:t>n=31 (2 envios duplicados por accidente descartados: "las cantidades" y la broma "Amor y Paz", cada par contado una vez). El dato que se mantiene y es mas fuerte que antes: 0/31 usa una app HOY como metodo (Pregunta 3) -- las 2 que probaron una app (Bring!, "Notas") la abandonaron. El "metodo ganador" (Papel vs Notas) sigue cambiando de lider con cada tanda -- ahora Notas por 1 respuesta -- es deliberadamente inestable, no se afirma un ganador. "Duplico" y "olvido" han vuelto a coincidir en 74% -- es casualidad estadistica, ya paso antes y se deshizo. El dato conjunto (55%, 17/31) se mantiene claramente por encima de la mitad.</a:t>
             </a:r>
             <a:endParaRPr lang="en-US" dirty="0"/>
           </a:p>
@@ -1128,7 +1128,7 @@
           <a:p>
             <a:r>
               <a:rPr lang="en-US" dirty="0"/>
-              <a:t>Actualizado a n=26 (2 duplicados por envio accidental descartados). Categorizacion: "no se quien compro que" y "llevar la cuenta de quien compro que antes" cuentan para AMBAS columnas (coop + tracker de gastos), "no saber que quieren los otros"/"comen mis cosas"/"compran cosas que no quiero" es coop puro, "no participan/tardan en pagar" es tracker de gastos puro. Cambio importante en esta tanda: la queja de caducidad/comida que se estropea paso de 1 mencion aislada a 4 menciones independientes -- ya es el segundo tema mas repetido despues de cooperacion, y una de ellas describe literalmente el "aviso de stock bajo" que ya estaba en el alcance de Fridge (documento de una pagina). Las menciones de precio (2, "esta todo carisimo"/"comprar es caro") siguen fuera de esta diapositiva por espacio -- estan en ideacion.md.</a:t>
+              <a:t>Actualizado a n=31 (2 duplicados por envio accidental descartados). Categorizacion: "no se quien compro que" y "llevar la cuenta de quien compro que antes" cuentan para AMBAS columnas (coop + tracker de gastos), "no saber que quieren los otros"/"comen mis cosas"/"compran cosas que no quiero"/"people eating my food"/"dudar en comprar algo y que se lo coma otro" es coop puro, "no participan/tardan en pagar" es tracker de gastos puro. Cooperacion sigue siendo el tema mas repetido con diferencia (8/31, 26%) tras 2 menciones nuevas en esta tanda. La queja de caducidad/comida que se estropea se mantiene en 4 menciones independientes -- segundo tema mas repetido, una de ellas describe literalmente el "aviso de stock bajo" que ya estaba en el alcance de Fridge. Las menciones de precio (2) siguen fuera de esta diapositiva por espacio -- estan en ideacion.md.</a:t>
             </a:r>
             <a:endParaRPr lang="en-US" dirty="0"/>
           </a:p>
@@ -5896,7 +5896,7 @@
                 <a:ea typeface="Cambria" pitchFamily="34" charset="-122"/>
                 <a:cs typeface="Cambria" pitchFamily="34" charset="-120"/>
               </a:rPr>
-              <a:t>La encuesta confirma el hueco (n=26)</a:t>
+              <a:t>La encuesta confirma el hueco (n=31)</a:t>
             </a:r>
             <a:endParaRPr lang="en-US" sz="2800" dirty="0"/>
           </a:p>
@@ -5935,7 +5935,7 @@
                 <a:ea typeface="Calibri" pitchFamily="34" charset="-122"/>
                 <a:cs typeface="Calibri" pitchFamily="34" charset="-120"/>
               </a:rPr>
-              <a:t>Encuesta bilingüe (ES/EN), 9 preguntas sobre hechos del último mes — no opiniones sobre una app futura. 26 respuestas únicas (2 envíos duplicados por accidente, descartados).</a:t>
+              <a:t>Encuesta bilingüe (ES/EN), 9 preguntas sobre hechos del último mes — no opiniones sobre una app futura. 31 respuestas únicas (2 envíos duplicados por accidente, descartados).</a:t>
             </a:r>
             <a:endParaRPr lang="en-US" sz="1000" dirty="0"/>
           </a:p>
@@ -5996,7 +5996,7 @@
                 <a:ea typeface="Cambria" pitchFamily="34" charset="-122"/>
                 <a:cs typeface="Cambria" pitchFamily="34" charset="-120"/>
               </a:rPr>
-              <a:t>0/26</a:t>
+              <a:t>0/31</a:t>
             </a:r>
             <a:endParaRPr lang="en-US" sz="3000" dirty="0"/>
           </a:p>
@@ -6096,7 +6096,7 @@
                 <a:ea typeface="Cambria" pitchFamily="34" charset="-122"/>
                 <a:cs typeface="Cambria" pitchFamily="34" charset="-120"/>
               </a:rPr>
-              <a:t>73%</a:t>
+              <a:t>74%</a:t>
             </a:r>
             <a:endParaRPr lang="en-US" sz="3000" dirty="0"/>
           </a:p>
@@ -6196,7 +6196,7 @@
                 <a:ea typeface="Cambria" pitchFamily="34" charset="-122"/>
                 <a:cs typeface="Cambria" pitchFamily="34" charset="-120"/>
               </a:rPr>
-              <a:t>81%</a:t>
+              <a:t>74%</a:t>
             </a:r>
             <a:endParaRPr lang="en-US" sz="3000" dirty="0"/>
           </a:p>
@@ -6274,7 +6274,7 @@
                 <a:ea typeface="Calibri" pitchFamily="34" charset="-122"/>
                 <a:cs typeface="Calibri" pitchFamily="34" charset="-120"/>
               </a:rPr>
-              <a:t>El 58% (15 de 26 personas) sufrió ambas cosas — compró duplicado y volvió a la tienda — en el mismo mes.</a:t>
+              <a:t>El 55% (17 de 31 personas) sufrió ambas cosas — compró duplicado y volvió a la tienda — en el mismo mes.</a:t>
             </a:r>
             <a:endParaRPr lang="en-US" sz="1150" dirty="0"/>
           </a:p>
@@ -6381,7 +6381,7 @@
                 <a:ea typeface="Calibri" pitchFamily="34" charset="-122"/>
                 <a:cs typeface="Calibri" pitchFamily="34" charset="-120"/>
               </a:rPr>
-              <a:t>Papel y boli</a:t>
+              <a:t>Notas del móvil</a:t>
             </a:r>
             <a:endParaRPr lang="en-US" sz="1100" dirty="0"/>
           </a:p>
@@ -6426,7 +6426,7 @@
             </a:avLst>
           </a:prstGeom>
           <a:solidFill>
-            <a:srgbClr val="C9682B"/>
+            <a:srgbClr val="D9A441"/>
           </a:solidFill>
           <a:ln/>
         </p:spPr>
@@ -6464,7 +6464,7 @@
                 <a:ea typeface="Calibri" pitchFamily="34" charset="-122"/>
                 <a:cs typeface="Calibri" pitchFamily="34" charset="-120"/>
               </a:rPr>
-              <a:t>11</a:t>
+              <a:t>12</a:t>
             </a:r>
             <a:endParaRPr lang="en-US" sz="1100" dirty="0"/>
           </a:p>
@@ -6503,7 +6503,7 @@
                 <a:ea typeface="Calibri" pitchFamily="34" charset="-122"/>
                 <a:cs typeface="Calibri" pitchFamily="34" charset="-120"/>
               </a:rPr>
-              <a:t>Notas del móvil</a:t>
+              <a:t>Papel y boli</a:t>
             </a:r>
             <a:endParaRPr lang="en-US" sz="1100" dirty="0"/>
           </a:p>
@@ -6540,7 +6540,7 @@
         <p:spPr>
           <a:xfrm>
             <a:off x="2788920" y="3986784"/>
-            <a:ext cx="2593571" cy="219456"/>
+            <a:ext cx="3268980" cy="219456"/>
           </a:xfrm>
           <a:prstGeom prst="roundRect">
             <a:avLst>
@@ -6548,7 +6548,7 @@
             </a:avLst>
           </a:prstGeom>
           <a:solidFill>
-            <a:srgbClr val="D9A441"/>
+            <a:srgbClr val="C9682B"/>
           </a:solidFill>
           <a:ln/>
         </p:spPr>
@@ -6586,7 +6586,7 @@
                 <a:ea typeface="Calibri" pitchFamily="34" charset="-122"/>
                 <a:cs typeface="Calibri" pitchFamily="34" charset="-120"/>
               </a:rPr>
-              <a:t>8</a:t>
+              <a:t>11</a:t>
             </a:r>
             <a:endParaRPr lang="en-US" sz="1100" dirty="0"/>
           </a:p>
@@ -6662,7 +6662,7 @@
         <p:spPr>
           <a:xfrm>
             <a:off x="2788920" y="4297680"/>
-            <a:ext cx="1945178" cy="219456"/>
+            <a:ext cx="2080260" cy="219456"/>
           </a:xfrm>
           <a:prstGeom prst="roundRect">
             <a:avLst>
@@ -6708,7 +6708,7 @@
                 <a:ea typeface="Calibri" pitchFamily="34" charset="-122"/>
                 <a:cs typeface="Calibri" pitchFamily="34" charset="-120"/>
               </a:rPr>
-              <a:t>6</a:t>
+              <a:t>7</a:t>
             </a:r>
             <a:endParaRPr lang="en-US" sz="1100" dirty="0"/>
           </a:p>
@@ -6784,7 +6784,7 @@
         <p:spPr>
           <a:xfrm>
             <a:off x="2788920" y="4608576"/>
-            <a:ext cx="324196" cy="219456"/>
+            <a:ext cx="297180" cy="219456"/>
           </a:xfrm>
           <a:prstGeom prst="roundRect">
             <a:avLst>
@@ -6969,7 +6969,7 @@
                 <a:ea typeface="Calibri" pitchFamily="34" charset="-122"/>
                 <a:cs typeface="Calibri" pitchFamily="34" charset="-120"/>
               </a:rPr>
-              <a:t>↑ 2 personas la probaron alguna vez (Pregunta 7) — pero 0/26 la usa hoy: la abandonaron</a:t>
+              <a:t>↑ 2 personas la probaron alguna vez (Pregunta 7) — pero 0/31 la usa hoy: la abandonaron</a:t>
             </a:r>
             <a:endParaRPr lang="en-US" sz="950" dirty="0"/>
           </a:p>
@@ -7055,7 +7055,7 @@
                 <a:ea typeface="Calibri" pitchFamily="34" charset="-122"/>
                 <a:cs typeface="Calibri" pitchFamily="34" charset="-120"/>
               </a:rPr>
-              <a:t>Bring! y AnyList llevan años disponibles y son razonablemente buenas (estado del arte, diapositiva anterior). 2 de 26 personas confirman haberlas probado — pero ninguna las usa hoy. Quien probó Bring! lo explica sin que se le pregunte: "porque si no colaboran los demás... pues mal vamos". El hueco no está en construir "una app más" — está en resolver por qué las que existen no retienen ni a quien sí las prueba.</a:t>
+              <a:t>Bring! y AnyList llevan años disponibles y son razonablemente buenas (estado del arte, diapositiva anterior). 2 de 31 personas confirman haberlas probado — pero ninguna las usa hoy. Quien probó Bring! lo explica sin que se le pregunte: "porque si no colaboran los demás... pues mal vamos". El hueco no está en construir "una app más" — está en resolver por qué las que existen no retienen ni a quien sí las prueba.</a:t>
             </a:r>
             <a:endParaRPr lang="en-US" sz="1150" dirty="0"/>
           </a:p>
@@ -7355,7 +7355,7 @@
                 <a:ea typeface="Calibri" pitchFamily="34" charset="-122"/>
                 <a:cs typeface="Calibri" pitchFamily="34" charset="-120"/>
               </a:rPr>
-              <a:t>6 de 26 personas (23%) — sin que se les preguntara</a:t>
+              <a:t>8 de 31 personas (26%) — el tema más repetido, sin que se les preguntara</a:t>
             </a:r>
             <a:endParaRPr lang="en-US" sz="1050" dirty="0"/>
           </a:p>
@@ -7390,7 +7390,7 @@
               <a:buChar char="•"/>
             </a:pPr>
             <a:r>
-              <a:rPr lang="en-US" sz="1050" i="1" dirty="0">
+              <a:rPr lang="en-US" sz="1000" i="1" dirty="0">
                 <a:solidFill>
                   <a:srgbClr val="2E2119"/>
                 </a:solidFill>
@@ -7400,7 +7400,7 @@
               </a:rPr>
               <a:t>"I don’t know who bought what"</a:t>
             </a:r>
-            <a:endParaRPr lang="en-US" sz="1050" dirty="0"/>
+            <a:endParaRPr lang="en-US" sz="1000" dirty="0"/>
           </a:p>
           <a:p>
             <a:pPr marL="342900" indent="-342900">
@@ -7411,7 +7411,7 @@
               <a:buChar char="•"/>
             </a:pPr>
             <a:r>
-              <a:rPr lang="en-US" sz="1050" i="1" dirty="0">
+              <a:rPr lang="en-US" sz="1000" i="1" dirty="0">
                 <a:solidFill>
                   <a:srgbClr val="2E2119"/>
                 </a:solidFill>
@@ -7419,9 +7419,9 @@
                 <a:ea typeface="Calibri" pitchFamily="34" charset="-122"/>
                 <a:cs typeface="Calibri" pitchFamily="34" charset="-120"/>
               </a:rPr>
-              <a:t>"Not knowing what the others want, the others eating my stuff"</a:t>
-            </a:r>
-            <a:endParaRPr lang="en-US" sz="1050" dirty="0"/>
+              <a:t>"Not knowing what the others want, the others eating my stuff" / "People eating my food"</a:t>
+            </a:r>
+            <a:endParaRPr lang="en-US" sz="1000" dirty="0"/>
           </a:p>
           <a:p>
             <a:pPr marL="342900" indent="-342900">
@@ -7432,7 +7432,7 @@
               <a:buChar char="•"/>
             </a:pPr>
             <a:r>
-              <a:rPr lang="en-US" sz="1050" i="1" dirty="0">
+              <a:rPr lang="en-US" sz="1000" i="1" dirty="0">
                 <a:solidFill>
                   <a:srgbClr val="2E2119"/>
                 </a:solidFill>
@@ -7442,7 +7442,7 @@
               </a:rPr>
               <a:t>"When people use the food I planned to use in a meal for myself... so I have to use something else"</a:t>
             </a:r>
-            <a:endParaRPr lang="en-US" sz="1050" dirty="0"/>
+            <a:endParaRPr lang="en-US" sz="1000" dirty="0"/>
           </a:p>
           <a:p>
             <a:pPr marL="342900" indent="-342900">
@@ -7453,7 +7453,7 @@
               <a:buChar char="•"/>
             </a:pPr>
             <a:r>
-              <a:rPr lang="en-US" sz="1050" i="1" dirty="0">
+              <a:rPr lang="en-US" sz="1000" i="1" dirty="0">
                 <a:solidFill>
                   <a:srgbClr val="2E2119"/>
                 </a:solidFill>
@@ -7461,9 +7461,9 @@
                 <a:ea typeface="Calibri" pitchFamily="34" charset="-122"/>
                 <a:cs typeface="Calibri" pitchFamily="34" charset="-120"/>
               </a:rPr>
-              <a:t>"Not knowing if someone bought something just for themself"</a:t>
-            </a:r>
-            <a:endParaRPr lang="en-US" sz="1050" dirty="0"/>
+              <a:t>"Not knowing if someone bought something just for themself" / dudar en comprar algo "y que se lo coma otra persona"</a:t>
+            </a:r>
+            <a:endParaRPr lang="en-US" sz="1000" dirty="0"/>
           </a:p>
           <a:p>
             <a:pPr marL="342900" indent="-342900">
@@ -7474,7 +7474,7 @@
               <a:buChar char="•"/>
             </a:pPr>
             <a:r>
-              <a:rPr lang="en-US" sz="1050" i="1" dirty="0">
+              <a:rPr lang="en-US" sz="1000" i="1" dirty="0">
                 <a:solidFill>
                   <a:srgbClr val="2E2119"/>
                 </a:solidFill>
@@ -7484,7 +7484,7 @@
               </a:rPr>
               <a:t>"Que compran cosas que no quiero"</a:t>
             </a:r>
-            <a:endParaRPr lang="en-US" sz="1050" dirty="0"/>
+            <a:endParaRPr lang="en-US" sz="1000" dirty="0"/>
           </a:p>
           <a:p>
             <a:pPr marL="342900" indent="-342900">
@@ -7495,7 +7495,7 @@
               <a:buChar char="•"/>
             </a:pPr>
             <a:r>
-              <a:rPr lang="en-US" sz="1050" i="1" dirty="0">
+              <a:rPr lang="en-US" sz="1000" i="1" dirty="0">
                 <a:solidFill>
                   <a:srgbClr val="2E2119"/>
                 </a:solidFill>
@@ -7505,7 +7505,7 @@
               </a:rPr>
               <a:t>"Cada vez una compra una cosa, lo complicado es llevar la cuenta de quién compró qué antes"</a:t>
             </a:r>
-            <a:endParaRPr lang="en-US" sz="1050" dirty="0"/>
+            <a:endParaRPr lang="en-US" sz="1000" dirty="0"/>
           </a:p>
         </p:txBody>
       </p:sp>
@@ -7610,7 +7610,7 @@
                 <a:ea typeface="Calibri" pitchFamily="34" charset="-122"/>
                 <a:cs typeface="Calibri" pitchFamily="34" charset="-120"/>
               </a:rPr>
-              <a:t>3 menciones espontáneas + 9/26 (35%) dice en la Pregunta 8 que no llevan cuenta</a:t>
+              <a:t>3 menciones espontáneas + 12/31 (39%) dice en la Pregunta 8 que no llevan cuenta</a:t>
             </a:r>
             <a:endParaRPr lang="en-US" sz="1050" dirty="0"/>
           </a:p>

</xml_diff>

<commit_message>
Close the survey and lock final results at n=32
One last response arrived (17/09) and is included. The survey is now
marked closed/final everywhere (docs/ideacion.md, the results artifact,
and the two survey slides in the presentation) instead of "updates as
more arrive" — this is the dataset used for the delivery. Papel/Notas
never settled on a leader across the whole collection (documented as a
technical tie, not a finding); the joint pain stat (both duplicated AND
forgot something) stayed stable above half across the last three batches
(58% -> 55% -> 53%), the strongest signal in the whole survey.

Co-Authored-By: Claude Sonnet 5 <noreply@anthropic.com>
Claude-Session: https://claude.ai/code/session_012BwrUiCYr6ApYk5hmXyh4o
</commit_message>
<xml_diff>
--- a/docs/larder-presentacion.pptx
+++ b/docs/larder-presentacion.pptx
@@ -1040,7 +1040,7 @@
           <a:p>
             <a:r>
               <a:rPr lang="en-US" dirty="0"/>
-              <a:t>n=31 (2 envios duplicados por accidente descartados: "las cantidades" y la broma "Amor y Paz", cada par contado una vez). El dato que se mantiene y es mas fuerte que antes: 0/31 usa una app HOY como metodo (Pregunta 3) -- las 2 que probaron una app (Bring!, "Notas") la abandonaron. El "metodo ganador" (Papel vs Notas) sigue cambiando de lider con cada tanda -- ahora Notas por 1 respuesta -- es deliberadamente inestable, no se afirma un ganador. "Duplico" y "olvido" han vuelto a coincidir en 74% -- es casualidad estadistica, ya paso antes y se deshizo. El dato conjunto (55%, 17/31) se mantiene claramente por encima de la mitad.</a:t>
+              <a:t>RESULTADOS FINALES -- encuesta cerrada el 17/09/2026, n=32 (2 envios duplicados por accidente descartados: "las cantidades" y la broma "Amor y Paz", cada par contado una vez). El dato mas fuerte de toda la encuesta: 0/32 usa una app HOY como metodo (Pregunta 3) -- las 2 que probaron una app (Bring!, "Notas") la abandonaron, sin excepcion, en las 4 tandas de la recogida. El "metodo ganador" (Papel vs Notas) nunca se asento -- cambio de lider en cada tanda por 1-2 respuestas -- es un empate tecnico, se documenta asi en vez de forzar un ganador. El dato conjunto (53%, 17/32) se mantuvo estable por encima de la mitad en las ultimas tres tandas (58%-&gt;55%-&gt;53%) -- la senal mas solida de toda la encuesta.</a:t>
             </a:r>
             <a:endParaRPr lang="en-US" dirty="0"/>
           </a:p>
@@ -1128,7 +1128,7 @@
           <a:p>
             <a:r>
               <a:rPr lang="en-US" dirty="0"/>
-              <a:t>Actualizado a n=31 (2 duplicados por envio accidental descartados). Categorizacion: "no se quien compro que" y "llevar la cuenta de quien compro que antes" cuentan para AMBAS columnas (coop + tracker de gastos), "no saber que quieren los otros"/"comen mis cosas"/"compran cosas que no quiero"/"people eating my food"/"dudar en comprar algo y que se lo coma otro" es coop puro, "no participan/tardan en pagar" es tracker de gastos puro. Cooperacion sigue siendo el tema mas repetido con diferencia (8/31, 26%) tras 2 menciones nuevas en esta tanda. La queja de caducidad/comida que se estropea se mantiene en 4 menciones independientes -- segundo tema mas repetido, una de ellas describe literalmente el "aviso de stock bajo" que ya estaba en el alcance de Fridge. Las menciones de precio (2) siguen fuera de esta diapositiva por espacio -- estan en ideacion.md.</a:t>
+              <a:t>RESULTADOS FINALES, n=32 (encuesta cerrada 17/09/2026; 2 duplicados por envio accidental descartados). Categorizacion: "no se quien compro que" y "llevar la cuenta de quien compro que antes" cuentan para AMBAS columnas (coop + tracker de gastos), "no saber que quieren los otros"/"comen mis cosas"/"compran cosas que no quiero"/"people eating my food"/"dudar en comprar algo y que se lo coma otro" es coop puro, "no participan/tardan en pagar" es tracker de gastos puro. Cooperacion termino como el tema mas repetido con diferencia (8/32, 25%) en toda la recogida. La queja de caducidad/comida que se estropea se mantiene en 4 menciones independientes -- segundo tema mas repetido, una de ellas describe literalmente el "aviso de stock bajo" que ya estaba en el alcance de Fridge. Las menciones de precio (2) siguen fuera de esta diapositiva por espacio -- estan en ideacion.md. La ultima respuesta (n=32) no aporto cita nueva (frustracion: "nada").</a:t>
             </a:r>
             <a:endParaRPr lang="en-US" dirty="0"/>
           </a:p>
@@ -5896,7 +5896,7 @@
                 <a:ea typeface="Cambria" pitchFamily="34" charset="-122"/>
                 <a:cs typeface="Cambria" pitchFamily="34" charset="-120"/>
               </a:rPr>
-              <a:t>La encuesta confirma el hueco (n=31)</a:t>
+              <a:t>La encuesta confirma el hueco (n=32, cerrada)</a:t>
             </a:r>
             <a:endParaRPr lang="en-US" sz="2800" dirty="0"/>
           </a:p>
@@ -5935,7 +5935,7 @@
                 <a:ea typeface="Calibri" pitchFamily="34" charset="-122"/>
                 <a:cs typeface="Calibri" pitchFamily="34" charset="-120"/>
               </a:rPr>
-              <a:t>Encuesta bilingüe (ES/EN), 9 preguntas sobre hechos del último mes — no opiniones sobre una app futura. 31 respuestas únicas (2 envíos duplicados por accidente, descartados).</a:t>
+              <a:t>Encuesta bilingüe (ES/EN), 9 preguntas sobre hechos del último mes — no opiniones sobre una app futura. Resultados finales: 32 respuestas únicas, cerrada el 17/09/2026.</a:t>
             </a:r>
             <a:endParaRPr lang="en-US" sz="1000" dirty="0"/>
           </a:p>
@@ -5996,7 +5996,7 @@
                 <a:ea typeface="Cambria" pitchFamily="34" charset="-122"/>
                 <a:cs typeface="Cambria" pitchFamily="34" charset="-120"/>
               </a:rPr>
-              <a:t>0/31</a:t>
+              <a:t>0/32</a:t>
             </a:r>
             <a:endParaRPr lang="en-US" sz="3000" dirty="0"/>
           </a:p>
@@ -6096,7 +6096,7 @@
                 <a:ea typeface="Cambria" pitchFamily="34" charset="-122"/>
                 <a:cs typeface="Cambria" pitchFamily="34" charset="-120"/>
               </a:rPr>
-              <a:t>74%</a:t>
+              <a:t>72%</a:t>
             </a:r>
             <a:endParaRPr lang="en-US" sz="3000" dirty="0"/>
           </a:p>
@@ -6196,7 +6196,7 @@
                 <a:ea typeface="Cambria" pitchFamily="34" charset="-122"/>
                 <a:cs typeface="Cambria" pitchFamily="34" charset="-120"/>
               </a:rPr>
-              <a:t>74%</a:t>
+              <a:t>75%</a:t>
             </a:r>
             <a:endParaRPr lang="en-US" sz="3000" dirty="0"/>
           </a:p>
@@ -6274,7 +6274,7 @@
                 <a:ea typeface="Calibri" pitchFamily="34" charset="-122"/>
                 <a:cs typeface="Calibri" pitchFamily="34" charset="-120"/>
               </a:rPr>
-              <a:t>El 55% (17 de 31 personas) sufrió ambas cosas — compró duplicado y volvió a la tienda — en el mismo mes.</a:t>
+              <a:t>El 53% (17 de 32 personas) sufrió ambas cosas — compró duplicado y volvió a la tienda — en el mismo mes.</a:t>
             </a:r>
             <a:endParaRPr lang="en-US" sz="1150" dirty="0"/>
           </a:p>
@@ -6662,7 +6662,7 @@
         <p:spPr>
           <a:xfrm>
             <a:off x="2788920" y="4297680"/>
-            <a:ext cx="2080260" cy="219456"/>
+            <a:ext cx="2377440" cy="219456"/>
           </a:xfrm>
           <a:prstGeom prst="roundRect">
             <a:avLst>
@@ -6708,7 +6708,7 @@
                 <a:ea typeface="Calibri" pitchFamily="34" charset="-122"/>
                 <a:cs typeface="Calibri" pitchFamily="34" charset="-120"/>
               </a:rPr>
-              <a:t>7</a:t>
+              <a:t>8</a:t>
             </a:r>
             <a:endParaRPr lang="en-US" sz="1100" dirty="0"/>
           </a:p>
@@ -6969,7 +6969,7 @@
                 <a:ea typeface="Calibri" pitchFamily="34" charset="-122"/>
                 <a:cs typeface="Calibri" pitchFamily="34" charset="-120"/>
               </a:rPr>
-              <a:t>↑ 2 personas la probaron alguna vez (Pregunta 7) — pero 0/31 la usa hoy: la abandonaron</a:t>
+              <a:t>↑ 2 personas la probaron alguna vez (Pregunta 7) — pero 0/32 la usa hoy: la abandonaron</a:t>
             </a:r>
             <a:endParaRPr lang="en-US" sz="950" dirty="0"/>
           </a:p>
@@ -7055,7 +7055,7 @@
                 <a:ea typeface="Calibri" pitchFamily="34" charset="-122"/>
                 <a:cs typeface="Calibri" pitchFamily="34" charset="-120"/>
               </a:rPr>
-              <a:t>Bring! y AnyList llevan años disponibles y son razonablemente buenas (estado del arte, diapositiva anterior). 2 de 31 personas confirman haberlas probado — pero ninguna las usa hoy. Quien probó Bring! lo explica sin que se le pregunte: "porque si no colaboran los demás... pues mal vamos". El hueco no está en construir "una app más" — está en resolver por qué las que existen no retienen ni a quien sí las prueba.</a:t>
+              <a:t>Bring! y AnyList llevan años disponibles y son razonablemente buenas (estado del arte, diapositiva anterior). 2 de 32 personas confirman haberlas probado — pero ninguna las usa hoy. Quien probó Bring! lo explica sin que se le pregunte: "porque si no colaboran los demás... pues mal vamos". El hueco no está en construir "una app más" — está en resolver por qué las que existen no retienen ni a quien sí las prueba.</a:t>
             </a:r>
             <a:endParaRPr lang="en-US" sz="1150" dirty="0"/>
           </a:p>
@@ -7355,7 +7355,7 @@
                 <a:ea typeface="Calibri" pitchFamily="34" charset="-122"/>
                 <a:cs typeface="Calibri" pitchFamily="34" charset="-120"/>
               </a:rPr>
-              <a:t>8 de 31 personas (26%) — el tema más repetido, sin que se les preguntara</a:t>
+              <a:t>8 de 32 personas (25%) — el tema más repetido, sin que se les preguntara</a:t>
             </a:r>
             <a:endParaRPr lang="en-US" sz="1050" dirty="0"/>
           </a:p>
@@ -7610,7 +7610,7 @@
                 <a:ea typeface="Calibri" pitchFamily="34" charset="-122"/>
                 <a:cs typeface="Calibri" pitchFamily="34" charset="-120"/>
               </a:rPr>
-              <a:t>3 menciones espontáneas + 12/31 (39%) dice en la Pregunta 8 que no llevan cuenta</a:t>
+              <a:t>3 menciones espontáneas + 12/32 (38%) dice en la Pregunta 8 que no llevan cuenta</a:t>
             </a:r>
             <a:endParaRPr lang="en-US" sz="1050" dirty="0"/>
           </a:p>

</xml_diff>

<commit_message>
Simplify the estado-del-arte slide: drop the two cringe callouts
Removed the Bring! Apple Watch review quote (real but irrelevant to the
argument) and the "Out of Milk" AI-retraction note (already documented in
ideacion.md and bitacora-ia.md, didn't need duplicating on the slide
itself). Replaced both with the actual reasoning for why the research
moved from reviews to direct conversations: good reviews don't reveal a
gap, bad ones were compatibility complaints rather than product feedback.

Co-Authored-By: Claude Sonnet 5 <noreply@anthropic.com>
Claude-Session: https://claude.ai/code/session_012BwrUiCYr6ApYk5hmXyh4o
</commit_message>
<xml_diff>
--- a/docs/larder-presentacion.pptx
+++ b/docs/larder-presentacion.pptx
@@ -953,7 +953,7 @@
           <a:p>
             <a:r>
               <a:rPr lang="en-US" dirty="0"/>
-              <a:t>La fuente principal ya no es busqueda por IA sino conversaciones reales con estudiantes/gente joven que comparten piso (mismo perfil que el mercado objetivo). AnyList tiene reconocimiento inteligente al escribir y codigo de barras -casi tan rapido como Notas-, pero todo su valor extra apunta a cocinar. La fila de Out of Milk se genero con IA (IA-2) y no se pudo verificar como app real: se documenta la retractacion en vez de ocultarla.</a:t>
+              <a:t>Diapositiva simplificada 17/09: se quito la cita de Bring! sobre el Apple Watch (real pero irrelevante para el argumento, quedaba "cringe") y la nota de correccion de "Out of Milk" (queda documentada en ideacion.md y en la bitacora de IA, no hacia falta duplicarla en la diapositiva). En su lugar, el razonamiento real de por que se paso de resenas a conversaciones directas: buenas resenas no sirven para encontrar el hueco, malas resenas eran solo compatibilidad tecnica, no quejas de producto.</a:t>
             </a:r>
             <a:endParaRPr lang="en-US" dirty="0"/>
           </a:p>
@@ -5926,11 +5926,11 @@
         <p:spPr>
           <a:xfrm>
             <a:off x="548640" y="3977640"/>
-            <a:ext cx="11064240" cy="1280160"/>
+            <a:ext cx="11064240" cy="2423160"/>
           </a:xfrm>
           <a:prstGeom prst="roundRect">
             <a:avLst>
-              <a:gd name="adj" fmla="val 8571"/>
+              <a:gd name="adj" fmla="val 4528"/>
             </a:avLst>
           </a:prstGeom>
           <a:solidFill>
@@ -5954,8 +5954,8 @@
         </p:nvSpPr>
         <p:spPr>
           <a:xfrm>
-            <a:off x="777240" y="4096512"/>
-            <a:ext cx="5486400" cy="274320"/>
+            <a:off x="777240" y="4160520"/>
+            <a:ext cx="10607040" cy="320040"/>
           </a:xfrm>
           <a:prstGeom prst="rect">
             <a:avLst/>
@@ -5971,7 +5971,7 @@
               <a:buNone/>
             </a:pPr>
             <a:r>
-              <a:rPr lang="en-US" sz="1100" b="1" spc="100" kern="0" dirty="0">
+              <a:rPr lang="en-US" sz="1300" b="1" dirty="0">
                 <a:solidFill>
                   <a:srgbClr val="C9682B"/>
                 </a:solidFill>
@@ -5979,9 +5979,9 @@
                 <a:ea typeface="Calibri" pitchFamily="34" charset="-122"/>
                 <a:cs typeface="Calibri" pitchFamily="34" charset="-120"/>
               </a:rPr>
-              <a:t>Cita literal verificada (fuente secundaria)</a:t>
-            </a:r>
-            <a:endParaRPr lang="en-US" sz="1100" dirty="0"/>
+              <a:t>Por qué no nos basamos en reseñas de las apps</a:t>
+            </a:r>
+            <a:endParaRPr lang="en-US" sz="1300" dirty="0"/>
           </a:p>
         </p:txBody>
       </p:sp>
@@ -5993,24 +5993,27 @@
         </p:nvSpPr>
         <p:spPr>
           <a:xfrm>
-            <a:off x="777240" y="4370832"/>
-            <a:ext cx="10607040" cy="502920"/>
-          </a:xfrm>
-          <a:prstGeom prst="rect">
-            <a:avLst/>
-          </a:prstGeom>
-          <a:noFill/>
-          <a:ln/>
-        </p:spPr>
-        <p:txBody>
-          <a:bodyPr wrap="square" lIns="0" tIns="0" rIns="0" bIns="0" rtlCol="0" anchor="ctr"/>
-          <a:lstStyle/>
-          <a:p>
-            <a:pPr indent="0" marL="0">
-              <a:buNone/>
-            </a:pPr>
-            <a:r>
-              <a:rPr lang="en-US" sz="1250" i="1" dirty="0">
+            <a:off x="777240" y="4526280"/>
+            <a:ext cx="10607040" cy="1783080"/>
+          </a:xfrm>
+          <a:prstGeom prst="rect">
+            <a:avLst/>
+          </a:prstGeom>
+          <a:noFill/>
+          <a:ln/>
+        </p:spPr>
+        <p:txBody>
+          <a:bodyPr wrap="square" lIns="0" tIns="0" rIns="0" bIns="0" rtlCol="0" anchor="t"/>
+          <a:lstStyle/>
+          <a:p>
+            <a:pPr indent="0" marL="0">
+              <a:spcAft>
+                <a:spcPts val="800"/>
+              </a:spcAft>
+              <a:buNone/>
+            </a:pPr>
+            <a:r>
+              <a:rPr lang="en-US" sz="1250" dirty="0">
                 <a:solidFill>
                   <a:srgbClr val="2E2119"/>
                 </a:solidFill>
@@ -6018,118 +6021,19 @@
                 <a:ea typeface="Calibri" pitchFamily="34" charset="-122"/>
                 <a:cs typeface="Calibri" pitchFamily="34" charset="-120"/>
               </a:rPr>
-              <a:t>"El icono de la aplicación aparece marcado como comprado en el Apple Watch pero no llega a descargarse ni a instalarse."</a:t>
+              <a:t>Las reseñas buenas no sirven para encontrar un hueco — obviamente no hablan de lo que falta. </a:t>
             </a:r>
             <a:endParaRPr lang="en-US" sz="1250" dirty="0"/>
           </a:p>
-        </p:txBody>
-      </p:sp>
-      <p:sp>
-        <p:nvSpPr>
-          <p:cNvPr id="11" name="Text 7"/>
-          <p:cNvSpPr txBox="1"/>
-          <p:nvPr/>
-        </p:nvSpPr>
-        <p:spPr>
-          <a:xfrm>
-            <a:off x="777240" y="4864608"/>
-            <a:ext cx="10607040" cy="320040"/>
-          </a:xfrm>
-          <a:prstGeom prst="rect">
-            <a:avLst/>
-          </a:prstGeom>
-          <a:noFill/>
-          <a:ln/>
-        </p:spPr>
-        <p:txBody>
-          <a:bodyPr wrap="square" lIns="0" tIns="0" rIns="0" bIns="0" rtlCol="0" anchor="ctr"/>
-          <a:lstStyle/>
-          <a:p>
-            <a:pPr indent="0" marL="0">
-              <a:buNone/>
-            </a:pPr>
-            <a:r>
-              <a:rPr lang="en-US" sz="1100" dirty="0">
-                <a:solidFill>
-                  <a:srgbClr val="8A7A6D"/>
-                </a:solidFill>
-                <a:latin typeface="Calibri" pitchFamily="34" charset="0"/>
-                <a:ea typeface="Calibri" pitchFamily="34" charset="-122"/>
-                <a:cs typeface="Calibri" pitchFamily="34" charset="-120"/>
-              </a:rPr>
-              <a:t>— Reseña real verificada de Bring! Grocery Shopping List, App Store</a:t>
-            </a:r>
-            <a:endParaRPr lang="en-US" sz="1100" dirty="0"/>
-          </a:p>
-        </p:txBody>
-      </p:sp>
-      <p:sp>
-        <p:nvSpPr>
-          <p:cNvPr id="12" name="Shape 8"/>
-          <p:cNvSpPr/>
-          <p:nvPr/>
-        </p:nvSpPr>
-        <p:spPr>
-          <a:xfrm>
-            <a:off x="548640" y="5440680"/>
-            <a:ext cx="11064240" cy="960120"/>
-          </a:xfrm>
-          <a:prstGeom prst="roundRect">
-            <a:avLst>
-              <a:gd name="adj" fmla="val 9524"/>
-            </a:avLst>
-          </a:prstGeom>
-          <a:solidFill>
-            <a:srgbClr val="F6E9D8"/>
-          </a:solidFill>
-          <a:ln w="12700">
-            <a:solidFill>
-              <a:srgbClr val="C9682B"/>
-            </a:solidFill>
-            <a:prstDash val="solid"/>
-          </a:ln>
-        </p:spPr>
-      </p:sp>
-      <p:sp>
-        <p:nvSpPr>
-          <p:cNvPr id="13" name="Text 9"/>
-          <p:cNvSpPr txBox="1"/>
-          <p:nvPr/>
-        </p:nvSpPr>
-        <p:spPr>
-          <a:xfrm>
-            <a:off x="777240" y="5532120"/>
-            <a:ext cx="10607040" cy="822960"/>
-          </a:xfrm>
-          <a:prstGeom prst="rect">
-            <a:avLst/>
-          </a:prstGeom>
-          <a:noFill/>
-          <a:ln/>
-        </p:spPr>
-        <p:txBody>
-          <a:bodyPr wrap="square" lIns="0" tIns="0" rIns="0" bIns="0" rtlCol="0" anchor="ctr"/>
-          <a:lstStyle/>
-          <a:p>
-            <a:pPr indent="0" marL="0">
-              <a:buNone/>
-            </a:pPr>
-            <a:r>
-              <a:rPr lang="en-US" sz="1200" b="1" dirty="0">
-                <a:solidFill>
-                  <a:srgbClr val="C9682B"/>
-                </a:solidFill>
-                <a:latin typeface="Calibri" pitchFamily="34" charset="0"/>
-                <a:ea typeface="Calibri" pitchFamily="34" charset="-122"/>
-                <a:cs typeface="Calibri" pitchFamily="34" charset="-120"/>
-              </a:rPr>
-              <a:t>Corrección honesta:  </a:t>
-            </a:r>
-            <a:pPr indent="0" marL="0">
-              <a:buNone/>
-            </a:pPr>
-            <a:r>
-              <a:rPr lang="en-US" sz="1200" dirty="0">
+          <a:p>
+            <a:pPr indent="0" marL="0">
+              <a:spcAft>
+                <a:spcPts val="800"/>
+              </a:spcAft>
+              <a:buNone/>
+            </a:pPr>
+            <a:r>
+              <a:rPr lang="en-US" sz="1250" dirty="0">
                 <a:solidFill>
                   <a:srgbClr val="2E2119"/>
                 </a:solidFill>
@@ -6137,9 +6041,26 @@
                 <a:ea typeface="Calibri" pitchFamily="34" charset="-122"/>
                 <a:cs typeface="Calibri" pitchFamily="34" charset="-120"/>
               </a:rPr>
-              <a:t>una tercera app ("Out of Milk") encontrada por búsqueda IA no superó la verificación real y se retiró del análisis, en vez de darse por buena.</a:t>
-            </a:r>
-            <a:endParaRPr lang="en-US" sz="1200" dirty="0"/>
+              <a:t>Las malas, casi todas, eran quejas de compatibilidad técnica (se cuelga, no sincroniza...), no gente pidiendo una función o diciendo que el enfoque no encajaba con su forma de comprar. </a:t>
+            </a:r>
+            <a:endParaRPr lang="en-US" sz="1250" dirty="0"/>
+          </a:p>
+          <a:p>
+            <a:pPr indent="0" marL="0">
+              <a:buNone/>
+            </a:pPr>
+            <a:r>
+              <a:rPr lang="en-US" sz="1250" dirty="0">
+                <a:solidFill>
+                  <a:srgbClr val="2E2119"/>
+                </a:solidFill>
+                <a:latin typeface="Calibri" pitchFamily="34" charset="0"/>
+                <a:ea typeface="Calibri" pitchFamily="34" charset="-122"/>
+                <a:cs typeface="Calibri" pitchFamily="34" charset="-120"/>
+              </a:rPr>
+              <a:t>Por eso se pasó a hablar directamente con quien vive el problema (estudiantes y gente joven) — la vía que el propio guion marca como "la más cara y la más fiable de las tres".</a:t>
+            </a:r>
+            <a:endParaRPr lang="en-US" sz="1250" dirty="0"/>
           </a:p>
         </p:txBody>
       </p:sp>

</xml_diff>

<commit_message>
Actualizar encuesta a n=35: tercera persona que abandona una app
Nueva tanda de 3 respuestas trae el primer caso de abandono de Bring!
por pereza de teclear (motivo distinto al de fricción social ya
documentado), más una cita que confirma directamente el argumento de
"compras aspiracionales de recetas que acaban pudriéndose". Actualiza
ideacion.md (tabla, lectura honesta, grupos de citas) y regenera la
presentación (slides 4, 5 y 6) con las mismas cifras.

Co-Authored-By: Claude Sonnet 5 <noreply@anthropic.com>
Claude-Session: https://claude.ai/code/session_012BwrUiCYr6ApYk5hmXyh4o
</commit_message>
<xml_diff>
--- a/docs/larder-presentacion.pptx
+++ b/docs/larder-presentacion.pptx
@@ -1041,7 +1041,7 @@
           <a:p>
             <a:r>
               <a:rPr lang="en-US" dirty="0"/>
-              <a:t>Diapositiva nueva (17/09) a peticion de Nadia: anticipar la objecion de un desarrollador de AnyList antes de que la haga alguien en la defensa. El argumento se vuelve en su contra -- si papel y boli tampoco tienen esas funciones y aun asi ganan en uso real, lo que anaden esas apps es complejidad, no lo que faltaba. Ademas el enfoque de recetas encaja con un publico mas asentado (ej. una madre de familia), no con el estudiante medio -- el meal prep de moda entre jovenes busca cocinar MENOS, no explorar recetas. Conclusion: ni siquiera cumplen bien la funcion de lista, porque el paso intermedio da pereza.</a:t>
+              <a:t>Diapositiva nueva (17/09) a peticion de Nadia: anticipar la objecion de un desarrollador de AnyList antes de que la haga alguien en la defensa. El argumento se vuelve en su contra -- si papel y boli tampoco tienen esas funciones y aun asi ganan en uso real, lo que anaden esas apps es complejidad, no lo que faltaba. Ademas el enfoque de recetas encaja con un publico mas asentado (ej. una madre de familia), no con el estudiante medio -- el meal prep de moda entre jovenes busca cocinar MENOS, no explorar recetas. Actualizado con una respuesta real de la encuesta (llegada 17/09, ver n=35) que confirma esto sin que se preguntara: compra pensando en cocinar algo elaborado, nunca lo hace, la comida se pudre. Conclusion: ni siquiera cumplen bien la funcion de lista, porque el paso intermedio da pereza.</a:t>
             </a:r>
             <a:endParaRPr lang="en-US" dirty="0"/>
           </a:p>
@@ -1217,7 +1217,7 @@
           <a:p>
             <a:r>
               <a:rPr lang="en-US" dirty="0"/>
-              <a:t>RESULTADOS FINALES -- encuesta cerrada el 17/09/2026, n=32 (2 envios duplicados por accidente descartados: "las cantidades" y la broma "Amor y Paz", cada par contado una vez). El dato mas fuerte de toda la encuesta: 0/32 usa una app HOY como metodo (Pregunta 3) -- las 2 que probaron una app (Bring!, "Notas") la abandonaron, sin excepcion, en las 4 tandas de la recogida. El "metodo ganador" (Papel vs Notas) nunca se asento -- cambio de lider en cada tanda por 1-2 respuestas -- es un empate tecnico, se documenta asi en vez de forzar un ganador. El dato conjunto (53%, 17/32) se mantuvo estable por encima de la mitad en las ultimas tres tandas (58%-&gt;55%-&gt;53%) -- la senal mas solida de toda la encuesta. Correccion 17/09: la cita de Bring! no fue espontanea -- la Pregunta 7 tiene un seguimiento explicito ("¿cual, y por que la dejaste?") que se activa solo si contestas que si probaste una app; se corrigio el texto para no decir "sin que se le pregunte".</a:t>
+              <a:t>n=35 a fecha 17/09/2026 (el formulario sigue tecnicamente abierto en Vercel; "cerrada" en el documento significa "version usada para la entrega", no "imposible que llegue alguna mas"). El dato mas fuerte de toda la encuesta: 0/35 usa una app HOY como metodo (Pregunta 3) -- las 3 que probaron una app la abandonaron, sin excepcion. Novedad de esta tanda: una TERCERA persona probo Bring! y lo dejo, pero por un motivo nuevo (pereza/friccion, no cooperacion) -- dos motivos de abandono distintos apuntando al mismo sitio. El "metodo ganador" (Papel vs Notas) nunca se asento -- empate tecnico. El dato conjunto (54%, 19/35) se mantiene estable por encima de la mitad en toda la recogida.</a:t>
             </a:r>
             <a:endParaRPr lang="en-US" dirty="0"/>
           </a:p>
@@ -1305,7 +1305,7 @@
           <a:p>
             <a:r>
               <a:rPr lang="en-US" dirty="0"/>
-              <a:t>RESULTADOS FINALES, n=32 (encuesta cerrada 17/09/2026; 2 duplicados por envio accidental descartados). Categorizacion: "no se quien compro que" y "llevar la cuenta de quien compro que antes" cuentan para AMBAS columnas (coop + tracker de gastos), "no saber que quieren los otros"/"comen mis cosas"/"compran cosas que no quiero"/"people eating my food"/"dudar en comprar algo y que se lo coma otro" es coop puro, "no participan/tardan en pagar" es tracker de gastos puro. Cooperacion termino como el tema mas repetido con diferencia (8/32, 25%) en toda la recogida. Correccion 17/09: separamos "caducidad/comida que se estropea" (3 menciones, entra en el plan de construccion con un campo de dias de frescura por categoria en nuestra propia base de datos, sin Odoo) de "se acaba y nadie avisa" (1 mencion, esta se resuelve gratis solo con que Fridge sea compartida -- ya no dependemos de logica de "aviso de stock bajo"). Las menciones de precio (2) siguen fuera de esta diapositiva por espacio -- estan en ideacion.md.</a:t>
+              <a:t>n=35 a fecha 17/09/2026 (formulario sigue tecnicamente abierto). Categorizacion: "no se quien compro que" y "llevar la cuenta de quien compro que antes" cuentan para AMBAS columnas (coop + tracker de gastos), "no saber que quieren los otros"/"comen mis cosas"/"compran cosas que no quiero"/"people eating my food"/"dudar en comprar algo y que se lo coma otro" es coop puro, "no participan/tardan en pagar" es tracker de gastos puro. Cooperacion sigue como el tema mas repetido (8/35, 23%). Las 3 respuestas nuevas no anadieron menciones de coop/gasto -- dos son sobre comida que se pudre (movidas a la diapositiva de recetas, donde encajan mejor) y una sobre "tener que mirar que falta". "Caducidad/comida que se estropea" (3 menciones) entra en el plan de construccion; "se acaba y nadie avisa" (1 mencion) se resuelve gratis con Fridge compartida. Las menciones de precio (2) siguen fuera de esta diapositiva por espacio -- estan en ideacion.md.</a:t>
             </a:r>
             <a:endParaRPr lang="en-US" dirty="0"/>
           </a:p>
@@ -6575,10 +6575,13 @@
           <a:lstStyle/>
           <a:p>
             <a:pPr indent="0" marL="0">
-              <a:buNone/>
-            </a:pPr>
-            <a:r>
-              <a:rPr lang="en-US" sz="1250" dirty="0">
+              <a:spcAft>
+                <a:spcPts val="600"/>
+              </a:spcAft>
+              <a:buNone/>
+            </a:pPr>
+            <a:r>
+              <a:rPr lang="en-US" sz="1150" dirty="0">
                 <a:solidFill>
                   <a:srgbClr val="2E2119"/>
                 </a:solidFill>
@@ -6586,9 +6589,40 @@
                 <a:ea typeface="Calibri" pitchFamily="34" charset="-122"/>
                 <a:cs typeface="Calibri" pitchFamily="34" charset="-120"/>
               </a:rPr>
-              <a:t>El estudiante medio independizado no es un apasionado de la cocina. La tendencia joven (meal prep) va al revés: tuppers básicos para toda la semana, para cocinar lo MÍNIMO posible.</a:t>
-            </a:r>
-            <a:endParaRPr lang="en-US" sz="1250" dirty="0"/>
+              <a:t>El estudiante medio independizado no es un apasionado de la cocina. La tendencia joven (meal prep) va al revés: tuppers básicos para toda la semana, para cocinar lo MÍNIMO posible. </a:t>
+            </a:r>
+            <a:endParaRPr lang="en-US" sz="1150" dirty="0"/>
+          </a:p>
+          <a:p>
+            <a:pPr indent="0" marL="0">
+              <a:buNone/>
+            </a:pPr>
+            <a:r>
+              <a:rPr lang="en-US" sz="1150" b="1" dirty="0">
+                <a:solidFill>
+                  <a:srgbClr val="C9682B"/>
+                </a:solidFill>
+                <a:latin typeface="Calibri" pitchFamily="34" charset="0"/>
+                <a:ea typeface="Calibri" pitchFamily="34" charset="-122"/>
+                <a:cs typeface="Calibri" pitchFamily="34" charset="-120"/>
+              </a:rPr>
+              <a:t>Confirmado en la encuesta: </a:t>
+            </a:r>
+            <a:pPr indent="0" marL="0">
+              <a:buNone/>
+            </a:pPr>
+            <a:r>
+              <a:rPr lang="en-US" sz="1150" i="1" dirty="0">
+                <a:solidFill>
+                  <a:srgbClr val="2E2119"/>
+                </a:solidFill>
+                <a:latin typeface="Calibri" pitchFamily="34" charset="0"/>
+                <a:ea typeface="Calibri" pitchFamily="34" charset="-122"/>
+                <a:cs typeface="Calibri" pitchFamily="34" charset="-120"/>
+              </a:rPr>
+              <a:t>"compro cosas pensando en hacer comidas elaboradas pero nunca las llego a hacer, y acaban pudriéndose".</a:t>
+            </a:r>
+            <a:endParaRPr lang="en-US" sz="1150" dirty="0"/>
           </a:p>
         </p:txBody>
       </p:sp>
@@ -7337,7 +7371,7 @@
                 <a:ea typeface="Cambria" pitchFamily="34" charset="-122"/>
                 <a:cs typeface="Cambria" pitchFamily="34" charset="-120"/>
               </a:rPr>
-              <a:t>La encuesta confirma el hueco (n=32, cerrada)</a:t>
+              <a:t>La encuesta confirma el hueco (n=35)</a:t>
             </a:r>
             <a:endParaRPr lang="en-US" sz="2800" dirty="0"/>
           </a:p>
@@ -7376,7 +7410,7 @@
                 <a:ea typeface="Calibri" pitchFamily="34" charset="-122"/>
                 <a:cs typeface="Calibri" pitchFamily="34" charset="-120"/>
               </a:rPr>
-              <a:t>Encuesta bilingüe (ES/EN), 9 preguntas sobre hechos del último mes — no opiniones sobre una app futura. Resultados finales: 32 respuestas únicas, cerrada el 17/09/2026.</a:t>
+              <a:t>Encuesta bilingüe (ES/EN), 9 preguntas sobre hechos del último mes — no opiniones sobre una app futura. 35 respuestas únicas a fecha 17/09/2026.</a:t>
             </a:r>
             <a:endParaRPr lang="en-US" sz="1000" dirty="0"/>
           </a:p>
@@ -7437,7 +7471,7 @@
                 <a:ea typeface="Cambria" pitchFamily="34" charset="-122"/>
                 <a:cs typeface="Cambria" pitchFamily="34" charset="-120"/>
               </a:rPr>
-              <a:t>0/32</a:t>
+              <a:t>0/35</a:t>
             </a:r>
             <a:endParaRPr lang="en-US" sz="3000" dirty="0"/>
           </a:p>
@@ -7476,7 +7510,7 @@
                 <a:ea typeface="Calibri" pitchFamily="34" charset="-122"/>
                 <a:cs typeface="Calibri" pitchFamily="34" charset="-120"/>
               </a:rPr>
-              <a:t>usa hoy una app específica como método — aunque 2 personas SÍ la probaron alguna vez (ver abajo)</a:t>
+              <a:t>usa hoy una app específica como método — aunque 3 personas SÍ la probaron alguna vez (ver abajo)</a:t>
             </a:r>
             <a:endParaRPr lang="en-US" sz="1000" dirty="0"/>
           </a:p>
@@ -7537,7 +7571,7 @@
                 <a:ea typeface="Cambria" pitchFamily="34" charset="-122"/>
                 <a:cs typeface="Cambria" pitchFamily="34" charset="-120"/>
               </a:rPr>
-              <a:t>72%</a:t>
+              <a:t>74%</a:t>
             </a:r>
             <a:endParaRPr lang="en-US" sz="3000" dirty="0"/>
           </a:p>
@@ -7637,7 +7671,7 @@
                 <a:ea typeface="Cambria" pitchFamily="34" charset="-122"/>
                 <a:cs typeface="Cambria" pitchFamily="34" charset="-120"/>
               </a:rPr>
-              <a:t>75%</a:t>
+              <a:t>74%</a:t>
             </a:r>
             <a:endParaRPr lang="en-US" sz="3000" dirty="0"/>
           </a:p>
@@ -7715,7 +7749,7 @@
                 <a:ea typeface="Calibri" pitchFamily="34" charset="-122"/>
                 <a:cs typeface="Calibri" pitchFamily="34" charset="-120"/>
               </a:rPr>
-              <a:t>El 53% (17 de 32) sufrió ambas cosas en el mismo mes — el mismo tiempo y dinero (260-520€/año) de la frase del dolor, confirmado con datos.</a:t>
+              <a:t>El 54% (19 de 35) sufrió ambas cosas en el mismo mes — el mismo tiempo y dinero (260-520€/año) de la frase del dolor, confirmado con datos.</a:t>
             </a:r>
             <a:endParaRPr lang="en-US" sz="1100" dirty="0"/>
           </a:p>
@@ -7905,7 +7939,7 @@
                 <a:ea typeface="Calibri" pitchFamily="34" charset="-122"/>
                 <a:cs typeface="Calibri" pitchFamily="34" charset="-120"/>
               </a:rPr>
-              <a:t>12</a:t>
+              <a:t>13</a:t>
             </a:r>
             <a:endParaRPr lang="en-US" sz="1100" dirty="0"/>
           </a:p>
@@ -7981,7 +8015,7 @@
         <p:spPr>
           <a:xfrm>
             <a:off x="2788920" y="3986784"/>
-            <a:ext cx="3268980" cy="219456"/>
+            <a:ext cx="3291840" cy="219456"/>
           </a:xfrm>
           <a:prstGeom prst="roundRect">
             <a:avLst>
@@ -8027,7 +8061,7 @@
                 <a:ea typeface="Calibri" pitchFamily="34" charset="-122"/>
                 <a:cs typeface="Calibri" pitchFamily="34" charset="-120"/>
               </a:rPr>
-              <a:t>11</a:t>
+              <a:t>12</a:t>
             </a:r>
             <a:endParaRPr lang="en-US" sz="1100" dirty="0"/>
           </a:p>
@@ -8103,7 +8137,7 @@
         <p:spPr>
           <a:xfrm>
             <a:off x="2788920" y="4297680"/>
-            <a:ext cx="2377440" cy="219456"/>
+            <a:ext cx="2468880" cy="219456"/>
           </a:xfrm>
           <a:prstGeom prst="roundRect">
             <a:avLst>
@@ -8149,7 +8183,7 @@
                 <a:ea typeface="Calibri" pitchFamily="34" charset="-122"/>
                 <a:cs typeface="Calibri" pitchFamily="34" charset="-120"/>
               </a:rPr>
-              <a:t>8</a:t>
+              <a:t>9</a:t>
             </a:r>
             <a:endParaRPr lang="en-US" sz="1100" dirty="0"/>
           </a:p>
@@ -8225,7 +8259,7 @@
         <p:spPr>
           <a:xfrm>
             <a:off x="2788920" y="4608576"/>
-            <a:ext cx="297180" cy="219456"/>
+            <a:ext cx="274320" cy="219456"/>
           </a:xfrm>
           <a:prstGeom prst="roundRect">
             <a:avLst>
@@ -8410,7 +8444,7 @@
                 <a:ea typeface="Calibri" pitchFamily="34" charset="-122"/>
                 <a:cs typeface="Calibri" pitchFamily="34" charset="-120"/>
               </a:rPr>
-              <a:t>↑ 2 personas la probaron alguna vez (Pregunta 7) — pero 0/32 la usa hoy: la abandonaron</a:t>
+              <a:t>↑ 3 personas la probaron alguna vez (Pregunta 7) — pero 0/35 la usa hoy: la abandonaron</a:t>
             </a:r>
             <a:endParaRPr lang="en-US" sz="950" dirty="0"/>
           </a:p>
@@ -8471,7 +8505,7 @@
               <a:buNone/>
             </a:pPr>
             <a:r>
-              <a:rPr lang="en-US" sz="1150" b="1" dirty="0">
+              <a:rPr lang="en-US" sz="1100" b="1" dirty="0">
                 <a:solidFill>
                   <a:srgbClr val="C9682B"/>
                 </a:solidFill>
@@ -8481,14 +8515,14 @@
               </a:rPr>
               <a:t>Las apps no son el problema — la retención sí.  </a:t>
             </a:r>
-            <a:endParaRPr lang="en-US" sz="1150" dirty="0"/>
-          </a:p>
-          <a:p>
-            <a:pPr indent="0" marL="0">
-              <a:buNone/>
-            </a:pPr>
-            <a:r>
-              <a:rPr lang="en-US" sz="1150" dirty="0">
+            <a:endParaRPr lang="en-US" sz="1100" dirty="0"/>
+          </a:p>
+          <a:p>
+            <a:pPr indent="0" marL="0">
+              <a:buNone/>
+            </a:pPr>
+            <a:r>
+              <a:rPr lang="en-US" sz="1100" dirty="0">
                 <a:solidFill>
                   <a:srgbClr val="2E2119"/>
                 </a:solidFill>
@@ -8496,9 +8530,9 @@
                 <a:ea typeface="Calibri" pitchFamily="34" charset="-122"/>
                 <a:cs typeface="Calibri" pitchFamily="34" charset="-120"/>
               </a:rPr>
-              <a:t>Bring! y AnyList llevan años disponibles y son razonablemente buenas (estado del arte). 2 de 32 personas confirman haberlas probado — pero ninguna las usa hoy. A quien probó Bring! se le preguntó por qué la dejó, y respondió: "porque si no colaboran los demás... pues mal vamos". El hueco no está en construir "una app más" — está en resolver por qué las que existen no retienen ni a quien sí las prueba.</a:t>
-            </a:r>
-            <a:endParaRPr lang="en-US" sz="1150" dirty="0"/>
+              <a:t>Bring! y AnyList llevan años disponibles y son razonablemente buenas (estado del arte). 3 de 35 personas confirman haberlas probado — pero ninguna las usa hoy. Dos de ellas probaron Bring! y lo dejaron por motivos distintos: una por falta de cooperación de sus compañeros, otra "porque me acaba dando pereza usarla". El hueco no está en construir "una app más" — está en resolver por qué las que existen no retienen ni a quien sí las prueba.</a:t>
+            </a:r>
+            <a:endParaRPr lang="en-US" sz="1100" dirty="0"/>
           </a:p>
         </p:txBody>
       </p:sp>
@@ -8796,7 +8830,7 @@
                 <a:ea typeface="Calibri" pitchFamily="34" charset="-122"/>
                 <a:cs typeface="Calibri" pitchFamily="34" charset="-120"/>
               </a:rPr>
-              <a:t>8 de 32 personas (25%) — el tema más repetido, sin que se les preguntara</a:t>
+              <a:t>8 de 35 personas (23%) — el tema más repetido, sin que se les preguntara</a:t>
             </a:r>
             <a:endParaRPr lang="en-US" sz="1050" dirty="0"/>
           </a:p>
@@ -9051,7 +9085,7 @@
                 <a:ea typeface="Calibri" pitchFamily="34" charset="-122"/>
                 <a:cs typeface="Calibri" pitchFamily="34" charset="-120"/>
               </a:rPr>
-              <a:t>3 menciones espontáneas + 12/32 (38%) dice en la Pregunta 8 que no llevan cuenta</a:t>
+              <a:t>3 menciones espontáneas + 12/35 (34%) dice en la Pregunta 8 que no llevan cuenta</a:t>
             </a:r>
             <a:endParaRPr lang="en-US" sz="1050" dirty="0"/>
           </a:p>

</xml_diff>

<commit_message>
Fijar el público como estudiantes en el estudio de mercado
Antes el mercado objetivo (≈99.700) coincidía con el accesible al
suponer que Larder servía a "cualquier hogar multi-persona". Ahora
que el público se define explícitamente como estudiantes, el embudo
de la sección 3 y de la slide de estudio de mercado parte de la UDC
(>13.300 matriculados → ≈4.123 que vienen de fuera → ≈650 pisos
compartidos), en vez de partir de hogares genéricos de A Coruña. Los
~99.700 hogares quedan documentados solo como techo de contexto, no
como objetivo de esta entrega. Se actualizan también las referencias
a esta cifra en la servilleta y en el documento de una página para
que no queden inconsistentes con este cambio.

Co-Authored-By: Claude Sonnet 5 <noreply@anthropic.com>
Claude-Session: https://claude.ai/code/session_012BwrUiCYr6ApYk5hmXyh4o
</commit_message>
<xml_diff>
--- a/docs/larder-presentacion.pptx
+++ b/docs/larder-presentacion.pptx
@@ -1393,7 +1393,7 @@
           <a:p>
             <a:r>
               <a:rPr lang="en-US" dirty="0"/>
-              <a:t>Se amplio el segmento objetivo a estudiantes+parejas+cualquiera que comparta gastos. Al no encontrar un desglose fiable para ese cruce en A Coruña, el mercado objetivo se iguala al accesible, y se documenta honestamente la limitacion de la busqueda.</a:t>
+              <a:t>Publico fijado como estudiantes (18/09): el embudo ahora parte de la UDC (&gt;13.300) en vez de hogares genericos. El mercado objetivo es directamente ~650 pisos, no "coincide con el accesible". Los ~99.700 hogares de A Coruna quedan solo como techo de contexto.</a:t>
             </a:r>
             <a:endParaRPr lang="en-US" dirty="0"/>
           </a:p>
@@ -9584,7 +9584,7 @@
               <a:buNone/>
             </a:pPr>
             <a:r>
-              <a:rPr lang="en-US" sz="2000" b="1" dirty="0">
+              <a:rPr lang="en-US" sz="3400" b="1" dirty="0">
                 <a:solidFill>
                   <a:srgbClr val="2E2119"/>
                 </a:solidFill>
@@ -9592,26 +9592,9 @@
                 <a:ea typeface="Cambria" pitchFamily="34" charset="-122"/>
                 <a:cs typeface="Cambria" pitchFamily="34" charset="-120"/>
               </a:rPr>
-              <a:t>Hogares de</a:t>
-            </a:r>
-            <a:endParaRPr lang="en-US" sz="2000" dirty="0"/>
-          </a:p>
-          <a:p>
-            <a:pPr indent="0" marL="0">
-              <a:buNone/>
-            </a:pPr>
-            <a:r>
-              <a:rPr lang="en-US" sz="2000" b="1" dirty="0">
-                <a:solidFill>
-                  <a:srgbClr val="2E2119"/>
-                </a:solidFill>
-                <a:latin typeface="Cambria" pitchFamily="34" charset="0"/>
-                <a:ea typeface="Cambria" pitchFamily="34" charset="-122"/>
-                <a:cs typeface="Cambria" pitchFamily="34" charset="-120"/>
-              </a:rPr>
-              <a:t>España 2+ pers.</a:t>
-            </a:r>
-            <a:endParaRPr lang="en-US" sz="2000" dirty="0"/>
+              <a:t>&gt; 13.300</a:t>
+            </a:r>
+            <a:endParaRPr lang="en-US" sz="3400" dirty="0"/>
           </a:p>
         </p:txBody>
       </p:sp>
@@ -9648,7 +9631,7 @@
                 <a:ea typeface="Calibri" pitchFamily="34" charset="-122"/>
                 <a:cs typeface="Calibri" pitchFamily="34" charset="-120"/>
               </a:rPr>
-              <a:t>Tamaño medio 2,50 pers./hogar (INE 2023)</a:t>
+              <a:t>Estudiantes matriculados en la UDC (curso 2025-26, ambos campus)</a:t>
             </a:r>
             <a:endParaRPr lang="en-US" sz="1050" dirty="0"/>
           </a:p>
@@ -9755,7 +9738,7 @@
                 <a:ea typeface="Cambria" pitchFamily="34" charset="-122"/>
                 <a:cs typeface="Cambria" pitchFamily="34" charset="-120"/>
               </a:rPr>
-              <a:t>≈ 99.700</a:t>
+              <a:t>≈ 4.123</a:t>
             </a:r>
             <a:endParaRPr lang="en-US" sz="3400" dirty="0"/>
           </a:p>
@@ -9794,7 +9777,7 @@
                 <a:ea typeface="Calibri" pitchFamily="34" charset="-122"/>
                 <a:cs typeface="Calibri" pitchFamily="34" charset="-120"/>
               </a:rPr>
-              <a:t>249.261 hab. ÷ 2,50 pers./hogar (INE/IGE 2024)</a:t>
+              <a:t>31% cambia de ciudad para estudiar — % nacional aplicado a la UDC (Fundación CYD)</a:t>
             </a:r>
             <a:endParaRPr lang="en-US" sz="1050" dirty="0"/>
           </a:p>
@@ -9901,7 +9884,7 @@
                 <a:ea typeface="Cambria" pitchFamily="34" charset="-122"/>
                 <a:cs typeface="Cambria" pitchFamily="34" charset="-120"/>
               </a:rPr>
-              <a:t>≈ 99.700</a:t>
+              <a:t>≈ 650 pisos</a:t>
             </a:r>
             <a:endParaRPr lang="en-US" sz="3400" dirty="0"/>
           </a:p>
@@ -9940,7 +9923,7 @@
                 <a:ea typeface="Calibri" pitchFamily="34" charset="-122"/>
                 <a:cs typeface="Calibri" pitchFamily="34" charset="-120"/>
               </a:rPr>
-              <a:t>Coincide con el accesible — ver nota abajo</a:t>
+              <a:t>55% de esos comparte piso ÷ 3,5 pers./piso de media</a:t>
             </a:r>
             <a:endParaRPr lang="en-US" sz="1050" dirty="0"/>
           </a:p>
@@ -10006,7 +9989,7 @@
                 <a:ea typeface="Calibri" pitchFamily="34" charset="-122"/>
                 <a:cs typeface="Calibri" pitchFamily="34" charset="-120"/>
               </a:rPr>
-              <a:t>Nota honesta sobre la búsqueda:  </a:t>
+              <a:t>Margen de error reconocido:  </a:t>
             </a:r>
             <a:endParaRPr lang="en-US" sz="1200" dirty="0"/>
           </a:p>
@@ -10026,7 +10009,7 @@
                 <a:ea typeface="Calibri" pitchFamily="34" charset="-122"/>
                 <a:cs typeface="Calibri" pitchFamily="34" charset="-120"/>
               </a:rPr>
-              <a:t>no se encontró un desglose público fiable de "hogares no familiares/parejas sin hijos" a nivel de A Coruña — es un resultado válido en sí mismo, no un dato inventado.</a:t>
+              <a:t>la cifra de ≈650 pisos encadena 3 supuestos (% que cambia de ciudad, % que comparte piso, tamaño medio del piso) — es una estimación gruesa, no un conteo exacto. Deja fuera a jóvenes trabajadores que comparten piso y sufren el mismo problema, pero no salen en estas estadísticas.</a:t>
             </a:r>
             <a:endParaRPr lang="en-US" sz="1200" dirty="0"/>
           </a:p>
@@ -10043,7 +10026,7 @@
                 <a:ea typeface="Calibri" pitchFamily="34" charset="-122"/>
                 <a:cs typeface="Calibri" pitchFamily="34" charset="-120"/>
               </a:rPr>
-              <a:t>Suelo verificable:  </a:t>
+              <a:t>Para contexto, no como objetivo:  </a:t>
             </a:r>
             <a:endParaRPr lang="en-US" sz="1200" dirty="0"/>
           </a:p>
@@ -10060,7 +10043,7 @@
                 <a:ea typeface="Calibri" pitchFamily="34" charset="-122"/>
                 <a:cs typeface="Calibri" pitchFamily="34" charset="-120"/>
               </a:rPr>
-              <a:t>≈ 650 pisos de estudiantes en A Coruña (UDC &gt;13.300 matriculados · 31% cambia de ciudad · 55% comparte piso — Fundación CYD).</a:t>
+              <a:t>A Coruña tiene ≈99.700 hogares de 2+ personas — el techo si algún día se sirviera a cualquier hogar, no solo a estudiantes.</a:t>
             </a:r>
             <a:endParaRPr lang="en-US" sz="1200" dirty="0"/>
           </a:p>

</xml_diff>

<commit_message>
Sincronizar ideacion.md con la versión final de la presentación
Adapta la documentación a dos cambios reales hechos en la versión
final del PDF: (1) el proveedor de IA para leer tickets pasa de
Gemini a Groq en todas las referencias del stack (servilleta, 3
columnas, sección de Fridge, documento de una página), y (2) el
cálculo de la frase del dolor pasa de 52 a 40 semanas activas al año
(se descuentan vacaciones/viajes), bajando la cifra de 260-520€/año a
200-400€/año en las tres secciones donde aparecía. Se actualiza
también build_deck.js para que la próxima regeneración del pptx no
revierta estos números.

Co-Authored-By: Claude Sonnet 5 <noreply@anthropic.com>
Claude-Session: https://claude.ai/code/session_012BwrUiCYr6ApYk5hmXyh4o
</commit_message>
<xml_diff>
--- a/docs/larder-presentacion.pptx
+++ b/docs/larder-presentacion.pptx
@@ -601,7 +601,7 @@
           <a:p>
             <a:r>
               <a:rPr lang="en-US" dirty="0"/>
-              <a:t>Actualizado 17/09 tras el giro de producto: se retira Odoo (Prices se calcula sobre nuestro propio historial de compras, no un catalogo externo que alguien tendria que mantener a mano). Se decide construir para esta entrega lo que antes era "P2 hipotetico" (lectura de tickets con Gemini, prediccion de consumo) -- la columna de la derecha se queda solo con lo que de verdad no compensa construir nunca en este proyecto. Nadie nos elegiria por construir facturacion o cobro con tarjeta propios; si por como llevamos nevera y lista compartida. Orden de construccion: una pantalla completa antes de abrir la siguiente -- eso no cambia aunque el alcance de cada pantalla haya crecido.</a:t>
+              <a:t>Actualizado 17/09 tras el giro de producto: se retira Odoo (Prices se calcula sobre nuestro propio historial de compras, no un catalogo externo que alguien tendria que mantener a mano). Se decide construir para esta entrega lo que antes era "P2 hipotetico" (lectura de tickets con Groq, prediccion de consumo) -- la columna de la derecha se queda solo con lo que de verdad no compensa construir nunca en este proyecto. Nadie nos elegiria por construir facturacion o cobro con tarjeta propios; si por como llevamos nevera y lista compartida. Orden de construccion: una pantalla completa antes de abrir la siguiente -- eso no cambia aunque el alcance de cada pantalla haya crecido.</a:t>
             </a:r>
             <a:endParaRPr lang="en-US" dirty="0"/>
           </a:p>
@@ -865,7 +865,7 @@
           <a:p>
             <a:r>
               <a:rPr lang="en-US" dirty="0"/>
-              <a:t>Actualizado 17/09: rango en vez de cifra fija, y 5€/viaje en vez de 10€ (Nadia considero la primera estimacion demasiado dramatizada). Un rango (260-520€/ano) es mas honesto que un unico numero porque la frecuencia real varia semana a semana. Es la segunda correccion de esta cifra: la primera version (120€/ano) tampoco cuadraba con las cuentas reales.</a:t>
+              <a:t>Actualizado 18/09: 40 semanas activas en vez de 52 (se descuentan vacaciones/viajes en los que no se hace la compra habitual del piso). Un rango (200-400€/ano) sigue siendo mas honesto que un unico numero porque la frecuencia real varia semana a semana.</a:t>
             </a:r>
             <a:endParaRPr lang="en-US" dirty="0"/>
           </a:p>
@@ -2573,7 +2573,7 @@
                 <a:ea typeface="Calibri" pitchFamily="34" charset="-122"/>
                 <a:cs typeface="Calibri" pitchFamily="34" charset="-120"/>
               </a:rPr>
-              <a:t>Lectura de tickets → items (Gemini API, free tier — la IA solo se usa aquí)</a:t>
+              <a:t>Lectura de tickets → items (Groq API, free tier — la IA solo se usa aquí)</a:t>
             </a:r>
             <a:endParaRPr lang="en-US" sz="1000" dirty="0"/>
           </a:p>
@@ -3365,7 +3365,7 @@
                 <a:ea typeface="Calibri" pitchFamily="34" charset="-122"/>
                 <a:cs typeface="Calibri" pitchFamily="34" charset="-120"/>
               </a:rPr>
-              <a:t>10-15 min/lista a ojo, 1-2 viajes/semana sin plan, 260-520€/año perdidos.</a:t>
+              <a:t>10-15 min/lista a ojo, 1-2 viajes/semana sin plan, 200-400€/año perdidos.</a:t>
             </a:r>
             <a:endParaRPr lang="en-US" sz="1100" dirty="0"/>
           </a:p>
@@ -4014,7 +4014,7 @@
                 <a:ea typeface="Calibri" pitchFamily="34" charset="-122"/>
                 <a:cs typeface="Calibri" pitchFamily="34" charset="-120"/>
               </a:rPr>
-              <a:t>Lectura de tickets (Gemini API) y aviso de turno de compra (bot de Telegram)</a:t>
+              <a:t>Lectura de tickets (Groq API) y aviso de turno de compra (bot de Telegram)</a:t>
             </a:r>
             <a:endParaRPr lang="en-US" sz="1600" dirty="0"/>
           </a:p>
@@ -4525,7 +4525,7 @@
                 <a:ea typeface="Cambria" pitchFamily="34" charset="-122"/>
                 <a:cs typeface="Cambria" pitchFamily="34" charset="-120"/>
               </a:rPr>
-              <a:t>260-520 €</a:t>
+              <a:t>200-400 €</a:t>
             </a:r>
             <a:endParaRPr lang="en-US" sz="4000" dirty="0"/>
           </a:p>
@@ -4623,7 +4623,7 @@
                 <a:ea typeface="Calibri" pitchFamily="34" charset="-122"/>
                 <a:cs typeface="Calibri" pitchFamily="34" charset="-120"/>
               </a:rPr>
-              <a:t>5 €/viaje × 1-2 viajes/semana × 52 semanas ≈ 260-520 €/año</a:t>
+              <a:t>5 €/viaje × 1-2 viajes/semana × 40 semanas activas ≈ 200-400 €/año</a:t>
             </a:r>
             <a:endParaRPr lang="en-US" sz="1300" dirty="0"/>
           </a:p>
@@ -7749,7 +7749,7 @@
                 <a:ea typeface="Calibri" pitchFamily="34" charset="-122"/>
                 <a:cs typeface="Calibri" pitchFamily="34" charset="-120"/>
               </a:rPr>
-              <a:t>El 54% (19 de 35) sufrió ambas cosas en el mismo mes — el mismo tiempo y dinero (260-520€/año) de la frase del dolor, confirmado con datos.</a:t>
+              <a:t>El 54% (19 de 35) sufrió ambas cosas en el mismo mes — el mismo tiempo y dinero (200-400€/año) de la frase del dolor, confirmado con datos.</a:t>
             </a:r>
             <a:endParaRPr lang="en-US" sz="1100" dirty="0"/>
           </a:p>

</xml_diff>

<commit_message>
Recolorear la presentación con la paleta verde bosque/ámbar
Sustituye la paleta marrón/naranja original por los mismos tonos que
el overview HTML para cliente (verde bosque oscuro, ámbar, papel
cálido), a petición de Nadia tras ver el HTML. Cambio puramente de
color — ningún contenido ni layout se ha tocado.

Co-Authored-By: Claude Sonnet 5 <noreply@anthropic.com>
Claude-Session: https://claude.ai/code/session_012BwrUiCYr6ApYk5hmXyh4o
</commit_message>
<xml_diff>
--- a/docs/larder-presentacion.pptx
+++ b/docs/larder-presentacion.pptx
@@ -2014,7 +2014,7 @@
     <p:bg>
       <p:bgPr>
         <a:solidFill>
-          <a:srgbClr val="2E2119"/>
+          <a:srgbClr val="26402C"/>
         </a:solidFill>
       </p:bgPr>
     </p:bg>
@@ -2047,7 +2047,7 @@
             <a:avLst/>
           </a:prstGeom>
           <a:solidFill>
-            <a:srgbClr val="C9682B"/>
+            <a:srgbClr val="C6821E"/>
           </a:solidFill>
           <a:ln/>
         </p:spPr>
@@ -2142,7 +2142,7 @@
             <a:r>
               <a:rPr lang="en-US" sz="1700" i="1" dirty="0">
                 <a:solidFill>
-                  <a:srgbClr val="D9A441"/>
+                  <a:srgbClr val="E3A94A"/>
                 </a:solidFill>
                 <a:latin typeface="Calibri" pitchFamily="34" charset="0"/>
                 <a:ea typeface="Calibri" pitchFamily="34" charset="-122"/>
@@ -2171,7 +2171,7 @@
             </a:avLst>
           </a:prstGeom>
           <a:solidFill>
-            <a:srgbClr val="3D2E23"/>
+            <a:srgbClr val="33513A"/>
           </a:solidFill>
           <a:ln/>
         </p:spPr>
@@ -2220,7 +2220,7 @@
             <a:r>
               <a:rPr lang="en-US" sz="1300" dirty="0">
                 <a:solidFill>
-                  <a:srgbClr val="D8CBBE"/>
+                  <a:srgbClr val="C7D0C2"/>
                 </a:solidFill>
                 <a:latin typeface="Calibri" pitchFamily="34" charset="0"/>
                 <a:ea typeface="Calibri" pitchFamily="34" charset="-122"/>
@@ -2279,7 +2279,7 @@
             <a:avLst/>
           </a:prstGeom>
           <a:solidFill>
-            <a:srgbClr val="C9682B"/>
+            <a:srgbClr val="C6821E"/>
           </a:solidFill>
           <a:ln/>
         </p:spPr>
@@ -2335,7 +2335,7 @@
             <a:r>
               <a:rPr lang="en-US" sz="1200" b="1" spc="200" kern="0" dirty="0">
                 <a:solidFill>
-                  <a:srgbClr val="C9682B"/>
+                  <a:srgbClr val="C6821E"/>
                 </a:solidFill>
                 <a:latin typeface="Calibri" pitchFamily="34" charset="0"/>
                 <a:ea typeface="Calibri" pitchFamily="34" charset="-122"/>
@@ -2374,7 +2374,7 @@
             <a:r>
               <a:rPr lang="en-US" sz="2800" b="1" dirty="0">
                 <a:solidFill>
-                  <a:srgbClr val="2E2119"/>
+                  <a:srgbClr val="26402C"/>
                 </a:solidFill>
                 <a:latin typeface="Cambria" pitchFamily="34" charset="0"/>
                 <a:ea typeface="Cambria" pitchFamily="34" charset="-122"/>
@@ -2403,7 +2403,7 @@
             </a:avLst>
           </a:prstGeom>
           <a:solidFill>
-            <a:srgbClr val="F4E9DA"/>
+            <a:srgbClr val="F2EFE7"/>
           </a:solidFill>
           <a:ln/>
           <a:effectLst>
@@ -2442,7 +2442,7 @@
             <a:r>
               <a:rPr lang="en-US" sz="1100" b="1" spc="100" kern="0" dirty="0">
                 <a:solidFill>
-                  <a:srgbClr val="C9682B"/>
+                  <a:srgbClr val="C6821E"/>
                 </a:solidFill>
                 <a:latin typeface="Calibri" pitchFamily="34" charset="0"/>
                 <a:ea typeface="Calibri" pitchFamily="34" charset="-122"/>
@@ -2481,7 +2481,7 @@
             <a:r>
               <a:rPr lang="en-US" sz="3400" b="1" dirty="0">
                 <a:solidFill>
-                  <a:srgbClr val="2E2119"/>
+                  <a:srgbClr val="26402C"/>
                 </a:solidFill>
                 <a:latin typeface="Cambria" pitchFamily="34" charset="0"/>
                 <a:ea typeface="Cambria" pitchFamily="34" charset="-122"/>
@@ -2520,7 +2520,7 @@
             <a:r>
               <a:rPr lang="en-US" sz="1050" dirty="0">
                 <a:solidFill>
-                  <a:srgbClr val="8A7A6D"/>
+                  <a:srgbClr val="5B6559"/>
                 </a:solidFill>
                 <a:latin typeface="Calibri" pitchFamily="34" charset="0"/>
                 <a:ea typeface="Calibri" pitchFamily="34" charset="-122"/>
@@ -2549,7 +2549,7 @@
             </a:avLst>
           </a:prstGeom>
           <a:solidFill>
-            <a:srgbClr val="2E2119"/>
+            <a:srgbClr val="26402C"/>
           </a:solidFill>
           <a:ln/>
           <a:effectLst>
@@ -2588,7 +2588,7 @@
             <a:r>
               <a:rPr lang="en-US" sz="1100" b="1" spc="100" kern="0" dirty="0">
                 <a:solidFill>
-                  <a:srgbClr val="D9A441"/>
+                  <a:srgbClr val="E3A94A"/>
                 </a:solidFill>
                 <a:latin typeface="Calibri" pitchFamily="34" charset="0"/>
                 <a:ea typeface="Calibri" pitchFamily="34" charset="-122"/>
@@ -2666,7 +2666,7 @@
             <a:r>
               <a:rPr lang="en-US" sz="1050" dirty="0">
                 <a:solidFill>
-                  <a:srgbClr val="D8CBBE"/>
+                  <a:srgbClr val="C7D0C2"/>
                 </a:solidFill>
                 <a:latin typeface="Calibri" pitchFamily="34" charset="0"/>
                 <a:ea typeface="Calibri" pitchFamily="34" charset="-122"/>
@@ -2695,7 +2695,7 @@
             </a:avLst>
           </a:prstGeom>
           <a:solidFill>
-            <a:srgbClr val="F4E9DA"/>
+            <a:srgbClr val="F2EFE7"/>
           </a:solidFill>
           <a:ln/>
           <a:effectLst>
@@ -2734,7 +2734,7 @@
             <a:r>
               <a:rPr lang="en-US" sz="1100" b="1" spc="100" kern="0" dirty="0">
                 <a:solidFill>
-                  <a:srgbClr val="C9682B"/>
+                  <a:srgbClr val="C6821E"/>
                 </a:solidFill>
                 <a:latin typeface="Calibri" pitchFamily="34" charset="0"/>
                 <a:ea typeface="Calibri" pitchFamily="34" charset="-122"/>
@@ -2773,7 +2773,7 @@
             <a:r>
               <a:rPr lang="en-US" sz="3400" b="1" dirty="0">
                 <a:solidFill>
-                  <a:srgbClr val="2E2119"/>
+                  <a:srgbClr val="26402C"/>
                 </a:solidFill>
                 <a:latin typeface="Cambria" pitchFamily="34" charset="0"/>
                 <a:ea typeface="Cambria" pitchFamily="34" charset="-122"/>
@@ -2812,7 +2812,7 @@
             <a:r>
               <a:rPr lang="en-US" sz="1050" dirty="0">
                 <a:solidFill>
-                  <a:srgbClr val="8A7A6D"/>
+                  <a:srgbClr val="5B6559"/>
                 </a:solidFill>
                 <a:latin typeface="Calibri" pitchFamily="34" charset="0"/>
                 <a:ea typeface="Calibri" pitchFamily="34" charset="-122"/>
@@ -2841,11 +2841,11 @@
             </a:avLst>
           </a:prstGeom>
           <a:solidFill>
-            <a:srgbClr val="F6E9D8"/>
+            <a:srgbClr val="F0E0BE"/>
           </a:solidFill>
           <a:ln w="12700">
             <a:solidFill>
-              <a:srgbClr val="C9682B"/>
+              <a:srgbClr val="C6821E"/>
             </a:solidFill>
             <a:prstDash val="solid"/>
           </a:ln>
@@ -2878,7 +2878,7 @@
             <a:r>
               <a:rPr lang="en-US" sz="1200" b="1" dirty="0">
                 <a:solidFill>
-                  <a:srgbClr val="C9682B"/>
+                  <a:srgbClr val="C6821E"/>
                 </a:solidFill>
                 <a:latin typeface="Calibri" pitchFamily="34" charset="0"/>
                 <a:ea typeface="Calibri" pitchFamily="34" charset="-122"/>
@@ -2898,7 +2898,7 @@
             <a:r>
               <a:rPr lang="en-US" sz="1200" dirty="0">
                 <a:solidFill>
-                  <a:srgbClr val="2E2119"/>
+                  <a:srgbClr val="26402C"/>
                 </a:solidFill>
                 <a:latin typeface="Calibri" pitchFamily="34" charset="0"/>
                 <a:ea typeface="Calibri" pitchFamily="34" charset="-122"/>
@@ -2915,7 +2915,7 @@
             <a:r>
               <a:rPr lang="en-US" sz="1200" b="1" dirty="0">
                 <a:solidFill>
-                  <a:srgbClr val="C9682B"/>
+                  <a:srgbClr val="C6821E"/>
                 </a:solidFill>
                 <a:latin typeface="Calibri" pitchFamily="34" charset="0"/>
                 <a:ea typeface="Calibri" pitchFamily="34" charset="-122"/>
@@ -2932,7 +2932,7 @@
             <a:r>
               <a:rPr lang="en-US" sz="1200" dirty="0">
                 <a:solidFill>
-                  <a:srgbClr val="2E2119"/>
+                  <a:srgbClr val="26402C"/>
                 </a:solidFill>
                 <a:latin typeface="Calibri" pitchFamily="34" charset="0"/>
                 <a:ea typeface="Calibri" pitchFamily="34" charset="-122"/>
@@ -2991,7 +2991,7 @@
             <a:avLst/>
           </a:prstGeom>
           <a:solidFill>
-            <a:srgbClr val="C9682B"/>
+            <a:srgbClr val="C6821E"/>
           </a:solidFill>
           <a:ln/>
         </p:spPr>
@@ -3047,7 +3047,7 @@
             <a:r>
               <a:rPr lang="en-US" sz="1200" b="1" spc="200" kern="0" dirty="0">
                 <a:solidFill>
-                  <a:srgbClr val="C9682B"/>
+                  <a:srgbClr val="C6821E"/>
                 </a:solidFill>
                 <a:latin typeface="Calibri" pitchFamily="34" charset="0"/>
                 <a:ea typeface="Calibri" pitchFamily="34" charset="-122"/>
@@ -3086,7 +3086,7 @@
             <a:r>
               <a:rPr lang="en-US" sz="2800" b="1" dirty="0">
                 <a:solidFill>
-                  <a:srgbClr val="2E2119"/>
+                  <a:srgbClr val="26402C"/>
                 </a:solidFill>
                 <a:latin typeface="Cambria" pitchFamily="34" charset="0"/>
                 <a:ea typeface="Cambria" pitchFamily="34" charset="-122"/>
@@ -3115,7 +3115,7 @@
             </a:avLst>
           </a:prstGeom>
           <a:solidFill>
-            <a:srgbClr val="F4E9DA"/>
+            <a:srgbClr val="F2EFE7"/>
           </a:solidFill>
           <a:ln/>
           <a:effectLst>
@@ -3154,7 +3154,7 @@
             <a:r>
               <a:rPr lang="en-US" sz="1000" b="1" spc="100" kern="0" dirty="0">
                 <a:solidFill>
-                  <a:srgbClr val="C9682B"/>
+                  <a:srgbClr val="C6821E"/>
                 </a:solidFill>
                 <a:latin typeface="Calibri" pitchFamily="34" charset="0"/>
                 <a:ea typeface="Calibri" pitchFamily="34" charset="-122"/>
@@ -3193,7 +3193,7 @@
             <a:r>
               <a:rPr lang="en-US" sz="1150" dirty="0">
                 <a:solidFill>
-                  <a:srgbClr val="2E2119"/>
+                  <a:srgbClr val="26402C"/>
                 </a:solidFill>
                 <a:latin typeface="Calibri" pitchFamily="34" charset="0"/>
                 <a:ea typeface="Calibri" pitchFamily="34" charset="-122"/>
@@ -3222,7 +3222,7 @@
             </a:avLst>
           </a:prstGeom>
           <a:solidFill>
-            <a:srgbClr val="F4E9DA"/>
+            <a:srgbClr val="F2EFE7"/>
           </a:solidFill>
           <a:ln/>
           <a:effectLst>
@@ -3261,7 +3261,7 @@
             <a:r>
               <a:rPr lang="en-US" sz="1000" b="1" spc="100" kern="0" dirty="0">
                 <a:solidFill>
-                  <a:srgbClr val="C9682B"/>
+                  <a:srgbClr val="C6821E"/>
                 </a:solidFill>
                 <a:latin typeface="Calibri" pitchFamily="34" charset="0"/>
                 <a:ea typeface="Calibri" pitchFamily="34" charset="-122"/>
@@ -3300,7 +3300,7 @@
             <a:r>
               <a:rPr lang="en-US" sz="1150" dirty="0">
                 <a:solidFill>
-                  <a:srgbClr val="2E2119"/>
+                  <a:srgbClr val="26402C"/>
                 </a:solidFill>
                 <a:latin typeface="Calibri" pitchFamily="34" charset="0"/>
                 <a:ea typeface="Calibri" pitchFamily="34" charset="-122"/>
@@ -3329,7 +3329,7 @@
             </a:avLst>
           </a:prstGeom>
           <a:solidFill>
-            <a:srgbClr val="F4E9DA"/>
+            <a:srgbClr val="F2EFE7"/>
           </a:solidFill>
           <a:ln/>
           <a:effectLst>
@@ -3368,7 +3368,7 @@
             <a:r>
               <a:rPr lang="en-US" sz="1000" b="1" spc="100" kern="0" dirty="0">
                 <a:solidFill>
-                  <a:srgbClr val="C9682B"/>
+                  <a:srgbClr val="C6821E"/>
                 </a:solidFill>
                 <a:latin typeface="Calibri" pitchFamily="34" charset="0"/>
                 <a:ea typeface="Calibri" pitchFamily="34" charset="-122"/>
@@ -3407,7 +3407,7 @@
             <a:r>
               <a:rPr lang="en-US" sz="1150" dirty="0">
                 <a:solidFill>
-                  <a:srgbClr val="2E2119"/>
+                  <a:srgbClr val="26402C"/>
                 </a:solidFill>
                 <a:latin typeface="Calibri" pitchFamily="34" charset="0"/>
                 <a:ea typeface="Calibri" pitchFamily="34" charset="-122"/>
@@ -3436,7 +3436,7 @@
             </a:avLst>
           </a:prstGeom>
           <a:solidFill>
-            <a:srgbClr val="F4E9DA"/>
+            <a:srgbClr val="F2EFE7"/>
           </a:solidFill>
           <a:ln/>
           <a:effectLst>
@@ -3475,7 +3475,7 @@
             <a:r>
               <a:rPr lang="en-US" sz="1000" b="1" spc="100" kern="0" dirty="0">
                 <a:solidFill>
-                  <a:srgbClr val="C9682B"/>
+                  <a:srgbClr val="C6821E"/>
                 </a:solidFill>
                 <a:latin typeface="Calibri" pitchFamily="34" charset="0"/>
                 <a:ea typeface="Calibri" pitchFamily="34" charset="-122"/>
@@ -3514,7 +3514,7 @@
             <a:r>
               <a:rPr lang="en-US" sz="1150" dirty="0">
                 <a:solidFill>
-                  <a:srgbClr val="2E2119"/>
+                  <a:srgbClr val="26402C"/>
                 </a:solidFill>
                 <a:latin typeface="Calibri" pitchFamily="34" charset="0"/>
                 <a:ea typeface="Calibri" pitchFamily="34" charset="-122"/>
@@ -3543,7 +3543,7 @@
             </a:avLst>
           </a:prstGeom>
           <a:solidFill>
-            <a:srgbClr val="F4E9DA"/>
+            <a:srgbClr val="F2EFE7"/>
           </a:solidFill>
           <a:ln/>
           <a:effectLst>
@@ -3582,7 +3582,7 @@
             <a:r>
               <a:rPr lang="en-US" sz="1000" b="1" spc="100" kern="0" dirty="0">
                 <a:solidFill>
-                  <a:srgbClr val="C9682B"/>
+                  <a:srgbClr val="C6821E"/>
                 </a:solidFill>
                 <a:latin typeface="Calibri" pitchFamily="34" charset="0"/>
                 <a:ea typeface="Calibri" pitchFamily="34" charset="-122"/>
@@ -3621,7 +3621,7 @@
             <a:r>
               <a:rPr lang="en-US" sz="1150" dirty="0">
                 <a:solidFill>
-                  <a:srgbClr val="2E2119"/>
+                  <a:srgbClr val="26402C"/>
                 </a:solidFill>
                 <a:latin typeface="Calibri" pitchFamily="34" charset="0"/>
                 <a:ea typeface="Calibri" pitchFamily="34" charset="-122"/>
@@ -3650,7 +3650,7 @@
             </a:avLst>
           </a:prstGeom>
           <a:solidFill>
-            <a:srgbClr val="F4E9DA"/>
+            <a:srgbClr val="F2EFE7"/>
           </a:solidFill>
           <a:ln/>
           <a:effectLst>
@@ -3689,7 +3689,7 @@
             <a:r>
               <a:rPr lang="en-US" sz="1000" b="1" spc="100" kern="0" dirty="0">
                 <a:solidFill>
-                  <a:srgbClr val="C9682B"/>
+                  <a:srgbClr val="C6821E"/>
                 </a:solidFill>
                 <a:latin typeface="Calibri" pitchFamily="34" charset="0"/>
                 <a:ea typeface="Calibri" pitchFamily="34" charset="-122"/>
@@ -3728,7 +3728,7 @@
             <a:r>
               <a:rPr lang="en-US" sz="1150" dirty="0">
                 <a:solidFill>
-                  <a:srgbClr val="2E2119"/>
+                  <a:srgbClr val="26402C"/>
                 </a:solidFill>
                 <a:latin typeface="Calibri" pitchFamily="34" charset="0"/>
                 <a:ea typeface="Calibri" pitchFamily="34" charset="-122"/>
@@ -3757,7 +3757,7 @@
             </a:avLst>
           </a:prstGeom>
           <a:solidFill>
-            <a:srgbClr val="2E2119"/>
+            <a:srgbClr val="26402C"/>
           </a:solidFill>
           <a:ln/>
         </p:spPr>
@@ -3789,7 +3789,7 @@
             <a:r>
               <a:rPr lang="en-US" sz="3400" b="1" dirty="0">
                 <a:solidFill>
-                  <a:srgbClr val="D9A441"/>
+                  <a:srgbClr val="E3A94A"/>
                 </a:solidFill>
                 <a:latin typeface="Cambria" pitchFamily="34" charset="0"/>
                 <a:ea typeface="Cambria" pitchFamily="34" charset="-122"/>
@@ -3857,11 +3857,11 @@
             </a:avLst>
           </a:prstGeom>
           <a:solidFill>
-            <a:srgbClr val="F6E9D8"/>
+            <a:srgbClr val="F0E0BE"/>
           </a:solidFill>
           <a:ln w="12700">
             <a:solidFill>
-              <a:srgbClr val="C9682B"/>
+              <a:srgbClr val="C6821E"/>
             </a:solidFill>
             <a:prstDash val="solid"/>
           </a:ln>
@@ -3894,7 +3894,7 @@
             <a:r>
               <a:rPr lang="en-US" sz="1150" i="1" dirty="0">
                 <a:solidFill>
-                  <a:srgbClr val="2E2119"/>
+                  <a:srgbClr val="26402C"/>
                 </a:solidFill>
                 <a:latin typeface="Calibri" pitchFamily="34" charset="0"/>
                 <a:ea typeface="Calibri" pitchFamily="34" charset="-122"/>
@@ -3933,7 +3933,7 @@
             <a:r>
               <a:rPr lang="en-US" sz="1000" i="1" dirty="0">
                 <a:solidFill>
-                  <a:srgbClr val="8A7A6D"/>
+                  <a:srgbClr val="5B6559"/>
                 </a:solidFill>
                 <a:latin typeface="Calibri" pitchFamily="34" charset="0"/>
                 <a:ea typeface="Calibri" pitchFamily="34" charset="-122"/>
@@ -3992,7 +3992,7 @@
             <a:avLst/>
           </a:prstGeom>
           <a:solidFill>
-            <a:srgbClr val="C9682B"/>
+            <a:srgbClr val="C6821E"/>
           </a:solidFill>
           <a:ln/>
         </p:spPr>
@@ -4048,7 +4048,7 @@
             <a:r>
               <a:rPr lang="en-US" sz="1200" b="1" spc="200" kern="0" dirty="0">
                 <a:solidFill>
-                  <a:srgbClr val="C9682B"/>
+                  <a:srgbClr val="C6821E"/>
                 </a:solidFill>
                 <a:latin typeface="Calibri" pitchFamily="34" charset="0"/>
                 <a:ea typeface="Calibri" pitchFamily="34" charset="-122"/>
@@ -4087,7 +4087,7 @@
             <a:r>
               <a:rPr lang="en-US" sz="2800" b="1" dirty="0">
                 <a:solidFill>
-                  <a:srgbClr val="2E2119"/>
+                  <a:srgbClr val="26402C"/>
                 </a:solidFill>
                 <a:latin typeface="Cambria" pitchFamily="34" charset="0"/>
                 <a:ea typeface="Cambria" pitchFamily="34" charset="-122"/>
@@ -4116,7 +4116,7 @@
             </a:avLst>
           </a:prstGeom>
           <a:solidFill>
-            <a:srgbClr val="F6E4D3"/>
+            <a:srgbClr val="ECD9B8"/>
           </a:solidFill>
           <a:ln/>
           <a:effectLst>
@@ -4145,7 +4145,7 @@
             </a:avLst>
           </a:prstGeom>
           <a:solidFill>
-            <a:srgbClr val="C9682B"/>
+            <a:srgbClr val="C6821E"/>
           </a:solidFill>
           <a:ln/>
         </p:spPr>
@@ -4220,7 +4220,7 @@
             <a:r>
               <a:rPr lang="en-US" sz="1000" dirty="0">
                 <a:solidFill>
-                  <a:srgbClr val="2E2119"/>
+                  <a:srgbClr val="26402C"/>
                 </a:solidFill>
                 <a:latin typeface="Calibri" pitchFamily="34" charset="0"/>
                 <a:ea typeface="Calibri" pitchFamily="34" charset="-122"/>
@@ -4241,7 +4241,7 @@
             <a:r>
               <a:rPr lang="en-US" sz="1000" dirty="0">
                 <a:solidFill>
-                  <a:srgbClr val="2E2119"/>
+                  <a:srgbClr val="26402C"/>
                 </a:solidFill>
                 <a:latin typeface="Calibri" pitchFamily="34" charset="0"/>
                 <a:ea typeface="Calibri" pitchFamily="34" charset="-122"/>
@@ -4262,7 +4262,7 @@
             <a:r>
               <a:rPr lang="en-US" sz="1000" dirty="0">
                 <a:solidFill>
-                  <a:srgbClr val="2E2119"/>
+                  <a:srgbClr val="26402C"/>
                 </a:solidFill>
                 <a:latin typeface="Calibri" pitchFamily="34" charset="0"/>
                 <a:ea typeface="Calibri" pitchFamily="34" charset="-122"/>
@@ -4283,7 +4283,7 @@
             <a:r>
               <a:rPr lang="en-US" sz="1000" dirty="0">
                 <a:solidFill>
-                  <a:srgbClr val="2E2119"/>
+                  <a:srgbClr val="26402C"/>
                 </a:solidFill>
                 <a:latin typeface="Calibri" pitchFamily="34" charset="0"/>
                 <a:ea typeface="Calibri" pitchFamily="34" charset="-122"/>
@@ -4304,7 +4304,7 @@
             <a:r>
               <a:rPr lang="en-US" sz="1000" dirty="0">
                 <a:solidFill>
-                  <a:srgbClr val="2E2119"/>
+                  <a:srgbClr val="26402C"/>
                 </a:solidFill>
                 <a:latin typeface="Calibri" pitchFamily="34" charset="0"/>
                 <a:ea typeface="Calibri" pitchFamily="34" charset="-122"/>
@@ -4333,7 +4333,7 @@
             </a:avLst>
           </a:prstGeom>
           <a:solidFill>
-            <a:srgbClr val="F4EFE8"/>
+            <a:srgbClr val="EDEAE1"/>
           </a:solidFill>
           <a:ln/>
           <a:effectLst>
@@ -4362,7 +4362,7 @@
             </a:avLst>
           </a:prstGeom>
           <a:solidFill>
-            <a:srgbClr val="D9A441"/>
+            <a:srgbClr val="E3A94A"/>
           </a:solidFill>
           <a:ln/>
         </p:spPr>
@@ -4437,7 +4437,7 @@
             <a:r>
               <a:rPr lang="en-US" sz="1000" dirty="0">
                 <a:solidFill>
-                  <a:srgbClr val="2E2119"/>
+                  <a:srgbClr val="26402C"/>
                 </a:solidFill>
                 <a:latin typeface="Calibri" pitchFamily="34" charset="0"/>
                 <a:ea typeface="Calibri" pitchFamily="34" charset="-122"/>
@@ -4458,7 +4458,7 @@
             <a:r>
               <a:rPr lang="en-US" sz="1000" dirty="0">
                 <a:solidFill>
-                  <a:srgbClr val="2E2119"/>
+                  <a:srgbClr val="26402C"/>
                 </a:solidFill>
                 <a:latin typeface="Calibri" pitchFamily="34" charset="0"/>
                 <a:ea typeface="Calibri" pitchFamily="34" charset="-122"/>
@@ -4479,7 +4479,7 @@
             <a:r>
               <a:rPr lang="en-US" sz="1000" dirty="0">
                 <a:solidFill>
-                  <a:srgbClr val="2E2119"/>
+                  <a:srgbClr val="26402C"/>
                 </a:solidFill>
                 <a:latin typeface="Calibri" pitchFamily="34" charset="0"/>
                 <a:ea typeface="Calibri" pitchFamily="34" charset="-122"/>
@@ -4508,7 +4508,7 @@
             </a:avLst>
           </a:prstGeom>
           <a:solidFill>
-            <a:srgbClr val="F4EFE8"/>
+            <a:srgbClr val="EDEAE1"/>
           </a:solidFill>
           <a:ln/>
           <a:effectLst>
@@ -4537,7 +4537,7 @@
             </a:avLst>
           </a:prstGeom>
           <a:solidFill>
-            <a:srgbClr val="8A7A6D"/>
+            <a:srgbClr val="5B6559"/>
           </a:solidFill>
           <a:ln/>
         </p:spPr>
@@ -4612,7 +4612,7 @@
             <a:r>
               <a:rPr lang="en-US" sz="1000" dirty="0">
                 <a:solidFill>
-                  <a:srgbClr val="2E2119"/>
+                  <a:srgbClr val="26402C"/>
                 </a:solidFill>
                 <a:latin typeface="Calibri" pitchFamily="34" charset="0"/>
                 <a:ea typeface="Calibri" pitchFamily="34" charset="-122"/>
@@ -4633,7 +4633,7 @@
             <a:r>
               <a:rPr lang="en-US" sz="1000" dirty="0">
                 <a:solidFill>
-                  <a:srgbClr val="2E2119"/>
+                  <a:srgbClr val="26402C"/>
                 </a:solidFill>
                 <a:latin typeface="Calibri" pitchFamily="34" charset="0"/>
                 <a:ea typeface="Calibri" pitchFamily="34" charset="-122"/>
@@ -4654,7 +4654,7 @@
             <a:r>
               <a:rPr lang="en-US" sz="1000" dirty="0">
                 <a:solidFill>
-                  <a:srgbClr val="2E2119"/>
+                  <a:srgbClr val="26402C"/>
                 </a:solidFill>
                 <a:latin typeface="Calibri" pitchFamily="34" charset="0"/>
                 <a:ea typeface="Calibri" pitchFamily="34" charset="-122"/>
@@ -4675,7 +4675,7 @@
             <a:r>
               <a:rPr lang="en-US" sz="1000" dirty="0">
                 <a:solidFill>
-                  <a:srgbClr val="2E2119"/>
+                  <a:srgbClr val="26402C"/>
                 </a:solidFill>
                 <a:latin typeface="Calibri" pitchFamily="34" charset="0"/>
                 <a:ea typeface="Calibri" pitchFamily="34" charset="-122"/>
@@ -4704,7 +4704,7 @@
             </a:avLst>
           </a:prstGeom>
           <a:solidFill>
-            <a:srgbClr val="2E2119"/>
+            <a:srgbClr val="26402C"/>
           </a:solidFill>
           <a:ln/>
         </p:spPr>
@@ -4736,7 +4736,7 @@
             <a:r>
               <a:rPr lang="en-US" sz="1250" i="1" dirty="0">
                 <a:solidFill>
-                  <a:srgbClr val="D9A441"/>
+                  <a:srgbClr val="E3A94A"/>
                 </a:solidFill>
                 <a:latin typeface="Calibri" pitchFamily="34" charset="0"/>
                 <a:ea typeface="Calibri" pitchFamily="34" charset="-122"/>
@@ -4775,7 +4775,7 @@
             <a:r>
               <a:rPr lang="en-US" sz="1100" dirty="0">
                 <a:solidFill>
-                  <a:srgbClr val="D8CBBE"/>
+                  <a:srgbClr val="C7D0C2"/>
                 </a:solidFill>
                 <a:latin typeface="Calibri" pitchFamily="34" charset="0"/>
                 <a:ea typeface="Calibri" pitchFamily="34" charset="-122"/>
@@ -4834,7 +4834,7 @@
             <a:avLst/>
           </a:prstGeom>
           <a:solidFill>
-            <a:srgbClr val="C9682B"/>
+            <a:srgbClr val="C6821E"/>
           </a:solidFill>
           <a:ln/>
         </p:spPr>
@@ -4890,7 +4890,7 @@
             <a:r>
               <a:rPr lang="en-US" sz="1200" b="1" spc="200" kern="0" dirty="0">
                 <a:solidFill>
-                  <a:srgbClr val="C9682B"/>
+                  <a:srgbClr val="C6821E"/>
                 </a:solidFill>
                 <a:latin typeface="Calibri" pitchFamily="34" charset="0"/>
                 <a:ea typeface="Calibri" pitchFamily="34" charset="-122"/>
@@ -4929,7 +4929,7 @@
             <a:r>
               <a:rPr lang="en-US" sz="2800" b="1" dirty="0">
                 <a:solidFill>
-                  <a:srgbClr val="2E2119"/>
+                  <a:srgbClr val="26402C"/>
                 </a:solidFill>
                 <a:latin typeface="Cambria" pitchFamily="34" charset="0"/>
                 <a:ea typeface="Cambria" pitchFamily="34" charset="-122"/>
@@ -4958,7 +4958,7 @@
             </a:avLst>
           </a:prstGeom>
           <a:solidFill>
-            <a:srgbClr val="F4E9DA"/>
+            <a:srgbClr val="F2EFE7"/>
           </a:solidFill>
           <a:ln/>
           <a:effectLst>
@@ -4997,7 +4997,7 @@
             <a:r>
               <a:rPr lang="en-US" sz="1000" b="1" spc="100" kern="0" dirty="0">
                 <a:solidFill>
-                  <a:srgbClr val="C9682B"/>
+                  <a:srgbClr val="C6821E"/>
                 </a:solidFill>
                 <a:latin typeface="Calibri" pitchFamily="34" charset="0"/>
                 <a:ea typeface="Calibri" pitchFamily="34" charset="-122"/>
@@ -5036,7 +5036,7 @@
             <a:r>
               <a:rPr lang="en-US" sz="1100" dirty="0">
                 <a:solidFill>
-                  <a:srgbClr val="2E2119"/>
+                  <a:srgbClr val="26402C"/>
                 </a:solidFill>
                 <a:latin typeface="Calibri" pitchFamily="34" charset="0"/>
                 <a:ea typeface="Calibri" pitchFamily="34" charset="-122"/>
@@ -5065,7 +5065,7 @@
             </a:avLst>
           </a:prstGeom>
           <a:solidFill>
-            <a:srgbClr val="EDE6DC"/>
+            <a:srgbClr val="E3E8DD"/>
           </a:solidFill>
           <a:ln/>
           <a:effectLst>
@@ -5104,7 +5104,7 @@
             <a:r>
               <a:rPr lang="en-US" sz="1000" b="1" spc="100" kern="0" dirty="0">
                 <a:solidFill>
-                  <a:srgbClr val="C9682B"/>
+                  <a:srgbClr val="C6821E"/>
                 </a:solidFill>
                 <a:latin typeface="Calibri" pitchFamily="34" charset="0"/>
                 <a:ea typeface="Calibri" pitchFamily="34" charset="-122"/>
@@ -5143,7 +5143,7 @@
             <a:r>
               <a:rPr lang="en-US" sz="1100" dirty="0">
                 <a:solidFill>
-                  <a:srgbClr val="2E2119"/>
+                  <a:srgbClr val="26402C"/>
                 </a:solidFill>
                 <a:latin typeface="Calibri" pitchFamily="34" charset="0"/>
                 <a:ea typeface="Calibri" pitchFamily="34" charset="-122"/>
@@ -5172,7 +5172,7 @@
             </a:avLst>
           </a:prstGeom>
           <a:solidFill>
-            <a:srgbClr val="F4E9DA"/>
+            <a:srgbClr val="F2EFE7"/>
           </a:solidFill>
           <a:ln/>
           <a:effectLst>
@@ -5211,7 +5211,7 @@
             <a:r>
               <a:rPr lang="en-US" sz="1000" b="1" spc="100" kern="0" dirty="0">
                 <a:solidFill>
-                  <a:srgbClr val="C9682B"/>
+                  <a:srgbClr val="C6821E"/>
                 </a:solidFill>
                 <a:latin typeface="Calibri" pitchFamily="34" charset="0"/>
                 <a:ea typeface="Calibri" pitchFamily="34" charset="-122"/>
@@ -5250,7 +5250,7 @@
             <a:r>
               <a:rPr lang="en-US" sz="1100" dirty="0">
                 <a:solidFill>
-                  <a:srgbClr val="2E2119"/>
+                  <a:srgbClr val="26402C"/>
                 </a:solidFill>
                 <a:latin typeface="Calibri" pitchFamily="34" charset="0"/>
                 <a:ea typeface="Calibri" pitchFamily="34" charset="-122"/>
@@ -5279,7 +5279,7 @@
             </a:avLst>
           </a:prstGeom>
           <a:solidFill>
-            <a:srgbClr val="EDE6DC"/>
+            <a:srgbClr val="E3E8DD"/>
           </a:solidFill>
           <a:ln/>
           <a:effectLst>
@@ -5318,7 +5318,7 @@
             <a:r>
               <a:rPr lang="en-US" sz="1000" b="1" spc="100" kern="0" dirty="0">
                 <a:solidFill>
-                  <a:srgbClr val="C9682B"/>
+                  <a:srgbClr val="C6821E"/>
                 </a:solidFill>
                 <a:latin typeface="Calibri" pitchFamily="34" charset="0"/>
                 <a:ea typeface="Calibri" pitchFamily="34" charset="-122"/>
@@ -5357,7 +5357,7 @@
             <a:r>
               <a:rPr lang="en-US" sz="1100" dirty="0">
                 <a:solidFill>
-                  <a:srgbClr val="2E2119"/>
+                  <a:srgbClr val="26402C"/>
                 </a:solidFill>
                 <a:latin typeface="Calibri" pitchFamily="34" charset="0"/>
                 <a:ea typeface="Calibri" pitchFamily="34" charset="-122"/>
@@ -5386,7 +5386,7 @@
             </a:avLst>
           </a:prstGeom>
           <a:solidFill>
-            <a:srgbClr val="F4E9DA"/>
+            <a:srgbClr val="F2EFE7"/>
           </a:solidFill>
           <a:ln/>
           <a:effectLst>
@@ -5425,7 +5425,7 @@
             <a:r>
               <a:rPr lang="en-US" sz="1000" b="1" spc="100" kern="0" dirty="0">
                 <a:solidFill>
-                  <a:srgbClr val="C9682B"/>
+                  <a:srgbClr val="C6821E"/>
                 </a:solidFill>
                 <a:latin typeface="Calibri" pitchFamily="34" charset="0"/>
                 <a:ea typeface="Calibri" pitchFamily="34" charset="-122"/>
@@ -5464,7 +5464,7 @@
             <a:r>
               <a:rPr lang="en-US" sz="1100" dirty="0">
                 <a:solidFill>
-                  <a:srgbClr val="2E2119"/>
+                  <a:srgbClr val="26402C"/>
                 </a:solidFill>
                 <a:latin typeface="Calibri" pitchFamily="34" charset="0"/>
                 <a:ea typeface="Calibri" pitchFamily="34" charset="-122"/>
@@ -5493,7 +5493,7 @@
             </a:avLst>
           </a:prstGeom>
           <a:solidFill>
-            <a:srgbClr val="EDE6DC"/>
+            <a:srgbClr val="E3E8DD"/>
           </a:solidFill>
           <a:ln/>
           <a:effectLst>
@@ -5532,7 +5532,7 @@
             <a:r>
               <a:rPr lang="en-US" sz="1000" b="1" spc="100" kern="0" dirty="0">
                 <a:solidFill>
-                  <a:srgbClr val="C9682B"/>
+                  <a:srgbClr val="C6821E"/>
                 </a:solidFill>
                 <a:latin typeface="Calibri" pitchFamily="34" charset="0"/>
                 <a:ea typeface="Calibri" pitchFamily="34" charset="-122"/>
@@ -5571,7 +5571,7 @@
             <a:r>
               <a:rPr lang="en-US" sz="1100" dirty="0">
                 <a:solidFill>
-                  <a:srgbClr val="2E2119"/>
+                  <a:srgbClr val="26402C"/>
                 </a:solidFill>
                 <a:latin typeface="Calibri" pitchFamily="34" charset="0"/>
                 <a:ea typeface="Calibri" pitchFamily="34" charset="-122"/>
@@ -5600,7 +5600,7 @@
             </a:avLst>
           </a:prstGeom>
           <a:solidFill>
-            <a:srgbClr val="F4E9DA"/>
+            <a:srgbClr val="F2EFE7"/>
           </a:solidFill>
           <a:ln/>
           <a:effectLst>
@@ -5639,7 +5639,7 @@
             <a:r>
               <a:rPr lang="en-US" sz="1000" b="1" spc="100" kern="0" dirty="0">
                 <a:solidFill>
-                  <a:srgbClr val="C9682B"/>
+                  <a:srgbClr val="C6821E"/>
                 </a:solidFill>
                 <a:latin typeface="Calibri" pitchFamily="34" charset="0"/>
                 <a:ea typeface="Calibri" pitchFamily="34" charset="-122"/>
@@ -5678,7 +5678,7 @@
             <a:r>
               <a:rPr lang="en-US" sz="1100" dirty="0">
                 <a:solidFill>
-                  <a:srgbClr val="2E2119"/>
+                  <a:srgbClr val="26402C"/>
                 </a:solidFill>
                 <a:latin typeface="Calibri" pitchFamily="34" charset="0"/>
                 <a:ea typeface="Calibri" pitchFamily="34" charset="-122"/>
@@ -5704,7 +5704,7 @@
     <p:bg>
       <p:bgPr>
         <a:solidFill>
-          <a:srgbClr val="2E2119"/>
+          <a:srgbClr val="26402C"/>
         </a:solidFill>
       </p:bgPr>
     </p:bg>
@@ -5737,7 +5737,7 @@
             <a:avLst/>
           </a:prstGeom>
           <a:solidFill>
-            <a:srgbClr val="C9682B"/>
+            <a:srgbClr val="C6821E"/>
           </a:solidFill>
           <a:ln/>
         </p:spPr>
@@ -5836,7 +5836,7 @@
             <a:r>
               <a:rPr lang="en-US" sz="1600" dirty="0">
                 <a:solidFill>
-                  <a:srgbClr val="EFE6DA"/>
+                  <a:srgbClr val="DCE3D6"/>
                 </a:solidFill>
                 <a:latin typeface="Calibri" pitchFamily="34" charset="0"/>
                 <a:ea typeface="Calibri" pitchFamily="34" charset="-122"/>
@@ -5857,7 +5857,7 @@
             <a:r>
               <a:rPr lang="en-US" sz="1600" dirty="0">
                 <a:solidFill>
-                  <a:srgbClr val="EFE6DA"/>
+                  <a:srgbClr val="DCE3D6"/>
                 </a:solidFill>
                 <a:latin typeface="Calibri" pitchFamily="34" charset="0"/>
                 <a:ea typeface="Calibri" pitchFamily="34" charset="-122"/>
@@ -5878,7 +5878,7 @@
             <a:r>
               <a:rPr lang="en-US" sz="1600" dirty="0">
                 <a:solidFill>
-                  <a:srgbClr val="EFE6DA"/>
+                  <a:srgbClr val="DCE3D6"/>
                 </a:solidFill>
                 <a:latin typeface="Calibri" pitchFamily="34" charset="0"/>
                 <a:ea typeface="Calibri" pitchFamily="34" charset="-122"/>
@@ -5899,7 +5899,7 @@
             <a:r>
               <a:rPr lang="en-US" sz="1600" dirty="0">
                 <a:solidFill>
-                  <a:srgbClr val="EFE6DA"/>
+                  <a:srgbClr val="DCE3D6"/>
                 </a:solidFill>
                 <a:latin typeface="Calibri" pitchFamily="34" charset="0"/>
                 <a:ea typeface="Calibri" pitchFamily="34" charset="-122"/>
@@ -5920,7 +5920,7 @@
             <a:r>
               <a:rPr lang="en-US" sz="1600" dirty="0">
                 <a:solidFill>
-                  <a:srgbClr val="EFE6DA"/>
+                  <a:srgbClr val="DCE3D6"/>
                 </a:solidFill>
                 <a:latin typeface="Calibri" pitchFamily="34" charset="0"/>
                 <a:ea typeface="Calibri" pitchFamily="34" charset="-122"/>
@@ -5949,7 +5949,7 @@
             </a:avLst>
           </a:prstGeom>
           <a:solidFill>
-            <a:srgbClr val="3D2E23"/>
+            <a:srgbClr val="33513A"/>
           </a:solidFill>
           <a:ln/>
         </p:spPr>
@@ -5981,7 +5981,7 @@
             <a:r>
               <a:rPr lang="en-US" sz="1250" i="1" dirty="0">
                 <a:solidFill>
-                  <a:srgbClr val="D9A441"/>
+                  <a:srgbClr val="E3A94A"/>
                 </a:solidFill>
                 <a:latin typeface="Calibri" pitchFamily="34" charset="0"/>
                 <a:ea typeface="Calibri" pitchFamily="34" charset="-122"/>
@@ -6040,7 +6040,7 @@
             <a:avLst/>
           </a:prstGeom>
           <a:solidFill>
-            <a:srgbClr val="C9682B"/>
+            <a:srgbClr val="C6821E"/>
           </a:solidFill>
           <a:ln/>
         </p:spPr>
@@ -6096,7 +6096,7 @@
             <a:r>
               <a:rPr lang="en-US" sz="1200" b="1" spc="200" kern="0" dirty="0">
                 <a:solidFill>
-                  <a:srgbClr val="C9682B"/>
+                  <a:srgbClr val="C6821E"/>
                 </a:solidFill>
                 <a:latin typeface="Calibri" pitchFamily="34" charset="0"/>
                 <a:ea typeface="Calibri" pitchFamily="34" charset="-122"/>
@@ -6135,7 +6135,7 @@
             <a:r>
               <a:rPr lang="en-US" sz="2800" b="1" dirty="0">
                 <a:solidFill>
-                  <a:srgbClr val="2E2119"/>
+                  <a:srgbClr val="26402C"/>
                 </a:solidFill>
                 <a:latin typeface="Cambria" pitchFamily="34" charset="0"/>
                 <a:ea typeface="Cambria" pitchFamily="34" charset="-122"/>
@@ -6164,7 +6164,7 @@
             </a:avLst>
           </a:prstGeom>
           <a:solidFill>
-            <a:srgbClr val="EDE6DC"/>
+            <a:srgbClr val="E3E8DD"/>
           </a:solidFill>
           <a:ln/>
           <a:effectLst>
@@ -6203,7 +6203,7 @@
             <a:r>
               <a:rPr lang="en-US" sz="1200" b="1" spc="200" kern="0" dirty="0">
                 <a:solidFill>
-                  <a:srgbClr val="8A7A6D"/>
+                  <a:srgbClr val="5B6559"/>
                 </a:solidFill>
                 <a:latin typeface="Calibri" pitchFamily="34" charset="0"/>
                 <a:ea typeface="Calibri" pitchFamily="34" charset="-122"/>
@@ -6242,7 +6242,7 @@
             <a:r>
               <a:rPr lang="en-US" sz="1500" i="1" dirty="0">
                 <a:solidFill>
-                  <a:srgbClr val="2E2119"/>
+                  <a:srgbClr val="26402C"/>
                 </a:solidFill>
                 <a:latin typeface="Calibri" pitchFamily="34" charset="0"/>
                 <a:ea typeface="Calibri" pitchFamily="34" charset="-122"/>
@@ -6271,7 +6271,7 @@
             </a:avLst>
           </a:prstGeom>
           <a:solidFill>
-            <a:srgbClr val="F4E9DA"/>
+            <a:srgbClr val="F2EFE7"/>
           </a:solidFill>
           <a:ln/>
           <a:effectLst>
@@ -6310,7 +6310,7 @@
             <a:r>
               <a:rPr lang="en-US" sz="1200" b="1" spc="100" kern="0" dirty="0">
                 <a:solidFill>
-                  <a:srgbClr val="C9682B"/>
+                  <a:srgbClr val="C6821E"/>
                 </a:solidFill>
                 <a:latin typeface="Calibri" pitchFamily="34" charset="0"/>
                 <a:ea typeface="Calibri" pitchFamily="34" charset="-122"/>
@@ -6349,7 +6349,7 @@
             <a:r>
               <a:rPr lang="en-US" sz="1350" dirty="0">
                 <a:solidFill>
-                  <a:srgbClr val="2E2119"/>
+                  <a:srgbClr val="26402C"/>
                 </a:solidFill>
                 <a:latin typeface="Calibri" pitchFamily="34" charset="0"/>
                 <a:ea typeface="Calibri" pitchFamily="34" charset="-122"/>
@@ -6378,7 +6378,7 @@
             </a:avLst>
           </a:prstGeom>
           <a:solidFill>
-            <a:srgbClr val="2E2119"/>
+            <a:srgbClr val="26402C"/>
           </a:solidFill>
           <a:ln/>
         </p:spPr>
@@ -6410,7 +6410,7 @@
             <a:r>
               <a:rPr lang="en-US" sz="4000" b="1" dirty="0">
                 <a:solidFill>
-                  <a:srgbClr val="D9A441"/>
+                  <a:srgbClr val="E3A94A"/>
                 </a:solidFill>
                 <a:latin typeface="Cambria" pitchFamily="34" charset="0"/>
                 <a:ea typeface="Cambria" pitchFamily="34" charset="-122"/>
@@ -6488,7 +6488,7 @@
             <a:r>
               <a:rPr lang="en-US" sz="1300" b="1" dirty="0">
                 <a:solidFill>
-                  <a:srgbClr val="2E2119"/>
+                  <a:srgbClr val="26402C"/>
                 </a:solidFill>
                 <a:latin typeface="Calibri" pitchFamily="34" charset="0"/>
                 <a:ea typeface="Calibri" pitchFamily="34" charset="-122"/>
@@ -6508,7 +6508,7 @@
             <a:r>
               <a:rPr lang="en-US" sz="1300" dirty="0">
                 <a:solidFill>
-                  <a:srgbClr val="2E2119"/>
+                  <a:srgbClr val="26402C"/>
                 </a:solidFill>
                 <a:latin typeface="Calibri" pitchFamily="34" charset="0"/>
                 <a:ea typeface="Calibri" pitchFamily="34" charset="-122"/>
@@ -6525,7 +6525,7 @@
             <a:r>
               <a:rPr lang="en-US" sz="1300" b="1" dirty="0">
                 <a:solidFill>
-                  <a:srgbClr val="2E2119"/>
+                  <a:srgbClr val="26402C"/>
                 </a:solidFill>
                 <a:latin typeface="Calibri" pitchFamily="34" charset="0"/>
                 <a:ea typeface="Calibri" pitchFamily="34" charset="-122"/>
@@ -6542,7 +6542,7 @@
             <a:r>
               <a:rPr lang="en-US" sz="1300" dirty="0">
                 <a:solidFill>
-                  <a:srgbClr val="2E2119"/>
+                  <a:srgbClr val="26402C"/>
                 </a:solidFill>
                 <a:latin typeface="Calibri" pitchFamily="34" charset="0"/>
                 <a:ea typeface="Calibri" pitchFamily="34" charset="-122"/>
@@ -6601,7 +6601,7 @@
             <a:avLst/>
           </a:prstGeom>
           <a:solidFill>
-            <a:srgbClr val="C9682B"/>
+            <a:srgbClr val="C6821E"/>
           </a:solidFill>
           <a:ln/>
         </p:spPr>
@@ -6657,7 +6657,7 @@
             <a:r>
               <a:rPr lang="en-US" sz="1200" b="1" spc="200" kern="0" dirty="0">
                 <a:solidFill>
-                  <a:srgbClr val="C9682B"/>
+                  <a:srgbClr val="C6821E"/>
                 </a:solidFill>
                 <a:latin typeface="Calibri" pitchFamily="34" charset="0"/>
                 <a:ea typeface="Calibri" pitchFamily="34" charset="-122"/>
@@ -6696,7 +6696,7 @@
             <a:r>
               <a:rPr lang="en-US" sz="2800" b="1" dirty="0">
                 <a:solidFill>
-                  <a:srgbClr val="2E2119"/>
+                  <a:srgbClr val="26402C"/>
                 </a:solidFill>
                 <a:latin typeface="Cambria" pitchFamily="34" charset="0"/>
                 <a:ea typeface="Cambria" pitchFamily="34" charset="-122"/>
@@ -6735,7 +6735,7 @@
             <a:r>
               <a:rPr lang="en-US" sz="1000" i="1" dirty="0">
                 <a:solidFill>
-                  <a:srgbClr val="8A7A6D"/>
+                  <a:srgbClr val="5B6559"/>
                 </a:solidFill>
                 <a:latin typeface="Calibri" pitchFamily="34" charset="0"/>
                 <a:ea typeface="Calibri" pitchFamily="34" charset="-122"/>
@@ -6804,7 +6804,7 @@
                   <a:tcPr marL="91440" marR="91440" marT="45720" marB="45720" anchor="ctr">
                     <a:lnL w="12700" cap="flat" cmpd="sng" algn="ctr">
                       <a:solidFill>
-                        <a:srgbClr val="E4D9C9"/>
+                        <a:srgbClr val="D6DED2"/>
                       </a:solidFill>
                       <a:prstDash val="solid"/>
                       <a:round/>
@@ -6813,7 +6813,7 @@
                     </a:lnL>
                     <a:lnR w="12700" cap="flat" cmpd="sng" algn="ctr">
                       <a:solidFill>
-                        <a:srgbClr val="E4D9C9"/>
+                        <a:srgbClr val="D6DED2"/>
                       </a:solidFill>
                       <a:prstDash val="solid"/>
                       <a:round/>
@@ -6822,7 +6822,7 @@
                     </a:lnR>
                     <a:lnT w="12700" cap="flat" cmpd="sng" algn="ctr">
                       <a:solidFill>
-                        <a:srgbClr val="E4D9C9"/>
+                        <a:srgbClr val="D6DED2"/>
                       </a:solidFill>
                       <a:prstDash val="solid"/>
                       <a:round/>
@@ -6831,7 +6831,7 @@
                     </a:lnT>
                     <a:lnB w="12700" cap="flat" cmpd="sng" algn="ctr">
                       <a:solidFill>
-                        <a:srgbClr val="E4D9C9"/>
+                        <a:srgbClr val="D6DED2"/>
                       </a:solidFill>
                       <a:prstDash val="solid"/>
                       <a:round/>
@@ -6839,7 +6839,7 @@
                       <a:tailEnd type="none" w="med" len="med"/>
                     </a:lnB>
                     <a:solidFill>
-                      <a:srgbClr val="2E2119"/>
+                      <a:srgbClr val="26402C"/>
                     </a:solidFill>
                   </a:tcPr>
                 </a:tc>
@@ -6872,7 +6872,7 @@
                   <a:tcPr marL="91440" marR="91440" marT="45720" marB="45720" anchor="ctr">
                     <a:lnL w="12700" cap="flat" cmpd="sng" algn="ctr">
                       <a:solidFill>
-                        <a:srgbClr val="E4D9C9"/>
+                        <a:srgbClr val="D6DED2"/>
                       </a:solidFill>
                       <a:prstDash val="solid"/>
                       <a:round/>
@@ -6881,7 +6881,7 @@
                     </a:lnL>
                     <a:lnR w="12700" cap="flat" cmpd="sng" algn="ctr">
                       <a:solidFill>
-                        <a:srgbClr val="E4D9C9"/>
+                        <a:srgbClr val="D6DED2"/>
                       </a:solidFill>
                       <a:prstDash val="solid"/>
                       <a:round/>
@@ -6890,7 +6890,7 @@
                     </a:lnR>
                     <a:lnT w="12700" cap="flat" cmpd="sng" algn="ctr">
                       <a:solidFill>
-                        <a:srgbClr val="E4D9C9"/>
+                        <a:srgbClr val="D6DED2"/>
                       </a:solidFill>
                       <a:prstDash val="solid"/>
                       <a:round/>
@@ -6899,7 +6899,7 @@
                     </a:lnT>
                     <a:lnB w="12700" cap="flat" cmpd="sng" algn="ctr">
                       <a:solidFill>
-                        <a:srgbClr val="E4D9C9"/>
+                        <a:srgbClr val="D6DED2"/>
                       </a:solidFill>
                       <a:prstDash val="solid"/>
                       <a:round/>
@@ -6907,7 +6907,7 @@
                       <a:tailEnd type="none" w="med" len="med"/>
                     </a:lnB>
                     <a:solidFill>
-                      <a:srgbClr val="2E2119"/>
+                      <a:srgbClr val="26402C"/>
                     </a:solidFill>
                   </a:tcPr>
                 </a:tc>
@@ -6940,7 +6940,7 @@
                   <a:tcPr marL="91440" marR="91440" marT="45720" marB="45720" anchor="ctr">
                     <a:lnL w="12700" cap="flat" cmpd="sng" algn="ctr">
                       <a:solidFill>
-                        <a:srgbClr val="E4D9C9"/>
+                        <a:srgbClr val="D6DED2"/>
                       </a:solidFill>
                       <a:prstDash val="solid"/>
                       <a:round/>
@@ -6949,7 +6949,7 @@
                     </a:lnL>
                     <a:lnR w="12700" cap="flat" cmpd="sng" algn="ctr">
                       <a:solidFill>
-                        <a:srgbClr val="E4D9C9"/>
+                        <a:srgbClr val="D6DED2"/>
                       </a:solidFill>
                       <a:prstDash val="solid"/>
                       <a:round/>
@@ -6958,7 +6958,7 @@
                     </a:lnR>
                     <a:lnT w="12700" cap="flat" cmpd="sng" algn="ctr">
                       <a:solidFill>
-                        <a:srgbClr val="E4D9C9"/>
+                        <a:srgbClr val="D6DED2"/>
                       </a:solidFill>
                       <a:prstDash val="solid"/>
                       <a:round/>
@@ -6967,7 +6967,7 @@
                     </a:lnT>
                     <a:lnB w="12700" cap="flat" cmpd="sng" algn="ctr">
                       <a:solidFill>
-                        <a:srgbClr val="E4D9C9"/>
+                        <a:srgbClr val="D6DED2"/>
                       </a:solidFill>
                       <a:prstDash val="solid"/>
                       <a:round/>
@@ -6975,7 +6975,7 @@
                       <a:tailEnd type="none" w="med" len="med"/>
                     </a:lnB>
                     <a:solidFill>
-                      <a:srgbClr val="2E2119"/>
+                      <a:srgbClr val="26402C"/>
                     </a:solidFill>
                   </a:tcPr>
                 </a:tc>
@@ -6992,7 +6992,7 @@
                       <a:r>
                         <a:rPr lang="en-US" sz="1200" dirty="0">
                           <a:solidFill>
-                            <a:srgbClr val="2E2119"/>
+                            <a:srgbClr val="26402C"/>
                           </a:solidFill>
                           <a:latin typeface="Calibri" pitchFamily="34" charset="0"/>
                           <a:ea typeface="Calibri" pitchFamily="34" charset="-122"/>
@@ -7010,7 +7010,7 @@
                   <a:tcPr marL="91440" marR="91440" marT="45720" marB="45720" anchor="ctr">
                     <a:lnL w="12700" cap="flat" cmpd="sng" algn="ctr">
                       <a:solidFill>
-                        <a:srgbClr val="E4D9C9"/>
+                        <a:srgbClr val="D6DED2"/>
                       </a:solidFill>
                       <a:prstDash val="solid"/>
                       <a:round/>
@@ -7019,7 +7019,7 @@
                     </a:lnL>
                     <a:lnR w="12700" cap="flat" cmpd="sng" algn="ctr">
                       <a:solidFill>
-                        <a:srgbClr val="E4D9C9"/>
+                        <a:srgbClr val="D6DED2"/>
                       </a:solidFill>
                       <a:prstDash val="solid"/>
                       <a:round/>
@@ -7028,7 +7028,7 @@
                     </a:lnR>
                     <a:lnT w="12700" cap="flat" cmpd="sng" algn="ctr">
                       <a:solidFill>
-                        <a:srgbClr val="E4D9C9"/>
+                        <a:srgbClr val="D6DED2"/>
                       </a:solidFill>
                       <a:prstDash val="solid"/>
                       <a:round/>
@@ -7037,7 +7037,7 @@
                     </a:lnT>
                     <a:lnB w="12700" cap="flat" cmpd="sng" algn="ctr">
                       <a:solidFill>
-                        <a:srgbClr val="E4D9C9"/>
+                        <a:srgbClr val="D6DED2"/>
                       </a:solidFill>
                       <a:prstDash val="solid"/>
                       <a:round/>
@@ -7060,7 +7060,7 @@
                       <a:r>
                         <a:rPr lang="en-US" sz="1200" dirty="0">
                           <a:solidFill>
-                            <a:srgbClr val="2E2119"/>
+                            <a:srgbClr val="26402C"/>
                           </a:solidFill>
                           <a:latin typeface="Calibri" pitchFamily="34" charset="0"/>
                           <a:ea typeface="Calibri" pitchFamily="34" charset="-122"/>
@@ -7078,7 +7078,7 @@
                   <a:tcPr marL="91440" marR="91440" marT="45720" marB="45720" anchor="ctr">
                     <a:lnL w="12700" cap="flat" cmpd="sng" algn="ctr">
                       <a:solidFill>
-                        <a:srgbClr val="E4D9C9"/>
+                        <a:srgbClr val="D6DED2"/>
                       </a:solidFill>
                       <a:prstDash val="solid"/>
                       <a:round/>
@@ -7087,7 +7087,7 @@
                     </a:lnL>
                     <a:lnR w="12700" cap="flat" cmpd="sng" algn="ctr">
                       <a:solidFill>
-                        <a:srgbClr val="E4D9C9"/>
+                        <a:srgbClr val="D6DED2"/>
                       </a:solidFill>
                       <a:prstDash val="solid"/>
                       <a:round/>
@@ -7096,7 +7096,7 @@
                     </a:lnR>
                     <a:lnT w="12700" cap="flat" cmpd="sng" algn="ctr">
                       <a:solidFill>
-                        <a:srgbClr val="E4D9C9"/>
+                        <a:srgbClr val="D6DED2"/>
                       </a:solidFill>
                       <a:prstDash val="solid"/>
                       <a:round/>
@@ -7105,7 +7105,7 @@
                     </a:lnT>
                     <a:lnB w="12700" cap="flat" cmpd="sng" algn="ctr">
                       <a:solidFill>
-                        <a:srgbClr val="E4D9C9"/>
+                        <a:srgbClr val="D6DED2"/>
                       </a:solidFill>
                       <a:prstDash val="solid"/>
                       <a:round/>
@@ -7128,7 +7128,7 @@
                       <a:r>
                         <a:rPr lang="en-US" sz="1200" dirty="0">
                           <a:solidFill>
-                            <a:srgbClr val="2E2119"/>
+                            <a:srgbClr val="26402C"/>
                           </a:solidFill>
                           <a:latin typeface="Calibri" pitchFamily="34" charset="0"/>
                           <a:ea typeface="Calibri" pitchFamily="34" charset="-122"/>
@@ -7146,7 +7146,7 @@
                   <a:tcPr marL="91440" marR="91440" marT="45720" marB="45720" anchor="ctr">
                     <a:lnL w="12700" cap="flat" cmpd="sng" algn="ctr">
                       <a:solidFill>
-                        <a:srgbClr val="E4D9C9"/>
+                        <a:srgbClr val="D6DED2"/>
                       </a:solidFill>
                       <a:prstDash val="solid"/>
                       <a:round/>
@@ -7155,7 +7155,7 @@
                     </a:lnL>
                     <a:lnR w="12700" cap="flat" cmpd="sng" algn="ctr">
                       <a:solidFill>
-                        <a:srgbClr val="E4D9C9"/>
+                        <a:srgbClr val="D6DED2"/>
                       </a:solidFill>
                       <a:prstDash val="solid"/>
                       <a:round/>
@@ -7164,7 +7164,7 @@
                     </a:lnR>
                     <a:lnT w="12700" cap="flat" cmpd="sng" algn="ctr">
                       <a:solidFill>
-                        <a:srgbClr val="E4D9C9"/>
+                        <a:srgbClr val="D6DED2"/>
                       </a:solidFill>
                       <a:prstDash val="solid"/>
                       <a:round/>
@@ -7173,7 +7173,7 @@
                     </a:lnT>
                     <a:lnB w="12700" cap="flat" cmpd="sng" algn="ctr">
                       <a:solidFill>
-                        <a:srgbClr val="E4D9C9"/>
+                        <a:srgbClr val="D6DED2"/>
                       </a:solidFill>
                       <a:prstDash val="solid"/>
                       <a:round/>
@@ -7198,7 +7198,7 @@
                       <a:r>
                         <a:rPr lang="en-US" sz="1200" dirty="0">
                           <a:solidFill>
-                            <a:srgbClr val="2E2119"/>
+                            <a:srgbClr val="26402C"/>
                           </a:solidFill>
                           <a:latin typeface="Calibri" pitchFamily="34" charset="0"/>
                           <a:ea typeface="Calibri" pitchFamily="34" charset="-122"/>
@@ -7216,7 +7216,7 @@
                   <a:tcPr marL="91440" marR="91440" marT="45720" marB="45720" anchor="ctr">
                     <a:lnL w="12700" cap="flat" cmpd="sng" algn="ctr">
                       <a:solidFill>
-                        <a:srgbClr val="E4D9C9"/>
+                        <a:srgbClr val="D6DED2"/>
                       </a:solidFill>
                       <a:prstDash val="solid"/>
                       <a:round/>
@@ -7225,7 +7225,7 @@
                     </a:lnL>
                     <a:lnR w="12700" cap="flat" cmpd="sng" algn="ctr">
                       <a:solidFill>
-                        <a:srgbClr val="E4D9C9"/>
+                        <a:srgbClr val="D6DED2"/>
                       </a:solidFill>
                       <a:prstDash val="solid"/>
                       <a:round/>
@@ -7234,7 +7234,7 @@
                     </a:lnR>
                     <a:lnT w="12700" cap="flat" cmpd="sng" algn="ctr">
                       <a:solidFill>
-                        <a:srgbClr val="E4D9C9"/>
+                        <a:srgbClr val="D6DED2"/>
                       </a:solidFill>
                       <a:prstDash val="solid"/>
                       <a:round/>
@@ -7243,7 +7243,7 @@
                     </a:lnT>
                     <a:lnB w="12700" cap="flat" cmpd="sng" algn="ctr">
                       <a:solidFill>
-                        <a:srgbClr val="E4D9C9"/>
+                        <a:srgbClr val="D6DED2"/>
                       </a:solidFill>
                       <a:prstDash val="solid"/>
                       <a:round/>
@@ -7266,7 +7266,7 @@
                       <a:r>
                         <a:rPr lang="en-US" sz="1200" dirty="0">
                           <a:solidFill>
-                            <a:srgbClr val="2E2119"/>
+                            <a:srgbClr val="26402C"/>
                           </a:solidFill>
                           <a:latin typeface="Calibri" pitchFamily="34" charset="0"/>
                           <a:ea typeface="Calibri" pitchFamily="34" charset="-122"/>
@@ -7284,7 +7284,7 @@
                   <a:tcPr marL="91440" marR="91440" marT="45720" marB="45720" anchor="ctr">
                     <a:lnL w="12700" cap="flat" cmpd="sng" algn="ctr">
                       <a:solidFill>
-                        <a:srgbClr val="E4D9C9"/>
+                        <a:srgbClr val="D6DED2"/>
                       </a:solidFill>
                       <a:prstDash val="solid"/>
                       <a:round/>
@@ -7293,7 +7293,7 @@
                     </a:lnL>
                     <a:lnR w="12700" cap="flat" cmpd="sng" algn="ctr">
                       <a:solidFill>
-                        <a:srgbClr val="E4D9C9"/>
+                        <a:srgbClr val="D6DED2"/>
                       </a:solidFill>
                       <a:prstDash val="solid"/>
                       <a:round/>
@@ -7302,7 +7302,7 @@
                     </a:lnR>
                     <a:lnT w="12700" cap="flat" cmpd="sng" algn="ctr">
                       <a:solidFill>
-                        <a:srgbClr val="E4D9C9"/>
+                        <a:srgbClr val="D6DED2"/>
                       </a:solidFill>
                       <a:prstDash val="solid"/>
                       <a:round/>
@@ -7311,7 +7311,7 @@
                     </a:lnT>
                     <a:lnB w="12700" cap="flat" cmpd="sng" algn="ctr">
                       <a:solidFill>
-                        <a:srgbClr val="E4D9C9"/>
+                        <a:srgbClr val="D6DED2"/>
                       </a:solidFill>
                       <a:prstDash val="solid"/>
                       <a:round/>
@@ -7334,7 +7334,7 @@
                       <a:r>
                         <a:rPr lang="en-US" sz="1200" dirty="0">
                           <a:solidFill>
-                            <a:srgbClr val="2E2119"/>
+                            <a:srgbClr val="26402C"/>
                           </a:solidFill>
                           <a:latin typeface="Calibri" pitchFamily="34" charset="0"/>
                           <a:ea typeface="Calibri" pitchFamily="34" charset="-122"/>
@@ -7352,7 +7352,7 @@
                   <a:tcPr marL="91440" marR="91440" marT="45720" marB="45720" anchor="ctr">
                     <a:lnL w="12700" cap="flat" cmpd="sng" algn="ctr">
                       <a:solidFill>
-                        <a:srgbClr val="E4D9C9"/>
+                        <a:srgbClr val="D6DED2"/>
                       </a:solidFill>
                       <a:prstDash val="solid"/>
                       <a:round/>
@@ -7361,7 +7361,7 @@
                     </a:lnL>
                     <a:lnR w="12700" cap="flat" cmpd="sng" algn="ctr">
                       <a:solidFill>
-                        <a:srgbClr val="E4D9C9"/>
+                        <a:srgbClr val="D6DED2"/>
                       </a:solidFill>
                       <a:prstDash val="solid"/>
                       <a:round/>
@@ -7370,7 +7370,7 @@
                     </a:lnR>
                     <a:lnT w="12700" cap="flat" cmpd="sng" algn="ctr">
                       <a:solidFill>
-                        <a:srgbClr val="E4D9C9"/>
+                        <a:srgbClr val="D6DED2"/>
                       </a:solidFill>
                       <a:prstDash val="solid"/>
                       <a:round/>
@@ -7379,7 +7379,7 @@
                     </a:lnT>
                     <a:lnB w="12700" cap="flat" cmpd="sng" algn="ctr">
                       <a:solidFill>
-                        <a:srgbClr val="E4D9C9"/>
+                        <a:srgbClr val="D6DED2"/>
                       </a:solidFill>
                       <a:prstDash val="solid"/>
                       <a:round/>
@@ -7404,7 +7404,7 @@
                       <a:r>
                         <a:rPr lang="en-US" sz="1200" dirty="0">
                           <a:solidFill>
-                            <a:srgbClr val="2E2119"/>
+                            <a:srgbClr val="26402C"/>
                           </a:solidFill>
                           <a:latin typeface="Calibri" pitchFamily="34" charset="0"/>
                           <a:ea typeface="Calibri" pitchFamily="34" charset="-122"/>
@@ -7422,7 +7422,7 @@
                   <a:tcPr marL="91440" marR="91440" marT="45720" marB="45720" anchor="ctr">
                     <a:lnL w="12700" cap="flat" cmpd="sng" algn="ctr">
                       <a:solidFill>
-                        <a:srgbClr val="E4D9C9"/>
+                        <a:srgbClr val="D6DED2"/>
                       </a:solidFill>
                       <a:prstDash val="solid"/>
                       <a:round/>
@@ -7431,7 +7431,7 @@
                     </a:lnL>
                     <a:lnR w="12700" cap="flat" cmpd="sng" algn="ctr">
                       <a:solidFill>
-                        <a:srgbClr val="E4D9C9"/>
+                        <a:srgbClr val="D6DED2"/>
                       </a:solidFill>
                       <a:prstDash val="solid"/>
                       <a:round/>
@@ -7440,7 +7440,7 @@
                     </a:lnR>
                     <a:lnT w="12700" cap="flat" cmpd="sng" algn="ctr">
                       <a:solidFill>
-                        <a:srgbClr val="E4D9C9"/>
+                        <a:srgbClr val="D6DED2"/>
                       </a:solidFill>
                       <a:prstDash val="solid"/>
                       <a:round/>
@@ -7449,7 +7449,7 @@
                     </a:lnT>
                     <a:lnB w="12700" cap="flat" cmpd="sng" algn="ctr">
                       <a:solidFill>
-                        <a:srgbClr val="E4D9C9"/>
+                        <a:srgbClr val="D6DED2"/>
                       </a:solidFill>
                       <a:prstDash val="solid"/>
                       <a:round/>
@@ -7472,7 +7472,7 @@
                       <a:r>
                         <a:rPr lang="en-US" sz="1200" dirty="0">
                           <a:solidFill>
-                            <a:srgbClr val="2E2119"/>
+                            <a:srgbClr val="26402C"/>
                           </a:solidFill>
                           <a:latin typeface="Calibri" pitchFamily="34" charset="0"/>
                           <a:ea typeface="Calibri" pitchFamily="34" charset="-122"/>
@@ -7490,7 +7490,7 @@
                   <a:tcPr marL="91440" marR="91440" marT="45720" marB="45720" anchor="ctr">
                     <a:lnL w="12700" cap="flat" cmpd="sng" algn="ctr">
                       <a:solidFill>
-                        <a:srgbClr val="E4D9C9"/>
+                        <a:srgbClr val="D6DED2"/>
                       </a:solidFill>
                       <a:prstDash val="solid"/>
                       <a:round/>
@@ -7499,7 +7499,7 @@
                     </a:lnL>
                     <a:lnR w="12700" cap="flat" cmpd="sng" algn="ctr">
                       <a:solidFill>
-                        <a:srgbClr val="E4D9C9"/>
+                        <a:srgbClr val="D6DED2"/>
                       </a:solidFill>
                       <a:prstDash val="solid"/>
                       <a:round/>
@@ -7508,7 +7508,7 @@
                     </a:lnR>
                     <a:lnT w="12700" cap="flat" cmpd="sng" algn="ctr">
                       <a:solidFill>
-                        <a:srgbClr val="E4D9C9"/>
+                        <a:srgbClr val="D6DED2"/>
                       </a:solidFill>
                       <a:prstDash val="solid"/>
                       <a:round/>
@@ -7517,7 +7517,7 @@
                     </a:lnT>
                     <a:lnB w="12700" cap="flat" cmpd="sng" algn="ctr">
                       <a:solidFill>
-                        <a:srgbClr val="E4D9C9"/>
+                        <a:srgbClr val="D6DED2"/>
                       </a:solidFill>
                       <a:prstDash val="solid"/>
                       <a:round/>
@@ -7540,7 +7540,7 @@
                       <a:r>
                         <a:rPr lang="en-US" sz="1200" dirty="0">
                           <a:solidFill>
-                            <a:srgbClr val="2E2119"/>
+                            <a:srgbClr val="26402C"/>
                           </a:solidFill>
                           <a:latin typeface="Calibri" pitchFamily="34" charset="0"/>
                           <a:ea typeface="Calibri" pitchFamily="34" charset="-122"/>
@@ -7558,7 +7558,7 @@
                   <a:tcPr marL="91440" marR="91440" marT="45720" marB="45720" anchor="ctr">
                     <a:lnL w="12700" cap="flat" cmpd="sng" algn="ctr">
                       <a:solidFill>
-                        <a:srgbClr val="E4D9C9"/>
+                        <a:srgbClr val="D6DED2"/>
                       </a:solidFill>
                       <a:prstDash val="solid"/>
                       <a:round/>
@@ -7567,7 +7567,7 @@
                     </a:lnL>
                     <a:lnR w="12700" cap="flat" cmpd="sng" algn="ctr">
                       <a:solidFill>
-                        <a:srgbClr val="E4D9C9"/>
+                        <a:srgbClr val="D6DED2"/>
                       </a:solidFill>
                       <a:prstDash val="solid"/>
                       <a:round/>
@@ -7576,7 +7576,7 @@
                     </a:lnR>
                     <a:lnT w="12700" cap="flat" cmpd="sng" algn="ctr">
                       <a:solidFill>
-                        <a:srgbClr val="E4D9C9"/>
+                        <a:srgbClr val="D6DED2"/>
                       </a:solidFill>
                       <a:prstDash val="solid"/>
                       <a:round/>
@@ -7585,7 +7585,7 @@
                     </a:lnT>
                     <a:lnB w="12700" cap="flat" cmpd="sng" algn="ctr">
                       <a:solidFill>
-                        <a:srgbClr val="E4D9C9"/>
+                        <a:srgbClr val="D6DED2"/>
                       </a:solidFill>
                       <a:prstDash val="solid"/>
                       <a:round/>
@@ -7610,7 +7610,7 @@
                       <a:r>
                         <a:rPr lang="en-US" sz="1200" dirty="0">
                           <a:solidFill>
-                            <a:srgbClr val="2E2119"/>
+                            <a:srgbClr val="26402C"/>
                           </a:solidFill>
                           <a:latin typeface="Calibri" pitchFamily="34" charset="0"/>
                           <a:ea typeface="Calibri" pitchFamily="34" charset="-122"/>
@@ -7628,7 +7628,7 @@
                   <a:tcPr marL="91440" marR="91440" marT="45720" marB="45720" anchor="ctr">
                     <a:lnL w="12700" cap="flat" cmpd="sng" algn="ctr">
                       <a:solidFill>
-                        <a:srgbClr val="E4D9C9"/>
+                        <a:srgbClr val="D6DED2"/>
                       </a:solidFill>
                       <a:prstDash val="solid"/>
                       <a:round/>
@@ -7637,7 +7637,7 @@
                     </a:lnL>
                     <a:lnR w="12700" cap="flat" cmpd="sng" algn="ctr">
                       <a:solidFill>
-                        <a:srgbClr val="E4D9C9"/>
+                        <a:srgbClr val="D6DED2"/>
                       </a:solidFill>
                       <a:prstDash val="solid"/>
                       <a:round/>
@@ -7646,7 +7646,7 @@
                     </a:lnR>
                     <a:lnT w="12700" cap="flat" cmpd="sng" algn="ctr">
                       <a:solidFill>
-                        <a:srgbClr val="E4D9C9"/>
+                        <a:srgbClr val="D6DED2"/>
                       </a:solidFill>
                       <a:prstDash val="solid"/>
                       <a:round/>
@@ -7655,7 +7655,7 @@
                     </a:lnT>
                     <a:lnB w="12700" cap="flat" cmpd="sng" algn="ctr">
                       <a:solidFill>
-                        <a:srgbClr val="E4D9C9"/>
+                        <a:srgbClr val="D6DED2"/>
                       </a:solidFill>
                       <a:prstDash val="solid"/>
                       <a:round/>
@@ -7678,7 +7678,7 @@
                       <a:r>
                         <a:rPr lang="en-US" sz="1200" dirty="0">
                           <a:solidFill>
-                            <a:srgbClr val="2E2119"/>
+                            <a:srgbClr val="26402C"/>
                           </a:solidFill>
                           <a:latin typeface="Calibri" pitchFamily="34" charset="0"/>
                           <a:ea typeface="Calibri" pitchFamily="34" charset="-122"/>
@@ -7696,7 +7696,7 @@
                   <a:tcPr marL="91440" marR="91440" marT="45720" marB="45720" anchor="ctr">
                     <a:lnL w="12700" cap="flat" cmpd="sng" algn="ctr">
                       <a:solidFill>
-                        <a:srgbClr val="E4D9C9"/>
+                        <a:srgbClr val="D6DED2"/>
                       </a:solidFill>
                       <a:prstDash val="solid"/>
                       <a:round/>
@@ -7705,7 +7705,7 @@
                     </a:lnL>
                     <a:lnR w="12700" cap="flat" cmpd="sng" algn="ctr">
                       <a:solidFill>
-                        <a:srgbClr val="E4D9C9"/>
+                        <a:srgbClr val="D6DED2"/>
                       </a:solidFill>
                       <a:prstDash val="solid"/>
                       <a:round/>
@@ -7714,7 +7714,7 @@
                     </a:lnR>
                     <a:lnT w="12700" cap="flat" cmpd="sng" algn="ctr">
                       <a:solidFill>
-                        <a:srgbClr val="E4D9C9"/>
+                        <a:srgbClr val="D6DED2"/>
                       </a:solidFill>
                       <a:prstDash val="solid"/>
                       <a:round/>
@@ -7723,7 +7723,7 @@
                     </a:lnT>
                     <a:lnB w="12700" cap="flat" cmpd="sng" algn="ctr">
                       <a:solidFill>
-                        <a:srgbClr val="E4D9C9"/>
+                        <a:srgbClr val="D6DED2"/>
                       </a:solidFill>
                       <a:prstDash val="solid"/>
                       <a:round/>
@@ -7746,7 +7746,7 @@
                       <a:r>
                         <a:rPr lang="en-US" sz="1200" dirty="0">
                           <a:solidFill>
-                            <a:srgbClr val="2E2119"/>
+                            <a:srgbClr val="26402C"/>
                           </a:solidFill>
                           <a:latin typeface="Calibri" pitchFamily="34" charset="0"/>
                           <a:ea typeface="Calibri" pitchFamily="34" charset="-122"/>
@@ -7764,7 +7764,7 @@
                   <a:tcPr marL="91440" marR="91440" marT="45720" marB="45720" anchor="ctr">
                     <a:lnL w="12700" cap="flat" cmpd="sng" algn="ctr">
                       <a:solidFill>
-                        <a:srgbClr val="E4D9C9"/>
+                        <a:srgbClr val="D6DED2"/>
                       </a:solidFill>
                       <a:prstDash val="solid"/>
                       <a:round/>
@@ -7773,7 +7773,7 @@
                     </a:lnL>
                     <a:lnR w="12700" cap="flat" cmpd="sng" algn="ctr">
                       <a:solidFill>
-                        <a:srgbClr val="E4D9C9"/>
+                        <a:srgbClr val="D6DED2"/>
                       </a:solidFill>
                       <a:prstDash val="solid"/>
                       <a:round/>
@@ -7782,7 +7782,7 @@
                     </a:lnR>
                     <a:lnT w="12700" cap="flat" cmpd="sng" algn="ctr">
                       <a:solidFill>
-                        <a:srgbClr val="E4D9C9"/>
+                        <a:srgbClr val="D6DED2"/>
                       </a:solidFill>
                       <a:prstDash val="solid"/>
                       <a:round/>
@@ -7791,7 +7791,7 @@
                     </a:lnT>
                     <a:lnB w="12700" cap="flat" cmpd="sng" algn="ctr">
                       <a:solidFill>
-                        <a:srgbClr val="E4D9C9"/>
+                        <a:srgbClr val="D6DED2"/>
                       </a:solidFill>
                       <a:prstDash val="solid"/>
                       <a:round/>
@@ -7825,7 +7825,7 @@
             </a:avLst>
           </a:prstGeom>
           <a:solidFill>
-            <a:srgbClr val="F4E9DA"/>
+            <a:srgbClr val="F2EFE7"/>
           </a:solidFill>
           <a:ln/>
           <a:effectLst>
@@ -7864,7 +7864,7 @@
             <a:r>
               <a:rPr lang="en-US" sz="1300" b="1" dirty="0">
                 <a:solidFill>
-                  <a:srgbClr val="C9682B"/>
+                  <a:srgbClr val="C6821E"/>
                 </a:solidFill>
                 <a:latin typeface="Calibri" pitchFamily="34" charset="0"/>
                 <a:ea typeface="Calibri" pitchFamily="34" charset="-122"/>
@@ -7906,7 +7906,7 @@
             <a:r>
               <a:rPr lang="en-US" sz="1250" dirty="0">
                 <a:solidFill>
-                  <a:srgbClr val="2E2119"/>
+                  <a:srgbClr val="26402C"/>
                 </a:solidFill>
                 <a:latin typeface="Calibri" pitchFamily="34" charset="0"/>
                 <a:ea typeface="Calibri" pitchFamily="34" charset="-122"/>
@@ -7926,7 +7926,7 @@
             <a:r>
               <a:rPr lang="en-US" sz="1250" dirty="0">
                 <a:solidFill>
-                  <a:srgbClr val="2E2119"/>
+                  <a:srgbClr val="26402C"/>
                 </a:solidFill>
                 <a:latin typeface="Calibri" pitchFamily="34" charset="0"/>
                 <a:ea typeface="Calibri" pitchFamily="34" charset="-122"/>
@@ -7943,7 +7943,7 @@
             <a:r>
               <a:rPr lang="en-US" sz="1250" dirty="0">
                 <a:solidFill>
-                  <a:srgbClr val="2E2119"/>
+                  <a:srgbClr val="26402C"/>
                 </a:solidFill>
                 <a:latin typeface="Calibri" pitchFamily="34" charset="0"/>
                 <a:ea typeface="Calibri" pitchFamily="34" charset="-122"/>
@@ -8002,7 +8002,7 @@
             <a:avLst/>
           </a:prstGeom>
           <a:solidFill>
-            <a:srgbClr val="C9682B"/>
+            <a:srgbClr val="C6821E"/>
           </a:solidFill>
           <a:ln/>
         </p:spPr>
@@ -8058,7 +8058,7 @@
             <a:r>
               <a:rPr lang="en-US" sz="1200" b="1" spc="200" kern="0" dirty="0">
                 <a:solidFill>
-                  <a:srgbClr val="C9682B"/>
+                  <a:srgbClr val="C6821E"/>
                 </a:solidFill>
                 <a:latin typeface="Calibri" pitchFamily="34" charset="0"/>
                 <a:ea typeface="Calibri" pitchFamily="34" charset="-122"/>
@@ -8097,7 +8097,7 @@
             <a:r>
               <a:rPr lang="en-US" sz="2800" b="1" dirty="0">
                 <a:solidFill>
-                  <a:srgbClr val="2E2119"/>
+                  <a:srgbClr val="26402C"/>
                 </a:solidFill>
                 <a:latin typeface="Cambria" pitchFamily="34" charset="0"/>
                 <a:ea typeface="Cambria" pitchFamily="34" charset="-122"/>
@@ -8136,7 +8136,7 @@
             <a:r>
               <a:rPr lang="en-US" sz="1000" i="1" dirty="0">
                 <a:solidFill>
-                  <a:srgbClr val="8A7A6D"/>
+                  <a:srgbClr val="5B6559"/>
                 </a:solidFill>
                 <a:latin typeface="Calibri" pitchFamily="34" charset="0"/>
                 <a:ea typeface="Calibri" pitchFamily="34" charset="-122"/>
@@ -8165,7 +8165,7 @@
             </a:avLst>
           </a:prstGeom>
           <a:solidFill>
-            <a:srgbClr val="2E2119"/>
+            <a:srgbClr val="26402C"/>
           </a:solidFill>
           <a:ln/>
         </p:spPr>
@@ -8220,7 +8220,7 @@
             <a:r>
               <a:rPr lang="en-US" sz="950" i="1" dirty="0">
                 <a:solidFill>
-                  <a:srgbClr val="2E2119"/>
+                  <a:srgbClr val="26402C"/>
                 </a:solidFill>
                 <a:latin typeface="Calibri" pitchFamily="34" charset="0"/>
                 <a:ea typeface="Calibri" pitchFamily="34" charset="-122"/>
@@ -8249,7 +8249,7 @@
             </a:avLst>
           </a:prstGeom>
           <a:solidFill>
-            <a:srgbClr val="2E2119"/>
+            <a:srgbClr val="26402C"/>
           </a:solidFill>
           <a:ln/>
         </p:spPr>
@@ -8304,7 +8304,7 @@
             <a:r>
               <a:rPr lang="en-US" sz="950" i="1" dirty="0">
                 <a:solidFill>
-                  <a:srgbClr val="2E2119"/>
+                  <a:srgbClr val="26402C"/>
                 </a:solidFill>
                 <a:latin typeface="Calibri" pitchFamily="34" charset="0"/>
                 <a:ea typeface="Calibri" pitchFamily="34" charset="-122"/>
@@ -8333,7 +8333,7 @@
             </a:avLst>
           </a:prstGeom>
           <a:solidFill>
-            <a:srgbClr val="2E2119"/>
+            <a:srgbClr val="26402C"/>
           </a:solidFill>
           <a:ln/>
         </p:spPr>
@@ -8388,7 +8388,7 @@
             <a:r>
               <a:rPr lang="en-US" sz="950" i="1" dirty="0">
                 <a:solidFill>
-                  <a:srgbClr val="2E2119"/>
+                  <a:srgbClr val="26402C"/>
                 </a:solidFill>
                 <a:latin typeface="Calibri" pitchFamily="34" charset="0"/>
                 <a:ea typeface="Calibri" pitchFamily="34" charset="-122"/>
@@ -8417,7 +8417,7 @@
             </a:avLst>
           </a:prstGeom>
           <a:solidFill>
-            <a:srgbClr val="2E2119"/>
+            <a:srgbClr val="26402C"/>
           </a:solidFill>
           <a:ln/>
         </p:spPr>
@@ -8472,7 +8472,7 @@
             <a:r>
               <a:rPr lang="en-US" sz="950" i="1" dirty="0">
                 <a:solidFill>
-                  <a:srgbClr val="2E2119"/>
+                  <a:srgbClr val="26402C"/>
                 </a:solidFill>
                 <a:latin typeface="Calibri" pitchFamily="34" charset="0"/>
                 <a:ea typeface="Calibri" pitchFamily="34" charset="-122"/>
@@ -8531,7 +8531,7 @@
             <a:avLst/>
           </a:prstGeom>
           <a:solidFill>
-            <a:srgbClr val="C9682B"/>
+            <a:srgbClr val="C6821E"/>
           </a:solidFill>
           <a:ln/>
         </p:spPr>
@@ -8587,7 +8587,7 @@
             <a:r>
               <a:rPr lang="en-US" sz="1200" b="1" spc="200" kern="0" dirty="0">
                 <a:solidFill>
-                  <a:srgbClr val="C9682B"/>
+                  <a:srgbClr val="C6821E"/>
                 </a:solidFill>
                 <a:latin typeface="Calibri" pitchFamily="34" charset="0"/>
                 <a:ea typeface="Calibri" pitchFamily="34" charset="-122"/>
@@ -8626,7 +8626,7 @@
             <a:r>
               <a:rPr lang="en-US" sz="2800" b="1" dirty="0">
                 <a:solidFill>
-                  <a:srgbClr val="2E2119"/>
+                  <a:srgbClr val="26402C"/>
                 </a:solidFill>
                 <a:latin typeface="Cambria" pitchFamily="34" charset="0"/>
                 <a:ea typeface="Cambria" pitchFamily="34" charset="-122"/>
@@ -8665,7 +8665,7 @@
             <a:r>
               <a:rPr lang="en-US" sz="1000" i="1" dirty="0">
                 <a:solidFill>
-                  <a:srgbClr val="8A7A6D"/>
+                  <a:srgbClr val="5B6559"/>
                 </a:solidFill>
                 <a:latin typeface="Calibri" pitchFamily="34" charset="0"/>
                 <a:ea typeface="Calibri" pitchFamily="34" charset="-122"/>
@@ -8694,7 +8694,7 @@
             </a:avLst>
           </a:prstGeom>
           <a:solidFill>
-            <a:srgbClr val="2E2119"/>
+            <a:srgbClr val="26402C"/>
           </a:solidFill>
           <a:ln/>
         </p:spPr>
@@ -8749,7 +8749,7 @@
             <a:r>
               <a:rPr lang="en-US" sz="950" i="1" dirty="0">
                 <a:solidFill>
-                  <a:srgbClr val="2E2119"/>
+                  <a:srgbClr val="26402C"/>
                 </a:solidFill>
                 <a:latin typeface="Calibri" pitchFamily="34" charset="0"/>
                 <a:ea typeface="Calibri" pitchFamily="34" charset="-122"/>
@@ -8778,7 +8778,7 @@
             </a:avLst>
           </a:prstGeom>
           <a:solidFill>
-            <a:srgbClr val="2E2119"/>
+            <a:srgbClr val="26402C"/>
           </a:solidFill>
           <a:ln/>
         </p:spPr>
@@ -8833,7 +8833,7 @@
             <a:r>
               <a:rPr lang="en-US" sz="950" i="1" dirty="0">
                 <a:solidFill>
-                  <a:srgbClr val="2E2119"/>
+                  <a:srgbClr val="26402C"/>
                 </a:solidFill>
                 <a:latin typeface="Calibri" pitchFamily="34" charset="0"/>
                 <a:ea typeface="Calibri" pitchFamily="34" charset="-122"/>
@@ -8862,7 +8862,7 @@
             </a:avLst>
           </a:prstGeom>
           <a:solidFill>
-            <a:srgbClr val="2E2119"/>
+            <a:srgbClr val="26402C"/>
           </a:solidFill>
           <a:ln/>
         </p:spPr>
@@ -8917,7 +8917,7 @@
             <a:r>
               <a:rPr lang="en-US" sz="950" i="1" dirty="0">
                 <a:solidFill>
-                  <a:srgbClr val="2E2119"/>
+                  <a:srgbClr val="26402C"/>
                 </a:solidFill>
                 <a:latin typeface="Calibri" pitchFamily="34" charset="0"/>
                 <a:ea typeface="Calibri" pitchFamily="34" charset="-122"/>
@@ -8946,7 +8946,7 @@
             </a:avLst>
           </a:prstGeom>
           <a:solidFill>
-            <a:srgbClr val="2E2119"/>
+            <a:srgbClr val="26402C"/>
           </a:solidFill>
           <a:ln/>
         </p:spPr>
@@ -9001,7 +9001,7 @@
             <a:r>
               <a:rPr lang="en-US" sz="950" i="1" dirty="0">
                 <a:solidFill>
-                  <a:srgbClr val="2E2119"/>
+                  <a:srgbClr val="26402C"/>
                 </a:solidFill>
                 <a:latin typeface="Calibri" pitchFamily="34" charset="0"/>
                 <a:ea typeface="Calibri" pitchFamily="34" charset="-122"/>
@@ -9060,7 +9060,7 @@
             <a:avLst/>
           </a:prstGeom>
           <a:solidFill>
-            <a:srgbClr val="C9682B"/>
+            <a:srgbClr val="C6821E"/>
           </a:solidFill>
           <a:ln/>
         </p:spPr>
@@ -9116,7 +9116,7 @@
             <a:r>
               <a:rPr lang="en-US" sz="1200" b="1" spc="200" kern="0" dirty="0">
                 <a:solidFill>
-                  <a:srgbClr val="C9682B"/>
+                  <a:srgbClr val="C6821E"/>
                 </a:solidFill>
                 <a:latin typeface="Calibri" pitchFamily="34" charset="0"/>
                 <a:ea typeface="Calibri" pitchFamily="34" charset="-122"/>
@@ -9155,7 +9155,7 @@
             <a:r>
               <a:rPr lang="en-US" sz="2800" b="1" dirty="0">
                 <a:solidFill>
-                  <a:srgbClr val="2E2119"/>
+                  <a:srgbClr val="26402C"/>
                 </a:solidFill>
                 <a:latin typeface="Cambria" pitchFamily="34" charset="0"/>
                 <a:ea typeface="Cambria" pitchFamily="34" charset="-122"/>
@@ -9194,7 +9194,7 @@
             <a:r>
               <a:rPr lang="en-US" sz="1000" i="1" dirty="0">
                 <a:solidFill>
-                  <a:srgbClr val="8A7A6D"/>
+                  <a:srgbClr val="5B6559"/>
                 </a:solidFill>
                 <a:latin typeface="Calibri" pitchFamily="34" charset="0"/>
                 <a:ea typeface="Calibri" pitchFamily="34" charset="-122"/>
@@ -9223,7 +9223,7 @@
             </a:avLst>
           </a:prstGeom>
           <a:solidFill>
-            <a:srgbClr val="2E2119"/>
+            <a:srgbClr val="26402C"/>
           </a:solidFill>
           <a:ln/>
         </p:spPr>
@@ -9255,7 +9255,7 @@
             <a:r>
               <a:rPr lang="en-US" sz="3000" b="1" dirty="0">
                 <a:solidFill>
-                  <a:srgbClr val="D9A441"/>
+                  <a:srgbClr val="E3A94A"/>
                 </a:solidFill>
                 <a:latin typeface="Cambria" pitchFamily="34" charset="0"/>
                 <a:ea typeface="Cambria" pitchFamily="34" charset="-122"/>
@@ -9294,7 +9294,7 @@
             <a:r>
               <a:rPr lang="en-US" sz="1000" dirty="0">
                 <a:solidFill>
-                  <a:srgbClr val="D8CBBE"/>
+                  <a:srgbClr val="C7D0C2"/>
                 </a:solidFill>
                 <a:latin typeface="Calibri" pitchFamily="34" charset="0"/>
                 <a:ea typeface="Calibri" pitchFamily="34" charset="-122"/>
@@ -9323,7 +9323,7 @@
             </a:avLst>
           </a:prstGeom>
           <a:solidFill>
-            <a:srgbClr val="2E2119"/>
+            <a:srgbClr val="26402C"/>
           </a:solidFill>
           <a:ln/>
         </p:spPr>
@@ -9355,7 +9355,7 @@
             <a:r>
               <a:rPr lang="en-US" sz="3000" b="1" dirty="0">
                 <a:solidFill>
-                  <a:srgbClr val="D9A441"/>
+                  <a:srgbClr val="E3A94A"/>
                 </a:solidFill>
                 <a:latin typeface="Cambria" pitchFamily="34" charset="0"/>
                 <a:ea typeface="Cambria" pitchFamily="34" charset="-122"/>
@@ -9394,7 +9394,7 @@
             <a:r>
               <a:rPr lang="en-US" sz="1000" dirty="0">
                 <a:solidFill>
-                  <a:srgbClr val="D8CBBE"/>
+                  <a:srgbClr val="C7D0C2"/>
                 </a:solidFill>
                 <a:latin typeface="Calibri" pitchFamily="34" charset="0"/>
                 <a:ea typeface="Calibri" pitchFamily="34" charset="-122"/>
@@ -9423,7 +9423,7 @@
             </a:avLst>
           </a:prstGeom>
           <a:solidFill>
-            <a:srgbClr val="2E2119"/>
+            <a:srgbClr val="26402C"/>
           </a:solidFill>
           <a:ln/>
         </p:spPr>
@@ -9455,7 +9455,7 @@
             <a:r>
               <a:rPr lang="en-US" sz="3000" b="1" dirty="0">
                 <a:solidFill>
-                  <a:srgbClr val="D9A441"/>
+                  <a:srgbClr val="E3A94A"/>
                 </a:solidFill>
                 <a:latin typeface="Cambria" pitchFamily="34" charset="0"/>
                 <a:ea typeface="Cambria" pitchFamily="34" charset="-122"/>
@@ -9494,7 +9494,7 @@
             <a:r>
               <a:rPr lang="en-US" sz="1000" dirty="0">
                 <a:solidFill>
-                  <a:srgbClr val="D8CBBE"/>
+                  <a:srgbClr val="C7D0C2"/>
                 </a:solidFill>
                 <a:latin typeface="Calibri" pitchFamily="34" charset="0"/>
                 <a:ea typeface="Calibri" pitchFamily="34" charset="-122"/>
@@ -9533,7 +9533,7 @@
             <a:r>
               <a:rPr lang="en-US" sz="1100" i="1" dirty="0">
                 <a:solidFill>
-                  <a:srgbClr val="8A7A6D"/>
+                  <a:srgbClr val="5B6559"/>
                 </a:solidFill>
                 <a:latin typeface="Calibri" pitchFamily="34" charset="0"/>
                 <a:ea typeface="Calibri" pitchFamily="34" charset="-122"/>
@@ -9562,7 +9562,7 @@
             </a:avLst>
           </a:prstGeom>
           <a:solidFill>
-            <a:srgbClr val="F4E9DA"/>
+            <a:srgbClr val="F2EFE7"/>
           </a:solidFill>
           <a:ln/>
           <a:effectLst>
@@ -9601,7 +9601,7 @@
             <a:r>
               <a:rPr lang="en-US" sz="1150" b="1" dirty="0">
                 <a:solidFill>
-                  <a:srgbClr val="C9682B"/>
+                  <a:srgbClr val="C6821E"/>
                 </a:solidFill>
                 <a:latin typeface="Calibri" pitchFamily="34" charset="0"/>
                 <a:ea typeface="Calibri" pitchFamily="34" charset="-122"/>
@@ -9640,7 +9640,7 @@
             <a:r>
               <a:rPr lang="en-US" sz="1100" dirty="0">
                 <a:solidFill>
-                  <a:srgbClr val="2E2119"/>
+                  <a:srgbClr val="26402C"/>
                 </a:solidFill>
                 <a:latin typeface="Calibri" pitchFamily="34" charset="0"/>
                 <a:ea typeface="Calibri" pitchFamily="34" charset="-122"/>
@@ -9669,7 +9669,7 @@
             </a:avLst>
           </a:prstGeom>
           <a:solidFill>
-            <a:srgbClr val="E7DCCB"/>
+            <a:srgbClr val="DCE3D6"/>
           </a:solidFill>
           <a:ln/>
         </p:spPr>
@@ -9691,7 +9691,7 @@
             </a:avLst>
           </a:prstGeom>
           <a:solidFill>
-            <a:srgbClr val="D9A441"/>
+            <a:srgbClr val="E3A94A"/>
           </a:solidFill>
           <a:ln/>
         </p:spPr>
@@ -9723,7 +9723,7 @@
             <a:r>
               <a:rPr lang="en-US" sz="1100" b="1" dirty="0">
                 <a:solidFill>
-                  <a:srgbClr val="2E2119"/>
+                  <a:srgbClr val="26402C"/>
                 </a:solidFill>
                 <a:latin typeface="Calibri" pitchFamily="34" charset="0"/>
                 <a:ea typeface="Calibri" pitchFamily="34" charset="-122"/>
@@ -9762,7 +9762,7 @@
             <a:r>
               <a:rPr lang="en-US" sz="1100" dirty="0">
                 <a:solidFill>
-                  <a:srgbClr val="2E2119"/>
+                  <a:srgbClr val="26402C"/>
                 </a:solidFill>
                 <a:latin typeface="Calibri" pitchFamily="34" charset="0"/>
                 <a:ea typeface="Calibri" pitchFamily="34" charset="-122"/>
@@ -9791,7 +9791,7 @@
             </a:avLst>
           </a:prstGeom>
           <a:solidFill>
-            <a:srgbClr val="E7DCCB"/>
+            <a:srgbClr val="DCE3D6"/>
           </a:solidFill>
           <a:ln/>
         </p:spPr>
@@ -9813,7 +9813,7 @@
             </a:avLst>
           </a:prstGeom>
           <a:solidFill>
-            <a:srgbClr val="C9682B"/>
+            <a:srgbClr val="C6821E"/>
           </a:solidFill>
           <a:ln/>
         </p:spPr>
@@ -9845,7 +9845,7 @@
             <a:r>
               <a:rPr lang="en-US" sz="1100" b="1" dirty="0">
                 <a:solidFill>
-                  <a:srgbClr val="2E2119"/>
+                  <a:srgbClr val="26402C"/>
                 </a:solidFill>
                 <a:latin typeface="Calibri" pitchFamily="34" charset="0"/>
                 <a:ea typeface="Calibri" pitchFamily="34" charset="-122"/>
@@ -9884,7 +9884,7 @@
             <a:r>
               <a:rPr lang="en-US" sz="1100" dirty="0">
                 <a:solidFill>
-                  <a:srgbClr val="2E2119"/>
+                  <a:srgbClr val="26402C"/>
                 </a:solidFill>
                 <a:latin typeface="Calibri" pitchFamily="34" charset="0"/>
                 <a:ea typeface="Calibri" pitchFamily="34" charset="-122"/>
@@ -9913,7 +9913,7 @@
             </a:avLst>
           </a:prstGeom>
           <a:solidFill>
-            <a:srgbClr val="E7DCCB"/>
+            <a:srgbClr val="DCE3D6"/>
           </a:solidFill>
           <a:ln/>
         </p:spPr>
@@ -9935,7 +9935,7 @@
             </a:avLst>
           </a:prstGeom>
           <a:solidFill>
-            <a:srgbClr val="8A7A6D"/>
+            <a:srgbClr val="5B6559"/>
           </a:solidFill>
           <a:ln/>
         </p:spPr>
@@ -9967,7 +9967,7 @@
             <a:r>
               <a:rPr lang="en-US" sz="1100" b="1" dirty="0">
                 <a:solidFill>
-                  <a:srgbClr val="2E2119"/>
+                  <a:srgbClr val="26402C"/>
                 </a:solidFill>
                 <a:latin typeface="Calibri" pitchFamily="34" charset="0"/>
                 <a:ea typeface="Calibri" pitchFamily="34" charset="-122"/>
@@ -10006,7 +10006,7 @@
             <a:r>
               <a:rPr lang="en-US" sz="1100" dirty="0">
                 <a:solidFill>
-                  <a:srgbClr val="2E2119"/>
+                  <a:srgbClr val="26402C"/>
                 </a:solidFill>
                 <a:latin typeface="Calibri" pitchFamily="34" charset="0"/>
                 <a:ea typeface="Calibri" pitchFamily="34" charset="-122"/>
@@ -10035,7 +10035,7 @@
             </a:avLst>
           </a:prstGeom>
           <a:solidFill>
-            <a:srgbClr val="E7DCCB"/>
+            <a:srgbClr val="DCE3D6"/>
           </a:solidFill>
           <a:ln/>
         </p:spPr>
@@ -10057,7 +10057,7 @@
             </a:avLst>
           </a:prstGeom>
           <a:solidFill>
-            <a:srgbClr val="8A7A6D"/>
+            <a:srgbClr val="5B6559"/>
           </a:solidFill>
           <a:ln/>
         </p:spPr>
@@ -10089,7 +10089,7 @@
             <a:r>
               <a:rPr lang="en-US" sz="1100" b="1" dirty="0">
                 <a:solidFill>
-                  <a:srgbClr val="2E2119"/>
+                  <a:srgbClr val="26402C"/>
                 </a:solidFill>
                 <a:latin typeface="Calibri" pitchFamily="34" charset="0"/>
                 <a:ea typeface="Calibri" pitchFamily="34" charset="-122"/>
@@ -10128,7 +10128,7 @@
             <a:r>
               <a:rPr lang="en-US" sz="1100" b="1" dirty="0">
                 <a:solidFill>
-                  <a:srgbClr val="2E2119"/>
+                  <a:srgbClr val="26402C"/>
                 </a:solidFill>
                 <a:latin typeface="Calibri" pitchFamily="34" charset="0"/>
                 <a:ea typeface="Calibri" pitchFamily="34" charset="-122"/>
@@ -10157,7 +10157,7 @@
             </a:avLst>
           </a:prstGeom>
           <a:solidFill>
-            <a:srgbClr val="E7DCCB"/>
+            <a:srgbClr val="DCE3D6"/>
           </a:solidFill>
           <a:ln/>
         </p:spPr>
@@ -10189,7 +10189,7 @@
             <a:r>
               <a:rPr lang="en-US" sz="1100" b="1" dirty="0">
                 <a:solidFill>
-                  <a:srgbClr val="C9682B"/>
+                  <a:srgbClr val="C6821E"/>
                 </a:solidFill>
                 <a:latin typeface="Calibri" pitchFamily="34" charset="0"/>
                 <a:ea typeface="Calibri" pitchFamily="34" charset="-122"/>
@@ -10228,7 +10228,7 @@
             <a:r>
               <a:rPr lang="en-US" sz="950" i="1" dirty="0">
                 <a:solidFill>
-                  <a:srgbClr val="C9682B"/>
+                  <a:srgbClr val="C6821E"/>
                 </a:solidFill>
                 <a:latin typeface="Calibri" pitchFamily="34" charset="0"/>
                 <a:ea typeface="Calibri" pitchFamily="34" charset="-122"/>
@@ -10257,11 +10257,11 @@
             </a:avLst>
           </a:prstGeom>
           <a:solidFill>
-            <a:srgbClr val="F6E9D8"/>
+            <a:srgbClr val="F0E0BE"/>
           </a:solidFill>
           <a:ln w="12700">
             <a:solidFill>
-              <a:srgbClr val="C9682B"/>
+              <a:srgbClr val="C6821E"/>
             </a:solidFill>
             <a:prstDash val="solid"/>
           </a:ln>
@@ -10297,7 +10297,7 @@
             <a:r>
               <a:rPr lang="en-US" sz="1100" b="1" dirty="0">
                 <a:solidFill>
-                  <a:srgbClr val="C9682B"/>
+                  <a:srgbClr val="C6821E"/>
                 </a:solidFill>
                 <a:latin typeface="Calibri" pitchFamily="34" charset="0"/>
                 <a:ea typeface="Calibri" pitchFamily="34" charset="-122"/>
@@ -10314,7 +10314,7 @@
             <a:r>
               <a:rPr lang="en-US" sz="1100" dirty="0">
                 <a:solidFill>
-                  <a:srgbClr val="2E2119"/>
+                  <a:srgbClr val="26402C"/>
                 </a:solidFill>
                 <a:latin typeface="Calibri" pitchFamily="34" charset="0"/>
                 <a:ea typeface="Calibri" pitchFamily="34" charset="-122"/>
@@ -10373,7 +10373,7 @@
             <a:avLst/>
           </a:prstGeom>
           <a:solidFill>
-            <a:srgbClr val="C9682B"/>
+            <a:srgbClr val="C6821E"/>
           </a:solidFill>
           <a:ln/>
         </p:spPr>
@@ -10429,7 +10429,7 @@
             <a:r>
               <a:rPr lang="en-US" sz="1200" b="1" spc="200" kern="0" dirty="0">
                 <a:solidFill>
-                  <a:srgbClr val="C9682B"/>
+                  <a:srgbClr val="C6821E"/>
                 </a:solidFill>
                 <a:latin typeface="Calibri" pitchFamily="34" charset="0"/>
                 <a:ea typeface="Calibri" pitchFamily="34" charset="-122"/>
@@ -10468,7 +10468,7 @@
             <a:r>
               <a:rPr lang="en-US" sz="2800" b="1" dirty="0">
                 <a:solidFill>
-                  <a:srgbClr val="2E2119"/>
+                  <a:srgbClr val="26402C"/>
                 </a:solidFill>
                 <a:latin typeface="Cambria" pitchFamily="34" charset="0"/>
                 <a:ea typeface="Cambria" pitchFamily="34" charset="-122"/>
@@ -10507,7 +10507,7 @@
             <a:r>
               <a:rPr lang="en-US" sz="1000" i="1" dirty="0">
                 <a:solidFill>
-                  <a:srgbClr val="8A7A6D"/>
+                  <a:srgbClr val="5B6559"/>
                 </a:solidFill>
                 <a:latin typeface="Calibri" pitchFamily="34" charset="0"/>
                 <a:ea typeface="Calibri" pitchFamily="34" charset="-122"/>
@@ -10536,7 +10536,7 @@
             </a:avLst>
           </a:prstGeom>
           <a:solidFill>
-            <a:srgbClr val="EDE6DC"/>
+            <a:srgbClr val="E3E8DD"/>
           </a:solidFill>
           <a:ln/>
           <a:effectLst>
@@ -10575,7 +10575,7 @@
             <a:r>
               <a:rPr lang="en-US" sz="1500" i="1" dirty="0">
                 <a:solidFill>
-                  <a:srgbClr val="2E2119"/>
+                  <a:srgbClr val="26402C"/>
                 </a:solidFill>
                 <a:latin typeface="Calibri" pitchFamily="34" charset="0"/>
                 <a:ea typeface="Calibri" pitchFamily="34" charset="-122"/>
@@ -10614,7 +10614,7 @@
             <a:r>
               <a:rPr lang="en-US" sz="1300" b="1" dirty="0">
                 <a:solidFill>
-                  <a:srgbClr val="C9682B"/>
+                  <a:srgbClr val="C6821E"/>
                 </a:solidFill>
                 <a:latin typeface="Calibri" pitchFamily="34" charset="0"/>
                 <a:ea typeface="Calibri" pitchFamily="34" charset="-122"/>
@@ -10628,7 +10628,7 @@
             <a:r>
               <a:rPr lang="en-US" sz="1300" dirty="0">
                 <a:solidFill>
-                  <a:srgbClr val="2E2119"/>
+                  <a:srgbClr val="26402C"/>
                 </a:solidFill>
                 <a:latin typeface="Calibri" pitchFamily="34" charset="0"/>
                 <a:ea typeface="Calibri" pitchFamily="34" charset="-122"/>
@@ -10657,7 +10657,7 @@
             </a:avLst>
           </a:prstGeom>
           <a:solidFill>
-            <a:srgbClr val="F4E9DA"/>
+            <a:srgbClr val="F2EFE7"/>
           </a:solidFill>
           <a:ln/>
           <a:effectLst>
@@ -10696,7 +10696,7 @@
             <a:r>
               <a:rPr lang="en-US" sz="1150" b="1" spc="100" kern="0" dirty="0">
                 <a:solidFill>
-                  <a:srgbClr val="C9682B"/>
+                  <a:srgbClr val="C6821E"/>
                 </a:solidFill>
                 <a:latin typeface="Calibri" pitchFamily="34" charset="0"/>
                 <a:ea typeface="Calibri" pitchFamily="34" charset="-122"/>
@@ -10735,7 +10735,7 @@
             <a:r>
               <a:rPr lang="en-US" sz="1250" dirty="0">
                 <a:solidFill>
-                  <a:srgbClr val="2E2119"/>
+                  <a:srgbClr val="26402C"/>
                 </a:solidFill>
                 <a:latin typeface="Calibri" pitchFamily="34" charset="0"/>
                 <a:ea typeface="Calibri" pitchFamily="34" charset="-122"/>
@@ -10764,7 +10764,7 @@
             </a:avLst>
           </a:prstGeom>
           <a:solidFill>
-            <a:srgbClr val="F6E4D3"/>
+            <a:srgbClr val="ECD9B8"/>
           </a:solidFill>
           <a:ln/>
           <a:effectLst>
@@ -10803,7 +10803,7 @@
             <a:r>
               <a:rPr lang="en-US" sz="1150" b="1" spc="100" kern="0" dirty="0">
                 <a:solidFill>
-                  <a:srgbClr val="C9682B"/>
+                  <a:srgbClr val="C6821E"/>
                 </a:solidFill>
                 <a:latin typeface="Calibri" pitchFamily="34" charset="0"/>
                 <a:ea typeface="Calibri" pitchFamily="34" charset="-122"/>
@@ -10845,7 +10845,7 @@
             <a:r>
               <a:rPr lang="en-US" sz="1150" dirty="0">
                 <a:solidFill>
-                  <a:srgbClr val="2E2119"/>
+                  <a:srgbClr val="26402C"/>
                 </a:solidFill>
                 <a:latin typeface="Calibri" pitchFamily="34" charset="0"/>
                 <a:ea typeface="Calibri" pitchFamily="34" charset="-122"/>
@@ -10862,7 +10862,7 @@
             <a:r>
               <a:rPr lang="en-US" sz="1150" b="1" dirty="0">
                 <a:solidFill>
-                  <a:srgbClr val="C9682B"/>
+                  <a:srgbClr val="C6821E"/>
                 </a:solidFill>
                 <a:latin typeface="Calibri" pitchFamily="34" charset="0"/>
                 <a:ea typeface="Calibri" pitchFamily="34" charset="-122"/>
@@ -10876,7 +10876,7 @@
             <a:r>
               <a:rPr lang="en-US" sz="1150" i="1" dirty="0">
                 <a:solidFill>
-                  <a:srgbClr val="2E2119"/>
+                  <a:srgbClr val="26402C"/>
                 </a:solidFill>
                 <a:latin typeface="Calibri" pitchFamily="34" charset="0"/>
                 <a:ea typeface="Calibri" pitchFamily="34" charset="-122"/>
@@ -10905,7 +10905,7 @@
             </a:avLst>
           </a:prstGeom>
           <a:solidFill>
-            <a:srgbClr val="2E2119"/>
+            <a:srgbClr val="26402C"/>
           </a:solidFill>
           <a:ln/>
         </p:spPr>
@@ -10937,7 +10937,7 @@
             <a:r>
               <a:rPr lang="en-US" sz="1250" i="1" dirty="0">
                 <a:solidFill>
-                  <a:srgbClr val="D9A441"/>
+                  <a:srgbClr val="E3A94A"/>
                 </a:solidFill>
                 <a:latin typeface="Calibri" pitchFamily="34" charset="0"/>
                 <a:ea typeface="Calibri" pitchFamily="34" charset="-122"/>
@@ -10996,7 +10996,7 @@
             <a:avLst/>
           </a:prstGeom>
           <a:solidFill>
-            <a:srgbClr val="C9682B"/>
+            <a:srgbClr val="C6821E"/>
           </a:solidFill>
           <a:ln/>
         </p:spPr>
@@ -11052,7 +11052,7 @@
             <a:r>
               <a:rPr lang="en-US" sz="1200" b="1" spc="200" kern="0" dirty="0">
                 <a:solidFill>
-                  <a:srgbClr val="C9682B"/>
+                  <a:srgbClr val="C6821E"/>
                 </a:solidFill>
                 <a:latin typeface="Calibri" pitchFamily="34" charset="0"/>
                 <a:ea typeface="Calibri" pitchFamily="34" charset="-122"/>
@@ -11091,7 +11091,7 @@
             <a:r>
               <a:rPr lang="en-US" sz="2800" b="1" dirty="0">
                 <a:solidFill>
-                  <a:srgbClr val="2E2119"/>
+                  <a:srgbClr val="26402C"/>
                 </a:solidFill>
                 <a:latin typeface="Cambria" pitchFamily="34" charset="0"/>
                 <a:ea typeface="Cambria" pitchFamily="34" charset="-122"/>
@@ -11120,7 +11120,7 @@
             </a:avLst>
           </a:prstGeom>
           <a:solidFill>
-            <a:srgbClr val="F4E9DA"/>
+            <a:srgbClr val="F2EFE7"/>
           </a:solidFill>
           <a:ln/>
           <a:effectLst>
@@ -11159,7 +11159,7 @@
             <a:r>
               <a:rPr lang="en-US" sz="1500" b="1" dirty="0">
                 <a:solidFill>
-                  <a:srgbClr val="C9682B"/>
+                  <a:srgbClr val="C6821E"/>
                 </a:solidFill>
                 <a:latin typeface="Cambria" pitchFamily="34" charset="0"/>
                 <a:ea typeface="Cambria" pitchFamily="34" charset="-122"/>
@@ -11198,7 +11198,7 @@
             <a:r>
               <a:rPr lang="en-US" sz="1300" dirty="0">
                 <a:solidFill>
-                  <a:srgbClr val="2E2119"/>
+                  <a:srgbClr val="26402C"/>
                 </a:solidFill>
                 <a:latin typeface="Calibri" pitchFamily="34" charset="0"/>
                 <a:ea typeface="Calibri" pitchFamily="34" charset="-122"/>
@@ -11227,7 +11227,7 @@
             </a:avLst>
           </a:prstGeom>
           <a:solidFill>
-            <a:srgbClr val="EDE6DC"/>
+            <a:srgbClr val="E3E8DD"/>
           </a:solidFill>
           <a:ln/>
           <a:effectLst>
@@ -11266,7 +11266,7 @@
             <a:r>
               <a:rPr lang="en-US" sz="1500" b="1" dirty="0">
                 <a:solidFill>
-                  <a:srgbClr val="C9682B"/>
+                  <a:srgbClr val="C6821E"/>
                 </a:solidFill>
                 <a:latin typeface="Cambria" pitchFamily="34" charset="0"/>
                 <a:ea typeface="Cambria" pitchFamily="34" charset="-122"/>
@@ -11305,7 +11305,7 @@
             <a:r>
               <a:rPr lang="en-US" sz="1300" dirty="0">
                 <a:solidFill>
-                  <a:srgbClr val="2E2119"/>
+                  <a:srgbClr val="26402C"/>
                 </a:solidFill>
                 <a:latin typeface="Calibri" pitchFamily="34" charset="0"/>
                 <a:ea typeface="Calibri" pitchFamily="34" charset="-122"/>
@@ -11334,7 +11334,7 @@
             </a:avLst>
           </a:prstGeom>
           <a:solidFill>
-            <a:srgbClr val="F4E9DA"/>
+            <a:srgbClr val="F2EFE7"/>
           </a:solidFill>
           <a:ln/>
           <a:effectLst>
@@ -11373,7 +11373,7 @@
             <a:r>
               <a:rPr lang="en-US" sz="1500" b="1" dirty="0">
                 <a:solidFill>
-                  <a:srgbClr val="C9682B"/>
+                  <a:srgbClr val="C6821E"/>
                 </a:solidFill>
                 <a:latin typeface="Cambria" pitchFamily="34" charset="0"/>
                 <a:ea typeface="Cambria" pitchFamily="34" charset="-122"/>
@@ -11412,7 +11412,7 @@
             <a:r>
               <a:rPr lang="en-US" sz="1300" dirty="0">
                 <a:solidFill>
-                  <a:srgbClr val="2E2119"/>
+                  <a:srgbClr val="26402C"/>
                 </a:solidFill>
                 <a:latin typeface="Calibri" pitchFamily="34" charset="0"/>
                 <a:ea typeface="Calibri" pitchFamily="34" charset="-122"/>
@@ -11441,7 +11441,7 @@
             </a:avLst>
           </a:prstGeom>
           <a:solidFill>
-            <a:srgbClr val="2E2119"/>
+            <a:srgbClr val="26402C"/>
           </a:solidFill>
           <a:ln/>
         </p:spPr>
@@ -11473,7 +11473,7 @@
             <a:r>
               <a:rPr lang="en-US" sz="1300" i="1" dirty="0">
                 <a:solidFill>
-                  <a:srgbClr val="D9A441"/>
+                  <a:srgbClr val="E3A94A"/>
                 </a:solidFill>
                 <a:latin typeface="Calibri" pitchFamily="34" charset="0"/>
                 <a:ea typeface="Calibri" pitchFamily="34" charset="-122"/>
@@ -11532,7 +11532,7 @@
             <a:avLst/>
           </a:prstGeom>
           <a:solidFill>
-            <a:srgbClr val="C9682B"/>
+            <a:srgbClr val="C6821E"/>
           </a:solidFill>
           <a:ln/>
         </p:spPr>
@@ -11588,7 +11588,7 @@
             <a:r>
               <a:rPr lang="en-US" sz="1200" b="1" spc="200" kern="0" dirty="0">
                 <a:solidFill>
-                  <a:srgbClr val="C9682B"/>
+                  <a:srgbClr val="C6821E"/>
                 </a:solidFill>
                 <a:latin typeface="Calibri" pitchFamily="34" charset="0"/>
                 <a:ea typeface="Calibri" pitchFamily="34" charset="-122"/>
@@ -11627,7 +11627,7 @@
             <a:r>
               <a:rPr lang="en-US" sz="2800" b="1" dirty="0">
                 <a:solidFill>
-                  <a:srgbClr val="2E2119"/>
+                  <a:srgbClr val="26402C"/>
                 </a:solidFill>
                 <a:latin typeface="Cambria" pitchFamily="34" charset="0"/>
                 <a:ea typeface="Cambria" pitchFamily="34" charset="-122"/>
@@ -11666,7 +11666,7 @@
             <a:r>
               <a:rPr lang="en-US" sz="1000" i="1" dirty="0">
                 <a:solidFill>
-                  <a:srgbClr val="8A7A6D"/>
+                  <a:srgbClr val="5B6559"/>
                 </a:solidFill>
                 <a:latin typeface="Calibri" pitchFamily="34" charset="0"/>
                 <a:ea typeface="Calibri" pitchFamily="34" charset="-122"/>
@@ -11695,7 +11695,7 @@
             </a:avLst>
           </a:prstGeom>
           <a:solidFill>
-            <a:srgbClr val="F4E9DA"/>
+            <a:srgbClr val="F2EFE7"/>
           </a:solidFill>
           <a:ln/>
           <a:effectLst>
@@ -11734,7 +11734,7 @@
             <a:r>
               <a:rPr lang="en-US" sz="1200" b="1" spc="150" kern="0" dirty="0">
                 <a:solidFill>
-                  <a:srgbClr val="C9682B"/>
+                  <a:srgbClr val="C6821E"/>
                 </a:solidFill>
                 <a:latin typeface="Calibri" pitchFamily="34" charset="0"/>
                 <a:ea typeface="Calibri" pitchFamily="34" charset="-122"/>
@@ -11773,7 +11773,7 @@
             <a:r>
               <a:rPr lang="en-US" sz="1050" i="1" dirty="0">
                 <a:solidFill>
-                  <a:srgbClr val="8A7A6D"/>
+                  <a:srgbClr val="5B6559"/>
                 </a:solidFill>
                 <a:latin typeface="Calibri" pitchFamily="34" charset="0"/>
                 <a:ea typeface="Calibri" pitchFamily="34" charset="-122"/>
@@ -11816,7 +11816,7 @@
             <a:r>
               <a:rPr lang="en-US" sz="1000" i="1" dirty="0">
                 <a:solidFill>
-                  <a:srgbClr val="2E2119"/>
+                  <a:srgbClr val="26402C"/>
                 </a:solidFill>
                 <a:latin typeface="Calibri" pitchFamily="34" charset="0"/>
                 <a:ea typeface="Calibri" pitchFamily="34" charset="-122"/>
@@ -11837,7 +11837,7 @@
             <a:r>
               <a:rPr lang="en-US" sz="1000" i="1" dirty="0">
                 <a:solidFill>
-                  <a:srgbClr val="2E2119"/>
+                  <a:srgbClr val="26402C"/>
                 </a:solidFill>
                 <a:latin typeface="Calibri" pitchFamily="34" charset="0"/>
                 <a:ea typeface="Calibri" pitchFamily="34" charset="-122"/>
@@ -11858,7 +11858,7 @@
             <a:r>
               <a:rPr lang="en-US" sz="1000" i="1" dirty="0">
                 <a:solidFill>
-                  <a:srgbClr val="2E2119"/>
+                  <a:srgbClr val="26402C"/>
                 </a:solidFill>
                 <a:latin typeface="Calibri" pitchFamily="34" charset="0"/>
                 <a:ea typeface="Calibri" pitchFamily="34" charset="-122"/>
@@ -11879,7 +11879,7 @@
             <a:r>
               <a:rPr lang="en-US" sz="1000" i="1" dirty="0">
                 <a:solidFill>
-                  <a:srgbClr val="2E2119"/>
+                  <a:srgbClr val="26402C"/>
                 </a:solidFill>
                 <a:latin typeface="Calibri" pitchFamily="34" charset="0"/>
                 <a:ea typeface="Calibri" pitchFamily="34" charset="-122"/>
@@ -11900,7 +11900,7 @@
             <a:r>
               <a:rPr lang="en-US" sz="1000" i="1" dirty="0">
                 <a:solidFill>
-                  <a:srgbClr val="2E2119"/>
+                  <a:srgbClr val="26402C"/>
                 </a:solidFill>
                 <a:latin typeface="Calibri" pitchFamily="34" charset="0"/>
                 <a:ea typeface="Calibri" pitchFamily="34" charset="-122"/>
@@ -11921,7 +11921,7 @@
             <a:r>
               <a:rPr lang="en-US" sz="1000" i="1" dirty="0">
                 <a:solidFill>
-                  <a:srgbClr val="2E2119"/>
+                  <a:srgbClr val="26402C"/>
                 </a:solidFill>
                 <a:latin typeface="Calibri" pitchFamily="34" charset="0"/>
                 <a:ea typeface="Calibri" pitchFamily="34" charset="-122"/>
@@ -11950,7 +11950,7 @@
             </a:avLst>
           </a:prstGeom>
           <a:solidFill>
-            <a:srgbClr val="EDE6DC"/>
+            <a:srgbClr val="E3E8DD"/>
           </a:solidFill>
           <a:ln/>
           <a:effectLst>
@@ -11989,7 +11989,7 @@
             <a:r>
               <a:rPr lang="en-US" sz="1200" b="1" spc="150" kern="0" dirty="0">
                 <a:solidFill>
-                  <a:srgbClr val="C9682B"/>
+                  <a:srgbClr val="C6821E"/>
                 </a:solidFill>
                 <a:latin typeface="Calibri" pitchFamily="34" charset="0"/>
                 <a:ea typeface="Calibri" pitchFamily="34" charset="-122"/>
@@ -12028,7 +12028,7 @@
             <a:r>
               <a:rPr lang="en-US" sz="1050" i="1" dirty="0">
                 <a:solidFill>
-                  <a:srgbClr val="8A7A6D"/>
+                  <a:srgbClr val="5B6559"/>
                 </a:solidFill>
                 <a:latin typeface="Calibri" pitchFamily="34" charset="0"/>
                 <a:ea typeface="Calibri" pitchFamily="34" charset="-122"/>
@@ -12071,7 +12071,7 @@
             <a:r>
               <a:rPr lang="en-US" sz="1100" i="1" dirty="0">
                 <a:solidFill>
-                  <a:srgbClr val="2E2119"/>
+                  <a:srgbClr val="26402C"/>
                 </a:solidFill>
                 <a:latin typeface="Calibri" pitchFamily="34" charset="0"/>
                 <a:ea typeface="Calibri" pitchFamily="34" charset="-122"/>
@@ -12092,7 +12092,7 @@
             <a:r>
               <a:rPr lang="en-US" sz="1100" i="1" dirty="0">
                 <a:solidFill>
-                  <a:srgbClr val="2E2119"/>
+                  <a:srgbClr val="26402C"/>
                 </a:solidFill>
                 <a:latin typeface="Calibri" pitchFamily="34" charset="0"/>
                 <a:ea typeface="Calibri" pitchFamily="34" charset="-122"/>
@@ -12113,7 +12113,7 @@
             <a:r>
               <a:rPr lang="en-US" sz="1100" i="1" dirty="0">
                 <a:solidFill>
-                  <a:srgbClr val="2E2119"/>
+                  <a:srgbClr val="26402C"/>
                 </a:solidFill>
                 <a:latin typeface="Calibri" pitchFamily="34" charset="0"/>
                 <a:ea typeface="Calibri" pitchFamily="34" charset="-122"/>
@@ -12142,7 +12142,7 @@
             </a:avLst>
           </a:prstGeom>
           <a:solidFill>
-            <a:srgbClr val="2E2119"/>
+            <a:srgbClr val="26402C"/>
           </a:solidFill>
           <a:ln/>
         </p:spPr>
@@ -12177,7 +12177,7 @@
             <a:r>
               <a:rPr lang="en-US" sz="1100" b="1" dirty="0">
                 <a:solidFill>
-                  <a:srgbClr val="D9A441"/>
+                  <a:srgbClr val="E3A94A"/>
                 </a:solidFill>
                 <a:latin typeface="Calibri" pitchFamily="34" charset="0"/>
                 <a:ea typeface="Calibri" pitchFamily="34" charset="-122"/>
@@ -12223,11 +12223,11 @@
             </a:avLst>
           </a:prstGeom>
           <a:solidFill>
-            <a:srgbClr val="F6E9D8"/>
+            <a:srgbClr val="F0E0BE"/>
           </a:solidFill>
           <a:ln w="12700">
             <a:solidFill>
-              <a:srgbClr val="C9682B"/>
+              <a:srgbClr val="C6821E"/>
             </a:solidFill>
             <a:prstDash val="solid"/>
           </a:ln>
@@ -12260,7 +12260,7 @@
             <a:r>
               <a:rPr lang="en-US" sz="1100" b="1" dirty="0">
                 <a:solidFill>
-                  <a:srgbClr val="C9682B"/>
+                  <a:srgbClr val="C6821E"/>
                 </a:solidFill>
                 <a:latin typeface="Calibri" pitchFamily="34" charset="0"/>
                 <a:ea typeface="Calibri" pitchFamily="34" charset="-122"/>
@@ -12274,7 +12274,7 @@
             <a:r>
               <a:rPr lang="en-US" sz="1100" dirty="0">
                 <a:solidFill>
-                  <a:srgbClr val="2E2119"/>
+                  <a:srgbClr val="26402C"/>
                 </a:solidFill>
                 <a:latin typeface="Calibri" pitchFamily="34" charset="0"/>
                 <a:ea typeface="Calibri" pitchFamily="34" charset="-122"/>

</xml_diff>